<commit_message>
Video deck: use the final Fig. 2 panels on the motivation and trick slides
Co-Authored-By: Claude Fable 5.1 <noreply@anthropic.com>
Claude-Session: https://claude.ai/code/session_011USoCwMtkSq1wKhwTPjNT9
</commit_message>
<xml_diff>
--- a/experiments/paper/video/ICRA27_video_v2.pptx
+++ b/experiments/paper/video/ICRA27_video_v2.pptx
@@ -519,7 +519,7 @@
 NARRATION:
 Vision-language-action models are capable but slow. Every control step runs a vision encoder and a language backbone. Training-free tricks promise cheaper inference, but each is reported on one model and one benchmark. Do the gains transfer?
 VISUAL / PRODUCTION NOTE:
-Static. Optional: play a short original-policy rollout behind the loop diagram. The three coloured markers on the loop show where foveation (orange diamond), temporal fusion (green dot) and depth pruning (purple dot) enter; they are explained on the trick slides.</a:t>
+Static. Optional: play a short original-policy rollout behind the loop diagram. Pipeline row cropped from Fig. 2(a).</a:t>
             </a:r>
             <a:endParaRPr lang="en-US" dirty="0"/>
           </a:p>
@@ -1071,7 +1071,7 @@
 NARRATION:
 Trick one, visual foveation. The observation keeps a sharp central disc and blurs the periphery. Token count and compute are unchanged. Only what the policy sees changes.
 VISUAL / PRODUCTION NOTE:
-Left: Fig. 2 crop and example frames at keep 20% and 50%. Right: side-by-side rollout clip.</a:t>
+Left: Fig. 2(a) foveation panel. Right: side-by-side rollout clip.</a:t>
             </a:r>
             <a:endParaRPr lang="en-US" dirty="0"/>
           </a:p>
@@ -1163,7 +1163,7 @@
 NARRATION:
 Trick two, action repeat. Each predicted action is held for two or four control steps, so the policy is called less often. No state check, a pure speed baseline.
 VISUAL / PRODUCTION NOTE:
-Timeline of policy calls (optional animation). Right: side-by-side rollout clip.</a:t>
+Left: Fig. 2(a) action repeat panel. Right: side-by-side rollout clip.</a:t>
             </a:r>
             <a:endParaRPr lang="en-US" dirty="0"/>
           </a:p>
@@ -1255,7 +1255,7 @@
 NARRATION:
 Trick three, depth pruning. Decoder blocks that barely change their hidden states are removed, one, two, or four of them. The selection is fixed before evaluation.
 VISUAL / PRODUCTION NOTE:
-Left: Fig. 2 crop. Right: side-by-side rollout clip.</a:t>
+Left: Fig. 2(a) panel. Right: side-by-side rollout clip.</a:t>
             </a:r>
             <a:endParaRPr lang="en-US" dirty="0"/>
           </a:p>
@@ -1347,7 +1347,7 @@
 NARRATION:
 Trick four, guarded reuse. The previous action is reused only while every gate passes: image change, action agreement, translation, and gripper. Any failed gate restores a full call.
 VISUAL / PRODUCTION NOTE:
-Left: Fig. 2 crop and gated timeline. Right: side-by-side rollout clip with gate overlay.</a:t>
+Left: Fig. 2(a) guarded reuse panel. Right: side-by-side rollout clip with gate overlay.</a:t>
             </a:r>
             <a:endParaRPr lang="en-US" dirty="0"/>
           </a:p>
@@ -1439,7 +1439,7 @@
 NARRATION:
 Trick five, temporal fusion. Visual tokens of stable patches are reused from the previous call, while patches with motion, entropy, or language attention are recomputed. The policy still runs every step.
 VISUAL / PRODUCTION NOTE:
-Left: Fig. 2 crop. Right: side-by-side rollout clip.</a:t>
+Left: Fig. 2(a) panel. Right: side-by-side rollout clip.</a:t>
             </a:r>
             <a:endParaRPr lang="en-US" dirty="0"/>
           </a:p>
@@ -2221,7 +2221,7 @@
       </p:sp>
       <p:pic>
         <p:nvPicPr>
-          <p:cNvPr id="5" name="Image 0" descr="/tmp/claude-0/-home-user-BiVLA/4327cefa-ba5d-5e2e-9d87-c73dd3a8ccbb/scratchpad/video_ppt/assets/ov_loop.png">    </p:cNvPr>
+          <p:cNvPr id="5" name="Image 0" descr="/tmp/claude-0/-home-user-BiVLA/4327cefa-ba5d-5e2e-9d87-c73dd3a8ccbb/scratchpad/video_ppt/assets/m_pipeline.png">    </p:cNvPr>
           <p:cNvPicPr>
             <a:picLocks noChangeAspect="1"/>
           </p:cNvPicPr>
@@ -2235,8 +2235,8 @@
         </p:blipFill>
         <p:spPr>
           <a:xfrm>
-            <a:off x="457200" y="932688"/>
-            <a:ext cx="8229600" cy="1188720"/>
+            <a:off x="457200" y="1051560"/>
+            <a:ext cx="8229600" cy="402336"/>
           </a:xfrm>
           <a:prstGeom prst="rect">
             <a:avLst/>
@@ -2251,8 +2251,8 @@
         </p:nvSpPr>
         <p:spPr>
           <a:xfrm>
-            <a:off x="457200" y="2176272"/>
-            <a:ext cx="8229600" cy="274320"/>
+            <a:off x="457200" y="1554480"/>
+            <a:ext cx="8229600" cy="365760"/>
           </a:xfrm>
           <a:prstGeom prst="rect">
             <a:avLst/>
@@ -2276,7 +2276,7 @@
                 <a:ea typeface="Arial" pitchFamily="34" charset="-122"/>
                 <a:cs typeface="Arial" pitchFamily="34" charset="-120"/>
               </a:rPr>
-              <a:t>One control step of a frozen VLA policy: the vision encoder and the language backbone run at every step.</a:t>
+              <a:t>The control loop of a frozen VLA policy (Fig. 2 of the paper). Coloured boxes are where the five tricks enter; the visual encoder and the action decoder run at every step.</a:t>
             </a:r>
             <a:endParaRPr lang="en-US" sz="1100" dirty="0"/>
           </a:p>
@@ -2290,7 +2290,7 @@
         </p:nvSpPr>
         <p:spPr>
           <a:xfrm>
-            <a:off x="457200" y="2542032"/>
+            <a:off x="457200" y="2240280"/>
             <a:ext cx="8229600" cy="457200"/>
           </a:xfrm>
           <a:prstGeom prst="rect">
@@ -2357,7 +2357,7 @@
         </p:nvSpPr>
         <p:spPr>
           <a:xfrm>
-            <a:off x="457200" y="3044952"/>
+            <a:off x="457200" y="2834640"/>
             <a:ext cx="8229600" cy="548640"/>
           </a:xfrm>
           <a:prstGeom prst="rect">
@@ -6570,7 +6570,7 @@
       </p:sp>
       <p:pic>
         <p:nvPicPr>
-          <p:cNvPr id="6" name="Image 0" descr="/tmp/claude-0/-home-user-BiVLA/4327cefa-ba5d-5e2e-9d87-c73dd3a8ccbb/scratchpad/video_ppt/assets/ov_fov.png">    </p:cNvPr>
+          <p:cNvPr id="6" name="Image 0" descr="/tmp/claude-0/-home-user-BiVLA/4327cefa-ba5d-5e2e-9d87-c73dd3a8ccbb/scratchpad/video_ppt/assets/m_fov.png">    </p:cNvPr>
           <p:cNvPicPr>
             <a:picLocks noChangeAspect="1"/>
           </p:cNvPicPr>
@@ -6585,212 +6585,23 @@
         <p:spPr>
           <a:xfrm>
             <a:off x="457200" y="960120"/>
-            <a:ext cx="3931920" cy="1298448"/>
+            <a:ext cx="3931920" cy="2468880"/>
           </a:xfrm>
           <a:prstGeom prst="rect">
             <a:avLst/>
           </a:prstGeom>
         </p:spPr>
       </p:pic>
-      <p:pic>
-        <p:nvPicPr>
-          <p:cNvPr id="7" name="Image 1" descr="/tmp/claude-0/-home-user-BiVLA/4327cefa-ba5d-5e2e-9d87-c73dd3a8ccbb/scratchpad/video_ppt/assets/frame_raw.png">    </p:cNvPr>
-          <p:cNvPicPr>
-            <a:picLocks noChangeAspect="1"/>
-          </p:cNvPicPr>
-          <p:nvPr/>
-        </p:nvPicPr>
-        <p:blipFill>
-          <a:blip r:embed="rId2"/>
-          <a:stretch>
-            <a:fillRect/>
-          </a:stretch>
-        </p:blipFill>
-        <p:spPr>
-          <a:xfrm>
-            <a:off x="457200" y="2468880"/>
-            <a:ext cx="1225296" cy="868680"/>
-          </a:xfrm>
-          <a:prstGeom prst="rect">
-            <a:avLst/>
-          </a:prstGeom>
-        </p:spPr>
-      </p:pic>
-      <p:sp>
-        <p:nvSpPr>
-          <p:cNvPr id="8" name="Text 4"/>
+      <p:sp>
+        <p:nvSpPr>
+          <p:cNvPr id="7" name="Text 4"/>
           <p:cNvSpPr txBox="1"/>
           <p:nvPr/>
         </p:nvSpPr>
         <p:spPr>
           <a:xfrm>
-            <a:off x="457200" y="3364992"/>
-            <a:ext cx="1225296" cy="274320"/>
-          </a:xfrm>
-          <a:prstGeom prst="rect">
-            <a:avLst/>
-          </a:prstGeom>
-          <a:noFill/>
-          <a:ln/>
-        </p:spPr>
-        <p:txBody>
-          <a:bodyPr wrap="square" lIns="0" tIns="0" rIns="0" bIns="0" rtlCol="0" anchor="t"/>
-          <a:lstStyle/>
-          <a:p>
-            <a:pPr algn="ctr" indent="0" marL="0">
-              <a:buNone/>
-            </a:pPr>
-            <a:r>
-              <a:rPr lang="en-US" sz="1050" dirty="0">
-                <a:solidFill>
-                  <a:srgbClr val="5F6B7A"/>
-                </a:solidFill>
-                <a:latin typeface="Arial" pitchFamily="34" charset="0"/>
-                <a:ea typeface="Arial" pitchFamily="34" charset="-122"/>
-                <a:cs typeface="Arial" pitchFamily="34" charset="-120"/>
-              </a:rPr>
-              <a:t>original</a:t>
-            </a:r>
-            <a:endParaRPr lang="en-US" sz="1050" dirty="0"/>
-          </a:p>
-        </p:txBody>
-      </p:sp>
-      <p:pic>
-        <p:nvPicPr>
-          <p:cNvPr id="9" name="Image 2" descr="/tmp/claude-0/-home-user-BiVLA/4327cefa-ba5d-5e2e-9d87-c73dd3a8ccbb/scratchpad/video_ppt/assets/frame_fov20.png">    </p:cNvPr>
-          <p:cNvPicPr>
-            <a:picLocks noChangeAspect="1"/>
-          </p:cNvPicPr>
-          <p:nvPr/>
-        </p:nvPicPr>
-        <p:blipFill>
-          <a:blip r:embed="rId3"/>
-          <a:stretch>
-            <a:fillRect/>
-          </a:stretch>
-        </p:blipFill>
-        <p:spPr>
-          <a:xfrm>
-            <a:off x="1810512" y="2468880"/>
-            <a:ext cx="1225296" cy="868680"/>
-          </a:xfrm>
-          <a:prstGeom prst="rect">
-            <a:avLst/>
-          </a:prstGeom>
-        </p:spPr>
-      </p:pic>
-      <p:sp>
-        <p:nvSpPr>
-          <p:cNvPr id="10" name="Text 5"/>
-          <p:cNvSpPr txBox="1"/>
-          <p:nvPr/>
-        </p:nvSpPr>
-        <p:spPr>
-          <a:xfrm>
-            <a:off x="1810512" y="3364992"/>
-            <a:ext cx="1225296" cy="274320"/>
-          </a:xfrm>
-          <a:prstGeom prst="rect">
-            <a:avLst/>
-          </a:prstGeom>
-          <a:noFill/>
-          <a:ln/>
-        </p:spPr>
-        <p:txBody>
-          <a:bodyPr wrap="square" lIns="0" tIns="0" rIns="0" bIns="0" rtlCol="0" anchor="t"/>
-          <a:lstStyle/>
-          <a:p>
-            <a:pPr algn="ctr" indent="0" marL="0">
-              <a:buNone/>
-            </a:pPr>
-            <a:r>
-              <a:rPr lang="en-US" sz="1050" dirty="0">
-                <a:solidFill>
-                  <a:srgbClr val="5F6B7A"/>
-                </a:solidFill>
-                <a:latin typeface="Arial" pitchFamily="34" charset="0"/>
-                <a:ea typeface="Arial" pitchFamily="34" charset="-122"/>
-                <a:cs typeface="Arial" pitchFamily="34" charset="-120"/>
-              </a:rPr>
-              <a:t>keep 20%</a:t>
-            </a:r>
-            <a:endParaRPr lang="en-US" sz="1050" dirty="0"/>
-          </a:p>
-        </p:txBody>
-      </p:sp>
-      <p:pic>
-        <p:nvPicPr>
-          <p:cNvPr id="11" name="Image 3" descr="/tmp/claude-0/-home-user-BiVLA/4327cefa-ba5d-5e2e-9d87-c73dd3a8ccbb/scratchpad/video_ppt/assets/frame_fov50.png">    </p:cNvPr>
-          <p:cNvPicPr>
-            <a:picLocks noChangeAspect="1"/>
-          </p:cNvPicPr>
-          <p:nvPr/>
-        </p:nvPicPr>
-        <p:blipFill>
-          <a:blip r:embed="rId4"/>
-          <a:stretch>
-            <a:fillRect/>
-          </a:stretch>
-        </p:blipFill>
-        <p:spPr>
-          <a:xfrm>
-            <a:off x="3163824" y="2468880"/>
-            <a:ext cx="1225296" cy="868680"/>
-          </a:xfrm>
-          <a:prstGeom prst="rect">
-            <a:avLst/>
-          </a:prstGeom>
-        </p:spPr>
-      </p:pic>
-      <p:sp>
-        <p:nvSpPr>
-          <p:cNvPr id="12" name="Text 6"/>
-          <p:cNvSpPr txBox="1"/>
-          <p:nvPr/>
-        </p:nvSpPr>
-        <p:spPr>
-          <a:xfrm>
-            <a:off x="3163824" y="3364992"/>
-            <a:ext cx="1225296" cy="274320"/>
-          </a:xfrm>
-          <a:prstGeom prst="rect">
-            <a:avLst/>
-          </a:prstGeom>
-          <a:noFill/>
-          <a:ln/>
-        </p:spPr>
-        <p:txBody>
-          <a:bodyPr wrap="square" lIns="0" tIns="0" rIns="0" bIns="0" rtlCol="0" anchor="t"/>
-          <a:lstStyle/>
-          <a:p>
-            <a:pPr algn="ctr" indent="0" marL="0">
-              <a:buNone/>
-            </a:pPr>
-            <a:r>
-              <a:rPr lang="en-US" sz="1050" dirty="0">
-                <a:solidFill>
-                  <a:srgbClr val="5F6B7A"/>
-                </a:solidFill>
-                <a:latin typeface="Arial" pitchFamily="34" charset="0"/>
-                <a:ea typeface="Arial" pitchFamily="34" charset="-122"/>
-                <a:cs typeface="Arial" pitchFamily="34" charset="-120"/>
-              </a:rPr>
-              <a:t>keep 50%</a:t>
-            </a:r>
-            <a:endParaRPr lang="en-US" sz="1050" dirty="0"/>
-          </a:p>
-        </p:txBody>
-      </p:sp>
-      <p:sp>
-        <p:nvSpPr>
-          <p:cNvPr id="13" name="Text 7"/>
-          <p:cNvSpPr txBox="1"/>
-          <p:nvPr/>
-        </p:nvSpPr>
-        <p:spPr>
-          <a:xfrm>
-            <a:off x="457200" y="3703320"/>
-            <a:ext cx="4023360" cy="1097280"/>
+            <a:off x="457200" y="3611880"/>
+            <a:ext cx="4023360" cy="1188720"/>
           </a:xfrm>
           <a:prstGeom prst="rect">
             <a:avLst/>
@@ -6868,7 +6679,7 @@
       </p:sp>
       <p:sp>
         <p:nvSpPr>
-          <p:cNvPr id="14" name="Shape 8"/>
+          <p:cNvPr id="8" name="Shape 5"/>
           <p:cNvSpPr/>
           <p:nvPr/>
         </p:nvSpPr>
@@ -6895,7 +6706,7 @@
       </p:sp>
       <p:sp>
         <p:nvSpPr>
-          <p:cNvPr id="15" name="Shape 9"/>
+          <p:cNvPr id="9" name="Shape 6"/>
           <p:cNvSpPr/>
           <p:nvPr/>
         </p:nvSpPr>
@@ -6920,7 +6731,7 @@
       </p:sp>
       <p:sp>
         <p:nvSpPr>
-          <p:cNvPr id="16" name="Shape 10"/>
+          <p:cNvPr id="10" name="Shape 7"/>
           <p:cNvSpPr/>
           <p:nvPr/>
         </p:nvSpPr>
@@ -6945,7 +6756,7 @@
       </p:sp>
       <p:sp>
         <p:nvSpPr>
-          <p:cNvPr id="17" name="Text 11"/>
+          <p:cNvPr id="11" name="Text 8"/>
           <p:cNvSpPr txBox="1"/>
           <p:nvPr/>
         </p:nvSpPr>
@@ -6984,7 +6795,7 @@
       </p:sp>
       <p:sp>
         <p:nvSpPr>
-          <p:cNvPr id="18" name="Text 12"/>
+          <p:cNvPr id="12" name="Text 9"/>
           <p:cNvSpPr txBox="1"/>
           <p:nvPr/>
         </p:nvSpPr>
@@ -7023,7 +6834,7 @@
       </p:sp>
       <p:sp>
         <p:nvSpPr>
-          <p:cNvPr id="19" name="Text 13"/>
+          <p:cNvPr id="13" name="Text 10"/>
           <p:cNvSpPr txBox="1"/>
           <p:nvPr/>
         </p:nvSpPr>
@@ -7238,7 +7049,7 @@
       </p:sp>
       <p:pic>
         <p:nvPicPr>
-          <p:cNvPr id="6" name="Image 0" descr="/tmp/claude-0/-home-user-BiVLA/4327cefa-ba5d-5e2e-9d87-c73dd3a8ccbb/scratchpad/video_ppt/assets/ov_repeat.png">    </p:cNvPr>
+          <p:cNvPr id="6" name="Image 0" descr="/tmp/claude-0/-home-user-BiVLA/4327cefa-ba5d-5e2e-9d87-c73dd3a8ccbb/scratchpad/video_ppt/assets/m_repeat.png">    </p:cNvPr>
           <p:cNvPicPr>
             <a:picLocks noChangeAspect="1"/>
           </p:cNvPicPr>
@@ -7253,7 +7064,7 @@
         <p:spPr>
           <a:xfrm>
             <a:off x="457200" y="960120"/>
-            <a:ext cx="3931920" cy="1298448"/>
+            <a:ext cx="3931920" cy="2679192"/>
           </a:xfrm>
           <a:prstGeom prst="rect">
             <a:avLst/>
@@ -7268,764 +7079,8 @@
         </p:nvSpPr>
         <p:spPr>
           <a:xfrm>
-            <a:off x="457200" y="2423160"/>
-            <a:ext cx="3931920" cy="274320"/>
-          </a:xfrm>
-          <a:prstGeom prst="rect">
-            <a:avLst/>
-          </a:prstGeom>
-          <a:noFill/>
-          <a:ln/>
-        </p:spPr>
-        <p:txBody>
-          <a:bodyPr wrap="square" lIns="0" tIns="0" rIns="0" bIns="0" rtlCol="0" anchor="ctr"/>
-          <a:lstStyle/>
-          <a:p>
-            <a:pPr indent="0" marL="0">
-              <a:buNone/>
-            </a:pPr>
-            <a:r>
-              <a:rPr lang="en-US" sz="1150" b="1" dirty="0">
-                <a:solidFill>
-                  <a:srgbClr val="1F2933"/>
-                </a:solidFill>
-                <a:latin typeface="Arial" pitchFamily="34" charset="0"/>
-                <a:ea typeface="Arial" pitchFamily="34" charset="-122"/>
-                <a:cs typeface="Arial" pitchFamily="34" charset="-120"/>
-              </a:rPr>
-              <a:t>Policy calls over 12 control steps</a:t>
-            </a:r>
-            <a:endParaRPr lang="en-US" sz="1150" dirty="0"/>
-          </a:p>
-        </p:txBody>
-      </p:sp>
-      <p:sp>
-        <p:nvSpPr>
-          <p:cNvPr id="8" name="Text 5"/>
-          <p:cNvSpPr txBox="1"/>
-          <p:nvPr/>
-        </p:nvSpPr>
-        <p:spPr>
-          <a:xfrm>
-            <a:off x="457200" y="2743200"/>
-            <a:ext cx="914400" cy="219456"/>
-          </a:xfrm>
-          <a:prstGeom prst="rect">
-            <a:avLst/>
-          </a:prstGeom>
-          <a:noFill/>
-          <a:ln/>
-        </p:spPr>
-        <p:txBody>
-          <a:bodyPr wrap="square" lIns="0" tIns="0" rIns="0" bIns="0" rtlCol="0" anchor="ctr"/>
-          <a:lstStyle/>
-          <a:p>
-            <a:pPr indent="0" marL="0">
-              <a:buNone/>
-            </a:pPr>
-            <a:r>
-              <a:rPr lang="en-US" sz="1050" dirty="0">
-                <a:solidFill>
-                  <a:srgbClr val="5F6B7A"/>
-                </a:solidFill>
-                <a:latin typeface="Arial" pitchFamily="34" charset="0"/>
-                <a:ea typeface="Arial" pitchFamily="34" charset="-122"/>
-                <a:cs typeface="Arial" pitchFamily="34" charset="-120"/>
-              </a:rPr>
-              <a:t>original</a:t>
-            </a:r>
-            <a:endParaRPr lang="en-US" sz="1050" dirty="0"/>
-          </a:p>
-        </p:txBody>
-      </p:sp>
-      <p:sp>
-        <p:nvSpPr>
-          <p:cNvPr id="9" name="Shape 6"/>
-          <p:cNvSpPr/>
-          <p:nvPr/>
-        </p:nvSpPr>
-        <p:spPr>
-          <a:xfrm>
-            <a:off x="1371600" y="2743200"/>
-            <a:ext cx="219456" cy="219456"/>
-          </a:xfrm>
-          <a:prstGeom prst="ellipse">
-            <a:avLst/>
-          </a:prstGeom>
-          <a:solidFill>
-            <a:srgbClr val="1F2933"/>
-          </a:solidFill>
-          <a:ln w="15875">
-            <a:solidFill>
-              <a:srgbClr val="1F2933"/>
-            </a:solidFill>
-            <a:prstDash val="solid"/>
-          </a:ln>
-        </p:spPr>
-      </p:sp>
-      <p:sp>
-        <p:nvSpPr>
-          <p:cNvPr id="10" name="Shape 7"/>
-          <p:cNvSpPr/>
-          <p:nvPr/>
-        </p:nvSpPr>
-        <p:spPr>
-          <a:xfrm>
-            <a:off x="1645920" y="2743200"/>
-            <a:ext cx="219456" cy="219456"/>
-          </a:xfrm>
-          <a:prstGeom prst="ellipse">
-            <a:avLst/>
-          </a:prstGeom>
-          <a:solidFill>
-            <a:srgbClr val="1F2933"/>
-          </a:solidFill>
-          <a:ln w="15875">
-            <a:solidFill>
-              <a:srgbClr val="1F2933"/>
-            </a:solidFill>
-            <a:prstDash val="solid"/>
-          </a:ln>
-        </p:spPr>
-      </p:sp>
-      <p:sp>
-        <p:nvSpPr>
-          <p:cNvPr id="11" name="Shape 8"/>
-          <p:cNvSpPr/>
-          <p:nvPr/>
-        </p:nvSpPr>
-        <p:spPr>
-          <a:xfrm>
-            <a:off x="1920240" y="2743200"/>
-            <a:ext cx="219456" cy="219456"/>
-          </a:xfrm>
-          <a:prstGeom prst="ellipse">
-            <a:avLst/>
-          </a:prstGeom>
-          <a:solidFill>
-            <a:srgbClr val="1F2933"/>
-          </a:solidFill>
-          <a:ln w="15875">
-            <a:solidFill>
-              <a:srgbClr val="1F2933"/>
-            </a:solidFill>
-            <a:prstDash val="solid"/>
-          </a:ln>
-        </p:spPr>
-      </p:sp>
-      <p:sp>
-        <p:nvSpPr>
-          <p:cNvPr id="12" name="Shape 9"/>
-          <p:cNvSpPr/>
-          <p:nvPr/>
-        </p:nvSpPr>
-        <p:spPr>
-          <a:xfrm>
-            <a:off x="2194560" y="2743200"/>
-            <a:ext cx="219456" cy="219456"/>
-          </a:xfrm>
-          <a:prstGeom prst="ellipse">
-            <a:avLst/>
-          </a:prstGeom>
-          <a:solidFill>
-            <a:srgbClr val="1F2933"/>
-          </a:solidFill>
-          <a:ln w="15875">
-            <a:solidFill>
-              <a:srgbClr val="1F2933"/>
-            </a:solidFill>
-            <a:prstDash val="solid"/>
-          </a:ln>
-        </p:spPr>
-      </p:sp>
-      <p:sp>
-        <p:nvSpPr>
-          <p:cNvPr id="13" name="Shape 10"/>
-          <p:cNvSpPr/>
-          <p:nvPr/>
-        </p:nvSpPr>
-        <p:spPr>
-          <a:xfrm>
-            <a:off x="2468880" y="2743200"/>
-            <a:ext cx="219456" cy="219456"/>
-          </a:xfrm>
-          <a:prstGeom prst="ellipse">
-            <a:avLst/>
-          </a:prstGeom>
-          <a:solidFill>
-            <a:srgbClr val="1F2933"/>
-          </a:solidFill>
-          <a:ln w="15875">
-            <a:solidFill>
-              <a:srgbClr val="1F2933"/>
-            </a:solidFill>
-            <a:prstDash val="solid"/>
-          </a:ln>
-        </p:spPr>
-      </p:sp>
-      <p:sp>
-        <p:nvSpPr>
-          <p:cNvPr id="14" name="Shape 11"/>
-          <p:cNvSpPr/>
-          <p:nvPr/>
-        </p:nvSpPr>
-        <p:spPr>
-          <a:xfrm>
-            <a:off x="2743200" y="2743200"/>
-            <a:ext cx="219456" cy="219456"/>
-          </a:xfrm>
-          <a:prstGeom prst="ellipse">
-            <a:avLst/>
-          </a:prstGeom>
-          <a:solidFill>
-            <a:srgbClr val="1F2933"/>
-          </a:solidFill>
-          <a:ln w="15875">
-            <a:solidFill>
-              <a:srgbClr val="1F2933"/>
-            </a:solidFill>
-            <a:prstDash val="solid"/>
-          </a:ln>
-        </p:spPr>
-      </p:sp>
-      <p:sp>
-        <p:nvSpPr>
-          <p:cNvPr id="15" name="Shape 12"/>
-          <p:cNvSpPr/>
-          <p:nvPr/>
-        </p:nvSpPr>
-        <p:spPr>
-          <a:xfrm>
-            <a:off x="3017520" y="2743200"/>
-            <a:ext cx="219456" cy="219456"/>
-          </a:xfrm>
-          <a:prstGeom prst="ellipse">
-            <a:avLst/>
-          </a:prstGeom>
-          <a:solidFill>
-            <a:srgbClr val="1F2933"/>
-          </a:solidFill>
-          <a:ln w="15875">
-            <a:solidFill>
-              <a:srgbClr val="1F2933"/>
-            </a:solidFill>
-            <a:prstDash val="solid"/>
-          </a:ln>
-        </p:spPr>
-      </p:sp>
-      <p:sp>
-        <p:nvSpPr>
-          <p:cNvPr id="16" name="Shape 13"/>
-          <p:cNvSpPr/>
-          <p:nvPr/>
-        </p:nvSpPr>
-        <p:spPr>
-          <a:xfrm>
-            <a:off x="3291840" y="2743200"/>
-            <a:ext cx="219456" cy="219456"/>
-          </a:xfrm>
-          <a:prstGeom prst="ellipse">
-            <a:avLst/>
-          </a:prstGeom>
-          <a:solidFill>
-            <a:srgbClr val="1F2933"/>
-          </a:solidFill>
-          <a:ln w="15875">
-            <a:solidFill>
-              <a:srgbClr val="1F2933"/>
-            </a:solidFill>
-            <a:prstDash val="solid"/>
-          </a:ln>
-        </p:spPr>
-      </p:sp>
-      <p:sp>
-        <p:nvSpPr>
-          <p:cNvPr id="17" name="Shape 14"/>
-          <p:cNvSpPr/>
-          <p:nvPr/>
-        </p:nvSpPr>
-        <p:spPr>
-          <a:xfrm>
-            <a:off x="3566160" y="2743200"/>
-            <a:ext cx="219456" cy="219456"/>
-          </a:xfrm>
-          <a:prstGeom prst="ellipse">
-            <a:avLst/>
-          </a:prstGeom>
-          <a:solidFill>
-            <a:srgbClr val="1F2933"/>
-          </a:solidFill>
-          <a:ln w="15875">
-            <a:solidFill>
-              <a:srgbClr val="1F2933"/>
-            </a:solidFill>
-            <a:prstDash val="solid"/>
-          </a:ln>
-        </p:spPr>
-      </p:sp>
-      <p:sp>
-        <p:nvSpPr>
-          <p:cNvPr id="18" name="Shape 15"/>
-          <p:cNvSpPr/>
-          <p:nvPr/>
-        </p:nvSpPr>
-        <p:spPr>
-          <a:xfrm>
-            <a:off x="3840480" y="2743200"/>
-            <a:ext cx="219456" cy="219456"/>
-          </a:xfrm>
-          <a:prstGeom prst="ellipse">
-            <a:avLst/>
-          </a:prstGeom>
-          <a:solidFill>
-            <a:srgbClr val="1F2933"/>
-          </a:solidFill>
-          <a:ln w="15875">
-            <a:solidFill>
-              <a:srgbClr val="1F2933"/>
-            </a:solidFill>
-            <a:prstDash val="solid"/>
-          </a:ln>
-        </p:spPr>
-      </p:sp>
-      <p:sp>
-        <p:nvSpPr>
-          <p:cNvPr id="19" name="Shape 16"/>
-          <p:cNvSpPr/>
-          <p:nvPr/>
-        </p:nvSpPr>
-        <p:spPr>
-          <a:xfrm>
-            <a:off x="4114800" y="2743200"/>
-            <a:ext cx="219456" cy="219456"/>
-          </a:xfrm>
-          <a:prstGeom prst="ellipse">
-            <a:avLst/>
-          </a:prstGeom>
-          <a:solidFill>
-            <a:srgbClr val="1F2933"/>
-          </a:solidFill>
-          <a:ln w="15875">
-            <a:solidFill>
-              <a:srgbClr val="1F2933"/>
-            </a:solidFill>
-            <a:prstDash val="solid"/>
-          </a:ln>
-        </p:spPr>
-      </p:sp>
-      <p:sp>
-        <p:nvSpPr>
-          <p:cNvPr id="20" name="Shape 17"/>
-          <p:cNvSpPr/>
-          <p:nvPr/>
-        </p:nvSpPr>
-        <p:spPr>
-          <a:xfrm>
-            <a:off x="4389120" y="2743200"/>
-            <a:ext cx="219456" cy="219456"/>
-          </a:xfrm>
-          <a:prstGeom prst="ellipse">
-            <a:avLst/>
-          </a:prstGeom>
-          <a:solidFill>
-            <a:srgbClr val="1F2933"/>
-          </a:solidFill>
-          <a:ln w="15875">
-            <a:solidFill>
-              <a:srgbClr val="1F2933"/>
-            </a:solidFill>
-            <a:prstDash val="solid"/>
-          </a:ln>
-        </p:spPr>
-      </p:sp>
-      <p:sp>
-        <p:nvSpPr>
-          <p:cNvPr id="21" name="Text 18"/>
-          <p:cNvSpPr txBox="1"/>
-          <p:nvPr/>
-        </p:nvSpPr>
-        <p:spPr>
-          <a:xfrm>
-            <a:off x="457200" y="3108960"/>
-            <a:ext cx="914400" cy="219456"/>
-          </a:xfrm>
-          <a:prstGeom prst="rect">
-            <a:avLst/>
-          </a:prstGeom>
-          <a:noFill/>
-          <a:ln/>
-        </p:spPr>
-        <p:txBody>
-          <a:bodyPr wrap="square" lIns="0" tIns="0" rIns="0" bIns="0" rtlCol="0" anchor="ctr"/>
-          <a:lstStyle/>
-          <a:p>
-            <a:pPr indent="0" marL="0">
-              <a:buNone/>
-            </a:pPr>
-            <a:r>
-              <a:rPr lang="en-US" sz="1050" dirty="0">
-                <a:solidFill>
-                  <a:srgbClr val="5F6B7A"/>
-                </a:solidFill>
-                <a:latin typeface="Arial" pitchFamily="34" charset="0"/>
-                <a:ea typeface="Arial" pitchFamily="34" charset="-122"/>
-                <a:cs typeface="Arial" pitchFamily="34" charset="-120"/>
-              </a:rPr>
-              <a:t>k = 4</a:t>
-            </a:r>
-            <a:endParaRPr lang="en-US" sz="1050" dirty="0"/>
-          </a:p>
-        </p:txBody>
-      </p:sp>
-      <p:sp>
-        <p:nvSpPr>
-          <p:cNvPr id="22" name="Shape 19"/>
-          <p:cNvSpPr/>
-          <p:nvPr/>
-        </p:nvSpPr>
-        <p:spPr>
-          <a:xfrm>
-            <a:off x="1371600" y="3108960"/>
-            <a:ext cx="219456" cy="219456"/>
-          </a:xfrm>
-          <a:prstGeom prst="ellipse">
-            <a:avLst/>
-          </a:prstGeom>
-          <a:solidFill>
-            <a:srgbClr val="C8641E"/>
-          </a:solidFill>
-          <a:ln w="15875">
-            <a:solidFill>
-              <a:srgbClr val="C8641E"/>
-            </a:solidFill>
-            <a:prstDash val="solid"/>
-          </a:ln>
-        </p:spPr>
-      </p:sp>
-      <p:sp>
-        <p:nvSpPr>
-          <p:cNvPr id="23" name="Shape 20"/>
-          <p:cNvSpPr/>
-          <p:nvPr/>
-        </p:nvSpPr>
-        <p:spPr>
-          <a:xfrm>
-            <a:off x="1645920" y="3108960"/>
-            <a:ext cx="219456" cy="219456"/>
-          </a:xfrm>
-          <a:prstGeom prst="ellipse">
-            <a:avLst/>
-          </a:prstGeom>
-          <a:solidFill>
-            <a:srgbClr val="FFFFFF"/>
-          </a:solidFill>
-          <a:ln w="15875">
-            <a:solidFill>
-              <a:srgbClr val="9AA3AE"/>
-            </a:solidFill>
-            <a:prstDash val="solid"/>
-          </a:ln>
-        </p:spPr>
-      </p:sp>
-      <p:sp>
-        <p:nvSpPr>
-          <p:cNvPr id="24" name="Shape 21"/>
-          <p:cNvSpPr/>
-          <p:nvPr/>
-        </p:nvSpPr>
-        <p:spPr>
-          <a:xfrm>
-            <a:off x="1920240" y="3108960"/>
-            <a:ext cx="219456" cy="219456"/>
-          </a:xfrm>
-          <a:prstGeom prst="ellipse">
-            <a:avLst/>
-          </a:prstGeom>
-          <a:solidFill>
-            <a:srgbClr val="FFFFFF"/>
-          </a:solidFill>
-          <a:ln w="15875">
-            <a:solidFill>
-              <a:srgbClr val="9AA3AE"/>
-            </a:solidFill>
-            <a:prstDash val="solid"/>
-          </a:ln>
-        </p:spPr>
-      </p:sp>
-      <p:sp>
-        <p:nvSpPr>
-          <p:cNvPr id="25" name="Shape 22"/>
-          <p:cNvSpPr/>
-          <p:nvPr/>
-        </p:nvSpPr>
-        <p:spPr>
-          <a:xfrm>
-            <a:off x="2194560" y="3108960"/>
-            <a:ext cx="219456" cy="219456"/>
-          </a:xfrm>
-          <a:prstGeom prst="ellipse">
-            <a:avLst/>
-          </a:prstGeom>
-          <a:solidFill>
-            <a:srgbClr val="FFFFFF"/>
-          </a:solidFill>
-          <a:ln w="15875">
-            <a:solidFill>
-              <a:srgbClr val="9AA3AE"/>
-            </a:solidFill>
-            <a:prstDash val="solid"/>
-          </a:ln>
-        </p:spPr>
-      </p:sp>
-      <p:sp>
-        <p:nvSpPr>
-          <p:cNvPr id="26" name="Shape 23"/>
-          <p:cNvSpPr/>
-          <p:nvPr/>
-        </p:nvSpPr>
-        <p:spPr>
-          <a:xfrm>
-            <a:off x="2468880" y="3108960"/>
-            <a:ext cx="219456" cy="219456"/>
-          </a:xfrm>
-          <a:prstGeom prst="ellipse">
-            <a:avLst/>
-          </a:prstGeom>
-          <a:solidFill>
-            <a:srgbClr val="C8641E"/>
-          </a:solidFill>
-          <a:ln w="15875">
-            <a:solidFill>
-              <a:srgbClr val="C8641E"/>
-            </a:solidFill>
-            <a:prstDash val="solid"/>
-          </a:ln>
-        </p:spPr>
-      </p:sp>
-      <p:sp>
-        <p:nvSpPr>
-          <p:cNvPr id="27" name="Shape 24"/>
-          <p:cNvSpPr/>
-          <p:nvPr/>
-        </p:nvSpPr>
-        <p:spPr>
-          <a:xfrm>
-            <a:off x="2743200" y="3108960"/>
-            <a:ext cx="219456" cy="219456"/>
-          </a:xfrm>
-          <a:prstGeom prst="ellipse">
-            <a:avLst/>
-          </a:prstGeom>
-          <a:solidFill>
-            <a:srgbClr val="FFFFFF"/>
-          </a:solidFill>
-          <a:ln w="15875">
-            <a:solidFill>
-              <a:srgbClr val="9AA3AE"/>
-            </a:solidFill>
-            <a:prstDash val="solid"/>
-          </a:ln>
-        </p:spPr>
-      </p:sp>
-      <p:sp>
-        <p:nvSpPr>
-          <p:cNvPr id="28" name="Shape 25"/>
-          <p:cNvSpPr/>
-          <p:nvPr/>
-        </p:nvSpPr>
-        <p:spPr>
-          <a:xfrm>
-            <a:off x="3017520" y="3108960"/>
-            <a:ext cx="219456" cy="219456"/>
-          </a:xfrm>
-          <a:prstGeom prst="ellipse">
-            <a:avLst/>
-          </a:prstGeom>
-          <a:solidFill>
-            <a:srgbClr val="FFFFFF"/>
-          </a:solidFill>
-          <a:ln w="15875">
-            <a:solidFill>
-              <a:srgbClr val="9AA3AE"/>
-            </a:solidFill>
-            <a:prstDash val="solid"/>
-          </a:ln>
-        </p:spPr>
-      </p:sp>
-      <p:sp>
-        <p:nvSpPr>
-          <p:cNvPr id="29" name="Shape 26"/>
-          <p:cNvSpPr/>
-          <p:nvPr/>
-        </p:nvSpPr>
-        <p:spPr>
-          <a:xfrm>
-            <a:off x="3291840" y="3108960"/>
-            <a:ext cx="219456" cy="219456"/>
-          </a:xfrm>
-          <a:prstGeom prst="ellipse">
-            <a:avLst/>
-          </a:prstGeom>
-          <a:solidFill>
-            <a:srgbClr val="FFFFFF"/>
-          </a:solidFill>
-          <a:ln w="15875">
-            <a:solidFill>
-              <a:srgbClr val="9AA3AE"/>
-            </a:solidFill>
-            <a:prstDash val="solid"/>
-          </a:ln>
-        </p:spPr>
-      </p:sp>
-      <p:sp>
-        <p:nvSpPr>
-          <p:cNvPr id="30" name="Shape 27"/>
-          <p:cNvSpPr/>
-          <p:nvPr/>
-        </p:nvSpPr>
-        <p:spPr>
-          <a:xfrm>
-            <a:off x="3566160" y="3108960"/>
-            <a:ext cx="219456" cy="219456"/>
-          </a:xfrm>
-          <a:prstGeom prst="ellipse">
-            <a:avLst/>
-          </a:prstGeom>
-          <a:solidFill>
-            <a:srgbClr val="C8641E"/>
-          </a:solidFill>
-          <a:ln w="15875">
-            <a:solidFill>
-              <a:srgbClr val="C8641E"/>
-            </a:solidFill>
-            <a:prstDash val="solid"/>
-          </a:ln>
-        </p:spPr>
-      </p:sp>
-      <p:sp>
-        <p:nvSpPr>
-          <p:cNvPr id="31" name="Shape 28"/>
-          <p:cNvSpPr/>
-          <p:nvPr/>
-        </p:nvSpPr>
-        <p:spPr>
-          <a:xfrm>
-            <a:off x="3840480" y="3108960"/>
-            <a:ext cx="219456" cy="219456"/>
-          </a:xfrm>
-          <a:prstGeom prst="ellipse">
-            <a:avLst/>
-          </a:prstGeom>
-          <a:solidFill>
-            <a:srgbClr val="FFFFFF"/>
-          </a:solidFill>
-          <a:ln w="15875">
-            <a:solidFill>
-              <a:srgbClr val="9AA3AE"/>
-            </a:solidFill>
-            <a:prstDash val="solid"/>
-          </a:ln>
-        </p:spPr>
-      </p:sp>
-      <p:sp>
-        <p:nvSpPr>
-          <p:cNvPr id="32" name="Shape 29"/>
-          <p:cNvSpPr/>
-          <p:nvPr/>
-        </p:nvSpPr>
-        <p:spPr>
-          <a:xfrm>
-            <a:off x="4114800" y="3108960"/>
-            <a:ext cx="219456" cy="219456"/>
-          </a:xfrm>
-          <a:prstGeom prst="ellipse">
-            <a:avLst/>
-          </a:prstGeom>
-          <a:solidFill>
-            <a:srgbClr val="FFFFFF"/>
-          </a:solidFill>
-          <a:ln w="15875">
-            <a:solidFill>
-              <a:srgbClr val="9AA3AE"/>
-            </a:solidFill>
-            <a:prstDash val="solid"/>
-          </a:ln>
-        </p:spPr>
-      </p:sp>
-      <p:sp>
-        <p:nvSpPr>
-          <p:cNvPr id="33" name="Shape 30"/>
-          <p:cNvSpPr/>
-          <p:nvPr/>
-        </p:nvSpPr>
-        <p:spPr>
-          <a:xfrm>
-            <a:off x="4389120" y="3108960"/>
-            <a:ext cx="219456" cy="219456"/>
-          </a:xfrm>
-          <a:prstGeom prst="ellipse">
-            <a:avLst/>
-          </a:prstGeom>
-          <a:solidFill>
-            <a:srgbClr val="FFFFFF"/>
-          </a:solidFill>
-          <a:ln w="15875">
-            <a:solidFill>
-              <a:srgbClr val="9AA3AE"/>
-            </a:solidFill>
-            <a:prstDash val="solid"/>
-          </a:ln>
-        </p:spPr>
-      </p:sp>
-      <p:sp>
-        <p:nvSpPr>
-          <p:cNvPr id="34" name="Text 31"/>
-          <p:cNvSpPr txBox="1"/>
-          <p:nvPr/>
-        </p:nvSpPr>
-        <p:spPr>
-          <a:xfrm>
-            <a:off x="1371600" y="3383280"/>
-            <a:ext cx="3200400" cy="274320"/>
-          </a:xfrm>
-          <a:prstGeom prst="rect">
-            <a:avLst/>
-          </a:prstGeom>
-          <a:noFill/>
-          <a:ln/>
-        </p:spPr>
-        <p:txBody>
-          <a:bodyPr wrap="square" lIns="0" tIns="0" rIns="0" bIns="0" rtlCol="0" anchor="t"/>
-          <a:lstStyle/>
-          <a:p>
-            <a:pPr algn="l" indent="0" marL="0">
-              <a:buNone/>
-            </a:pPr>
-            <a:r>
-              <a:rPr lang="en-US" sz="1000" dirty="0">
-                <a:solidFill>
-                  <a:srgbClr val="5F6B7A"/>
-                </a:solidFill>
-                <a:latin typeface="Arial" pitchFamily="34" charset="0"/>
-                <a:ea typeface="Arial" pitchFamily="34" charset="-122"/>
-                <a:cs typeface="Arial" pitchFamily="34" charset="-120"/>
-              </a:rPr>
-              <a:t>filled = policy call, hollow = previous action held</a:t>
-            </a:r>
-            <a:endParaRPr lang="en-US" sz="1000" dirty="0"/>
-          </a:p>
-        </p:txBody>
-      </p:sp>
-      <p:sp>
-        <p:nvSpPr>
-          <p:cNvPr id="35" name="Text 32"/>
-          <p:cNvSpPr txBox="1"/>
-          <p:nvPr/>
-        </p:nvSpPr>
-        <p:spPr>
-          <a:xfrm>
-            <a:off x="457200" y="3703320"/>
-            <a:ext cx="4023360" cy="1097280"/>
+            <a:off x="457200" y="3794760"/>
+            <a:ext cx="4023360" cy="1005840"/>
           </a:xfrm>
           <a:prstGeom prst="rect">
             <a:avLst/>
@@ -8103,7 +7158,7 @@
       </p:sp>
       <p:sp>
         <p:nvSpPr>
-          <p:cNvPr id="36" name="Shape 33"/>
+          <p:cNvPr id="8" name="Shape 5"/>
           <p:cNvSpPr/>
           <p:nvPr/>
         </p:nvSpPr>
@@ -8130,7 +7185,7 @@
       </p:sp>
       <p:sp>
         <p:nvSpPr>
-          <p:cNvPr id="37" name="Shape 34"/>
+          <p:cNvPr id="9" name="Shape 6"/>
           <p:cNvSpPr/>
           <p:nvPr/>
         </p:nvSpPr>
@@ -8155,7 +7210,7 @@
       </p:sp>
       <p:sp>
         <p:nvSpPr>
-          <p:cNvPr id="38" name="Shape 35"/>
+          <p:cNvPr id="10" name="Shape 7"/>
           <p:cNvSpPr/>
           <p:nvPr/>
         </p:nvSpPr>
@@ -8180,7 +7235,7 @@
       </p:sp>
       <p:sp>
         <p:nvSpPr>
-          <p:cNvPr id="39" name="Text 36"/>
+          <p:cNvPr id="11" name="Text 8"/>
           <p:cNvSpPr txBox="1"/>
           <p:nvPr/>
         </p:nvSpPr>
@@ -8219,7 +7274,7 @@
       </p:sp>
       <p:sp>
         <p:nvSpPr>
-          <p:cNvPr id="40" name="Text 37"/>
+          <p:cNvPr id="12" name="Text 9"/>
           <p:cNvSpPr txBox="1"/>
           <p:nvPr/>
         </p:nvSpPr>
@@ -8258,7 +7313,7 @@
       </p:sp>
       <p:sp>
         <p:nvSpPr>
-          <p:cNvPr id="41" name="Text 38"/>
+          <p:cNvPr id="13" name="Text 10"/>
           <p:cNvSpPr txBox="1"/>
           <p:nvPr/>
         </p:nvSpPr>
@@ -8473,7 +7528,7 @@
       </p:sp>
       <p:pic>
         <p:nvPicPr>
-          <p:cNvPr id="6" name="Image 0" descr="/tmp/claude-0/-home-user-BiVLA/4327cefa-ba5d-5e2e-9d87-c73dd3a8ccbb/scratchpad/video_ppt/assets/ov_prune.png">    </p:cNvPr>
+          <p:cNvPr id="6" name="Image 0" descr="/tmp/claude-0/-home-user-BiVLA/4327cefa-ba5d-5e2e-9d87-c73dd3a8ccbb/scratchpad/video_ppt/assets/m_prune.png">    </p:cNvPr>
           <p:cNvPicPr>
             <a:picLocks noChangeAspect="1"/>
           </p:cNvPicPr>
@@ -8488,7 +7543,7 @@
         <p:spPr>
           <a:xfrm>
             <a:off x="457200" y="960120"/>
-            <a:ext cx="3931920" cy="1618488"/>
+            <a:ext cx="2514600" cy="2542032"/>
           </a:xfrm>
           <a:prstGeom prst="rect">
             <a:avLst/>
@@ -8503,8 +7558,8 @@
         </p:nvSpPr>
         <p:spPr>
           <a:xfrm>
-            <a:off x="457200" y="2788920"/>
-            <a:ext cx="4023360" cy="1920240"/>
+            <a:off x="3108960" y="1005840"/>
+            <a:ext cx="1371600" cy="3566160"/>
           </a:xfrm>
           <a:prstGeom prst="rect">
             <a:avLst/>
@@ -8518,13 +7573,13 @@
           <a:p>
             <a:pPr marL="177800" indent="-177800">
               <a:spcAft>
-                <a:spcPts val="400"/>
+                <a:spcPts val="500"/>
               </a:spcAft>
               <a:buSzPct val="100000"/>
               <a:buChar char="•"/>
             </a:pPr>
             <a:r>
-              <a:rPr lang="en-US" sz="1150" dirty="0">
+              <a:rPr lang="en-US" sz="1050" dirty="0">
                 <a:solidFill>
                   <a:srgbClr val="1F2933"/>
                 </a:solidFill>
@@ -8534,18 +7589,18 @@
               </a:rPr>
               <a:t>Block Influence: how little a decoder block changes its hidden states on calibration data</a:t>
             </a:r>
-            <a:endParaRPr lang="en-US" sz="1150" dirty="0"/>
+            <a:endParaRPr lang="en-US" sz="1050" dirty="0"/>
           </a:p>
           <a:p>
             <a:pPr marL="177800" indent="-177800">
               <a:spcAft>
-                <a:spcPts val="400"/>
+                <a:spcPts val="500"/>
               </a:spcAft>
               <a:buSzPct val="100000"/>
               <a:buChar char="•"/>
             </a:pPr>
             <a:r>
-              <a:rPr lang="en-US" sz="1150" dirty="0">
+              <a:rPr lang="en-US" sz="1050" dirty="0">
                 <a:solidFill>
                   <a:srgbClr val="1F2933"/>
                 </a:solidFill>
@@ -8555,18 +7610,18 @@
               </a:rPr>
               <a:t>Remove the 1, 2, or 4 lowest-influence blocks; none adjacent, first and last kept</a:t>
             </a:r>
-            <a:endParaRPr lang="en-US" sz="1150" dirty="0"/>
+            <a:endParaRPr lang="en-US" sz="1050" dirty="0"/>
           </a:p>
           <a:p>
             <a:pPr marL="177800" indent="-177800">
               <a:spcAft>
-                <a:spcPts val="400"/>
+                <a:spcPts val="500"/>
               </a:spcAft>
               <a:buSzPct val="100000"/>
               <a:buChar char="•"/>
             </a:pPr>
             <a:r>
-              <a:rPr lang="en-US" sz="1150" dirty="0">
+              <a:rPr lang="en-US" sz="1050" dirty="0">
                 <a:solidFill>
                   <a:srgbClr val="1F2933"/>
                 </a:solidFill>
@@ -8574,9 +7629,30 @@
                 <a:ea typeface="Arial" pitchFamily="34" charset="-122"/>
                 <a:cs typeface="Arial" pitchFamily="34" charset="-120"/>
               </a:rPr>
-              <a:t>Selected once, fixed before evaluation; reduces prefill and decoding compute</a:t>
-            </a:r>
-            <a:endParaRPr lang="en-US" sz="1150" dirty="0"/>
+              <a:t>Selected once from calibration data, fixed before evaluation</a:t>
+            </a:r>
+            <a:endParaRPr lang="en-US" sz="1050" dirty="0"/>
+          </a:p>
+          <a:p>
+            <a:pPr marL="177800" indent="-177800">
+              <a:spcAft>
+                <a:spcPts val="500"/>
+              </a:spcAft>
+              <a:buSzPct val="100000"/>
+              <a:buChar char="•"/>
+            </a:pPr>
+            <a:r>
+              <a:rPr lang="en-US" sz="1050" dirty="0">
+                <a:solidFill>
+                  <a:srgbClr val="1F2933"/>
+                </a:solidFill>
+                <a:latin typeface="Arial" pitchFamily="34" charset="0"/>
+                <a:ea typeface="Arial" pitchFamily="34" charset="-122"/>
+                <a:cs typeface="Arial" pitchFamily="34" charset="-120"/>
+              </a:rPr>
+              <a:t>Acts inside the action decoder, after the visual encoder</a:t>
+            </a:r>
+            <a:endParaRPr lang="en-US" sz="1050" dirty="0"/>
           </a:p>
         </p:txBody>
       </p:sp>
@@ -8952,7 +8028,7 @@
       </p:sp>
       <p:pic>
         <p:nvPicPr>
-          <p:cNvPr id="6" name="Image 0" descr="/tmp/claude-0/-home-user-BiVLA/4327cefa-ba5d-5e2e-9d87-c73dd3a8ccbb/scratchpad/video_ppt/assets/ov_guarded.png">    </p:cNvPr>
+          <p:cNvPr id="6" name="Image 0" descr="/tmp/claude-0/-home-user-BiVLA/4327cefa-ba5d-5e2e-9d87-c73dd3a8ccbb/scratchpad/video_ppt/assets/m_guarded.png">    </p:cNvPr>
           <p:cNvPicPr>
             <a:picLocks noChangeAspect="1"/>
           </p:cNvPicPr>
@@ -8967,7 +8043,7 @@
         <p:spPr>
           <a:xfrm>
             <a:off x="457200" y="960120"/>
-            <a:ext cx="3931920" cy="1618488"/>
+            <a:ext cx="3931920" cy="2532888"/>
           </a:xfrm>
           <a:prstGeom prst="rect">
             <a:avLst/>
@@ -8982,8 +8058,8 @@
         </p:nvSpPr>
         <p:spPr>
           <a:xfrm>
-            <a:off x="457200" y="2788920"/>
-            <a:ext cx="914400" cy="219456"/>
+            <a:off x="457200" y="3611880"/>
+            <a:ext cx="4023360" cy="1188720"/>
           </a:xfrm>
           <a:prstGeom prst="rect">
             <a:avLst/>
@@ -8992,521 +8068,18 @@
           <a:ln/>
         </p:spPr>
         <p:txBody>
-          <a:bodyPr wrap="square" lIns="0" tIns="0" rIns="0" bIns="0" rtlCol="0" anchor="ctr"/>
-          <a:lstStyle/>
-          <a:p>
-            <a:pPr indent="0" marL="0">
-              <a:buNone/>
-            </a:pPr>
-            <a:r>
-              <a:rPr lang="en-US" sz="1050" dirty="0">
-                <a:solidFill>
-                  <a:srgbClr val="5F6B7A"/>
-                </a:solidFill>
-                <a:latin typeface="Arial" pitchFamily="34" charset="0"/>
-                <a:ea typeface="Arial" pitchFamily="34" charset="-122"/>
-                <a:cs typeface="Arial" pitchFamily="34" charset="-120"/>
-              </a:rPr>
-              <a:t>guarded</a:t>
-            </a:r>
-            <a:endParaRPr lang="en-US" sz="1050" dirty="0"/>
-          </a:p>
-        </p:txBody>
-      </p:sp>
-      <p:sp>
-        <p:nvSpPr>
-          <p:cNvPr id="8" name="Shape 5"/>
-          <p:cNvSpPr/>
-          <p:nvPr/>
-        </p:nvSpPr>
-        <p:spPr>
-          <a:xfrm>
-            <a:off x="1371600" y="2788920"/>
-            <a:ext cx="219456" cy="219456"/>
-          </a:xfrm>
-          <a:prstGeom prst="ellipse">
-            <a:avLst/>
-          </a:prstGeom>
-          <a:solidFill>
-            <a:srgbClr val="C8641E"/>
-          </a:solidFill>
-          <a:ln w="15875">
-            <a:solidFill>
-              <a:srgbClr val="C8641E"/>
-            </a:solidFill>
-            <a:prstDash val="solid"/>
-          </a:ln>
-        </p:spPr>
-      </p:sp>
-      <p:sp>
-        <p:nvSpPr>
-          <p:cNvPr id="9" name="Shape 6"/>
-          <p:cNvSpPr/>
-          <p:nvPr/>
-        </p:nvSpPr>
-        <p:spPr>
-          <a:xfrm>
-            <a:off x="1645920" y="2788920"/>
-            <a:ext cx="219456" cy="219456"/>
-          </a:xfrm>
-          <a:prstGeom prst="ellipse">
-            <a:avLst/>
-          </a:prstGeom>
-          <a:solidFill>
-            <a:srgbClr val="FFFFFF"/>
-          </a:solidFill>
-          <a:ln w="15875">
-            <a:solidFill>
-              <a:srgbClr val="9AA3AE"/>
-            </a:solidFill>
-            <a:prstDash val="solid"/>
-          </a:ln>
-        </p:spPr>
-      </p:sp>
-      <p:sp>
-        <p:nvSpPr>
-          <p:cNvPr id="10" name="Shape 7"/>
-          <p:cNvSpPr/>
-          <p:nvPr/>
-        </p:nvSpPr>
-        <p:spPr>
-          <a:xfrm>
-            <a:off x="1709928" y="3081528"/>
-            <a:ext cx="91440" cy="91440"/>
-          </a:xfrm>
-          <a:prstGeom prst="ellipse">
-            <a:avLst/>
-          </a:prstGeom>
-          <a:solidFill>
-            <a:srgbClr val="2E8B57"/>
-          </a:solidFill>
-          <a:ln w="12700">
-            <a:solidFill>
-              <a:srgbClr val="2E8B57"/>
-            </a:solidFill>
-            <a:prstDash val="solid"/>
-          </a:ln>
-        </p:spPr>
-      </p:sp>
-      <p:sp>
-        <p:nvSpPr>
-          <p:cNvPr id="11" name="Shape 8"/>
-          <p:cNvSpPr/>
-          <p:nvPr/>
-        </p:nvSpPr>
-        <p:spPr>
-          <a:xfrm>
-            <a:off x="1920240" y="2788920"/>
-            <a:ext cx="219456" cy="219456"/>
-          </a:xfrm>
-          <a:prstGeom prst="ellipse">
-            <a:avLst/>
-          </a:prstGeom>
-          <a:solidFill>
-            <a:srgbClr val="FFFFFF"/>
-          </a:solidFill>
-          <a:ln w="15875">
-            <a:solidFill>
-              <a:srgbClr val="9AA3AE"/>
-            </a:solidFill>
-            <a:prstDash val="solid"/>
-          </a:ln>
-        </p:spPr>
-      </p:sp>
-      <p:sp>
-        <p:nvSpPr>
-          <p:cNvPr id="12" name="Shape 9"/>
-          <p:cNvSpPr/>
-          <p:nvPr/>
-        </p:nvSpPr>
-        <p:spPr>
-          <a:xfrm>
-            <a:off x="1984248" y="3081528"/>
-            <a:ext cx="91440" cy="91440"/>
-          </a:xfrm>
-          <a:prstGeom prst="ellipse">
-            <a:avLst/>
-          </a:prstGeom>
-          <a:solidFill>
-            <a:srgbClr val="2E8B57"/>
-          </a:solidFill>
-          <a:ln w="12700">
-            <a:solidFill>
-              <a:srgbClr val="2E8B57"/>
-            </a:solidFill>
-            <a:prstDash val="solid"/>
-          </a:ln>
-        </p:spPr>
-      </p:sp>
-      <p:sp>
-        <p:nvSpPr>
-          <p:cNvPr id="13" name="Shape 10"/>
-          <p:cNvSpPr/>
-          <p:nvPr/>
-        </p:nvSpPr>
-        <p:spPr>
-          <a:xfrm>
-            <a:off x="2194560" y="2788920"/>
-            <a:ext cx="219456" cy="219456"/>
-          </a:xfrm>
-          <a:prstGeom prst="ellipse">
-            <a:avLst/>
-          </a:prstGeom>
-          <a:solidFill>
-            <a:srgbClr val="C8641E"/>
-          </a:solidFill>
-          <a:ln w="15875">
-            <a:solidFill>
-              <a:srgbClr val="C8641E"/>
-            </a:solidFill>
-            <a:prstDash val="solid"/>
-          </a:ln>
-        </p:spPr>
-      </p:sp>
-      <p:sp>
-        <p:nvSpPr>
-          <p:cNvPr id="14" name="Shape 11"/>
-          <p:cNvSpPr/>
-          <p:nvPr/>
-        </p:nvSpPr>
-        <p:spPr>
-          <a:xfrm>
-            <a:off x="2468880" y="2788920"/>
-            <a:ext cx="219456" cy="219456"/>
-          </a:xfrm>
-          <a:prstGeom prst="ellipse">
-            <a:avLst/>
-          </a:prstGeom>
-          <a:solidFill>
-            <a:srgbClr val="C8641E"/>
-          </a:solidFill>
-          <a:ln w="15875">
-            <a:solidFill>
-              <a:srgbClr val="C8641E"/>
-            </a:solidFill>
-            <a:prstDash val="solid"/>
-          </a:ln>
-        </p:spPr>
-      </p:sp>
-      <p:sp>
-        <p:nvSpPr>
-          <p:cNvPr id="15" name="Shape 12"/>
-          <p:cNvSpPr/>
-          <p:nvPr/>
-        </p:nvSpPr>
-        <p:spPr>
-          <a:xfrm>
-            <a:off x="2743200" y="2788920"/>
-            <a:ext cx="219456" cy="219456"/>
-          </a:xfrm>
-          <a:prstGeom prst="ellipse">
-            <a:avLst/>
-          </a:prstGeom>
-          <a:solidFill>
-            <a:srgbClr val="FFFFFF"/>
-          </a:solidFill>
-          <a:ln w="15875">
-            <a:solidFill>
-              <a:srgbClr val="9AA3AE"/>
-            </a:solidFill>
-            <a:prstDash val="solid"/>
-          </a:ln>
-        </p:spPr>
-      </p:sp>
-      <p:sp>
-        <p:nvSpPr>
-          <p:cNvPr id="16" name="Shape 13"/>
-          <p:cNvSpPr/>
-          <p:nvPr/>
-        </p:nvSpPr>
-        <p:spPr>
-          <a:xfrm>
-            <a:off x="2807208" y="3081528"/>
-            <a:ext cx="91440" cy="91440"/>
-          </a:xfrm>
-          <a:prstGeom prst="ellipse">
-            <a:avLst/>
-          </a:prstGeom>
-          <a:solidFill>
-            <a:srgbClr val="2E8B57"/>
-          </a:solidFill>
-          <a:ln w="12700">
-            <a:solidFill>
-              <a:srgbClr val="2E8B57"/>
-            </a:solidFill>
-            <a:prstDash val="solid"/>
-          </a:ln>
-        </p:spPr>
-      </p:sp>
-      <p:sp>
-        <p:nvSpPr>
-          <p:cNvPr id="17" name="Shape 14"/>
-          <p:cNvSpPr/>
-          <p:nvPr/>
-        </p:nvSpPr>
-        <p:spPr>
-          <a:xfrm>
-            <a:off x="3017520" y="2788920"/>
-            <a:ext cx="219456" cy="219456"/>
-          </a:xfrm>
-          <a:prstGeom prst="ellipse">
-            <a:avLst/>
-          </a:prstGeom>
-          <a:solidFill>
-            <a:srgbClr val="C8641E"/>
-          </a:solidFill>
-          <a:ln w="15875">
-            <a:solidFill>
-              <a:srgbClr val="C8641E"/>
-            </a:solidFill>
-            <a:prstDash val="solid"/>
-          </a:ln>
-        </p:spPr>
-      </p:sp>
-      <p:sp>
-        <p:nvSpPr>
-          <p:cNvPr id="18" name="Shape 15"/>
-          <p:cNvSpPr/>
-          <p:nvPr/>
-        </p:nvSpPr>
-        <p:spPr>
-          <a:xfrm>
-            <a:off x="3291840" y="2788920"/>
-            <a:ext cx="219456" cy="219456"/>
-          </a:xfrm>
-          <a:prstGeom prst="ellipse">
-            <a:avLst/>
-          </a:prstGeom>
-          <a:solidFill>
-            <a:srgbClr val="C8641E"/>
-          </a:solidFill>
-          <a:ln w="15875">
-            <a:solidFill>
-              <a:srgbClr val="C8641E"/>
-            </a:solidFill>
-            <a:prstDash val="solid"/>
-          </a:ln>
-        </p:spPr>
-      </p:sp>
-      <p:sp>
-        <p:nvSpPr>
-          <p:cNvPr id="19" name="Shape 16"/>
-          <p:cNvSpPr/>
-          <p:nvPr/>
-        </p:nvSpPr>
-        <p:spPr>
-          <a:xfrm>
-            <a:off x="3566160" y="2788920"/>
-            <a:ext cx="219456" cy="219456"/>
-          </a:xfrm>
-          <a:prstGeom prst="ellipse">
-            <a:avLst/>
-          </a:prstGeom>
-          <a:solidFill>
-            <a:srgbClr val="C8641E"/>
-          </a:solidFill>
-          <a:ln w="15875">
-            <a:solidFill>
-              <a:srgbClr val="C8641E"/>
-            </a:solidFill>
-            <a:prstDash val="solid"/>
-          </a:ln>
-        </p:spPr>
-      </p:sp>
-      <p:sp>
-        <p:nvSpPr>
-          <p:cNvPr id="20" name="Shape 17"/>
-          <p:cNvSpPr/>
-          <p:nvPr/>
-        </p:nvSpPr>
-        <p:spPr>
-          <a:xfrm>
-            <a:off x="3840480" y="2788920"/>
-            <a:ext cx="219456" cy="219456"/>
-          </a:xfrm>
-          <a:prstGeom prst="ellipse">
-            <a:avLst/>
-          </a:prstGeom>
-          <a:solidFill>
-            <a:srgbClr val="FFFFFF"/>
-          </a:solidFill>
-          <a:ln w="15875">
-            <a:solidFill>
-              <a:srgbClr val="9AA3AE"/>
-            </a:solidFill>
-            <a:prstDash val="solid"/>
-          </a:ln>
-        </p:spPr>
-      </p:sp>
-      <p:sp>
-        <p:nvSpPr>
-          <p:cNvPr id="21" name="Shape 18"/>
-          <p:cNvSpPr/>
-          <p:nvPr/>
-        </p:nvSpPr>
-        <p:spPr>
-          <a:xfrm>
-            <a:off x="3904488" y="3081528"/>
-            <a:ext cx="91440" cy="91440"/>
-          </a:xfrm>
-          <a:prstGeom prst="ellipse">
-            <a:avLst/>
-          </a:prstGeom>
-          <a:solidFill>
-            <a:srgbClr val="2E8B57"/>
-          </a:solidFill>
-          <a:ln w="12700">
-            <a:solidFill>
-              <a:srgbClr val="2E8B57"/>
-            </a:solidFill>
-            <a:prstDash val="solid"/>
-          </a:ln>
-        </p:spPr>
-      </p:sp>
-      <p:sp>
-        <p:nvSpPr>
-          <p:cNvPr id="22" name="Shape 19"/>
-          <p:cNvSpPr/>
-          <p:nvPr/>
-        </p:nvSpPr>
-        <p:spPr>
-          <a:xfrm>
-            <a:off x="4114800" y="2788920"/>
-            <a:ext cx="219456" cy="219456"/>
-          </a:xfrm>
-          <a:prstGeom prst="ellipse">
-            <a:avLst/>
-          </a:prstGeom>
-          <a:solidFill>
-            <a:srgbClr val="FFFFFF"/>
-          </a:solidFill>
-          <a:ln w="15875">
-            <a:solidFill>
-              <a:srgbClr val="9AA3AE"/>
-            </a:solidFill>
-            <a:prstDash val="solid"/>
-          </a:ln>
-        </p:spPr>
-      </p:sp>
-      <p:sp>
-        <p:nvSpPr>
-          <p:cNvPr id="23" name="Shape 20"/>
-          <p:cNvSpPr/>
-          <p:nvPr/>
-        </p:nvSpPr>
-        <p:spPr>
-          <a:xfrm>
-            <a:off x="4178808" y="3081528"/>
-            <a:ext cx="91440" cy="91440"/>
-          </a:xfrm>
-          <a:prstGeom prst="ellipse">
-            <a:avLst/>
-          </a:prstGeom>
-          <a:solidFill>
-            <a:srgbClr val="2E8B57"/>
-          </a:solidFill>
-          <a:ln w="12700">
-            <a:solidFill>
-              <a:srgbClr val="2E8B57"/>
-            </a:solidFill>
-            <a:prstDash val="solid"/>
-          </a:ln>
-        </p:spPr>
-      </p:sp>
-      <p:sp>
-        <p:nvSpPr>
-          <p:cNvPr id="24" name="Shape 21"/>
-          <p:cNvSpPr/>
-          <p:nvPr/>
-        </p:nvSpPr>
-        <p:spPr>
-          <a:xfrm>
-            <a:off x="4389120" y="2788920"/>
-            <a:ext cx="219456" cy="219456"/>
-          </a:xfrm>
-          <a:prstGeom prst="ellipse">
-            <a:avLst/>
-          </a:prstGeom>
-          <a:solidFill>
-            <a:srgbClr val="C8641E"/>
-          </a:solidFill>
-          <a:ln w="15875">
-            <a:solidFill>
-              <a:srgbClr val="C8641E"/>
-            </a:solidFill>
-            <a:prstDash val="solid"/>
-          </a:ln>
-        </p:spPr>
-      </p:sp>
-      <p:sp>
-        <p:nvSpPr>
-          <p:cNvPr id="25" name="Text 22"/>
-          <p:cNvSpPr txBox="1"/>
-          <p:nvPr/>
-        </p:nvSpPr>
-        <p:spPr>
-          <a:xfrm>
-            <a:off x="1371600" y="3200400"/>
-            <a:ext cx="3200400" cy="274320"/>
-          </a:xfrm>
-          <a:prstGeom prst="rect">
-            <a:avLst/>
-          </a:prstGeom>
-          <a:noFill/>
-          <a:ln/>
-        </p:spPr>
-        <p:txBody>
-          <a:bodyPr wrap="square" lIns="0" tIns="0" rIns="0" bIns="0" rtlCol="0" anchor="t"/>
-          <a:lstStyle/>
-          <a:p>
-            <a:pPr algn="l" indent="0" marL="0">
-              <a:buNone/>
-            </a:pPr>
-            <a:r>
-              <a:rPr lang="en-US" sz="1000" dirty="0">
-                <a:solidFill>
-                  <a:srgbClr val="5F6B7A"/>
-                </a:solidFill>
-                <a:latin typeface="Arial" pitchFamily="34" charset="0"/>
-                <a:ea typeface="Arial" pitchFamily="34" charset="-122"/>
-                <a:cs typeface="Arial" pitchFamily="34" charset="-120"/>
-              </a:rPr>
-              <a:t>hollow = call skipped, green = every gate passed</a:t>
-            </a:r>
-            <a:endParaRPr lang="en-US" sz="1000" dirty="0"/>
-          </a:p>
-        </p:txBody>
-      </p:sp>
-      <p:sp>
-        <p:nvSpPr>
-          <p:cNvPr id="26" name="Text 23"/>
-          <p:cNvSpPr txBox="1"/>
-          <p:nvPr/>
-        </p:nvSpPr>
-        <p:spPr>
-          <a:xfrm>
-            <a:off x="457200" y="3520440"/>
-            <a:ext cx="4023360" cy="1280160"/>
-          </a:xfrm>
-          <a:prstGeom prst="rect">
-            <a:avLst/>
-          </a:prstGeom>
-          <a:noFill/>
-          <a:ln/>
-        </p:spPr>
-        <p:txBody>
           <a:bodyPr wrap="square" lIns="0" tIns="0" rIns="0" bIns="0" rtlCol="0" anchor="t"/>
           <a:lstStyle/>
           <a:p>
             <a:pPr marL="177800" indent="-177800">
               <a:spcAft>
-                <a:spcPts val="400"/>
+                <a:spcPts val="300"/>
               </a:spcAft>
               <a:buSzPct val="100000"/>
               <a:buChar char="•"/>
             </a:pPr>
             <a:r>
-              <a:rPr lang="en-US" sz="1150" dirty="0">
+              <a:rPr lang="en-US" sz="1100" dirty="0">
                 <a:solidFill>
                   <a:srgbClr val="1F2933"/>
                 </a:solidFill>
@@ -9516,18 +8089,18 @@
               </a:rPr>
               <a:t>Reuse the previous action only when all gates pass: small global and local image change, recent actions agree, translation not near zero, gripper unchanged, reuse count below a cap</a:t>
             </a:r>
-            <a:endParaRPr lang="en-US" sz="1150" dirty="0"/>
+            <a:endParaRPr lang="en-US" sz="1100" dirty="0"/>
           </a:p>
           <a:p>
             <a:pPr marL="177800" indent="-177800">
               <a:spcAft>
-                <a:spcPts val="400"/>
+                <a:spcPts val="300"/>
               </a:spcAft>
               <a:buSzPct val="100000"/>
               <a:buChar char="•"/>
             </a:pPr>
             <a:r>
-              <a:rPr lang="en-US" sz="1150" dirty="0">
+              <a:rPr lang="en-US" sz="1100" dirty="0">
                 <a:solidFill>
                   <a:srgbClr val="1F2933"/>
                 </a:solidFill>
@@ -9537,13 +8110,13 @@
               </a:rPr>
               <a:t>Presets: strict, moderate, aggressive</a:t>
             </a:r>
-            <a:endParaRPr lang="en-US" sz="1150" dirty="0"/>
-          </a:p>
-        </p:txBody>
-      </p:sp>
-      <p:sp>
-        <p:nvSpPr>
-          <p:cNvPr id="27" name="Shape 24"/>
+            <a:endParaRPr lang="en-US" sz="1100" dirty="0"/>
+          </a:p>
+        </p:txBody>
+      </p:sp>
+      <p:sp>
+        <p:nvSpPr>
+          <p:cNvPr id="8" name="Shape 5"/>
           <p:cNvSpPr/>
           <p:nvPr/>
         </p:nvSpPr>
@@ -9570,7 +8143,7 @@
       </p:sp>
       <p:sp>
         <p:nvSpPr>
-          <p:cNvPr id="28" name="Shape 25"/>
+          <p:cNvPr id="9" name="Shape 6"/>
           <p:cNvSpPr/>
           <p:nvPr/>
         </p:nvSpPr>
@@ -9595,7 +8168,7 @@
       </p:sp>
       <p:sp>
         <p:nvSpPr>
-          <p:cNvPr id="29" name="Shape 26"/>
+          <p:cNvPr id="10" name="Shape 7"/>
           <p:cNvSpPr/>
           <p:nvPr/>
         </p:nvSpPr>
@@ -9620,7 +8193,7 @@
       </p:sp>
       <p:sp>
         <p:nvSpPr>
-          <p:cNvPr id="30" name="Text 27"/>
+          <p:cNvPr id="11" name="Text 8"/>
           <p:cNvSpPr txBox="1"/>
           <p:nvPr/>
         </p:nvSpPr>
@@ -9659,7 +8232,7 @@
       </p:sp>
       <p:sp>
         <p:nvSpPr>
-          <p:cNvPr id="31" name="Text 28"/>
+          <p:cNvPr id="12" name="Text 9"/>
           <p:cNvSpPr txBox="1"/>
           <p:nvPr/>
         </p:nvSpPr>
@@ -9698,7 +8271,7 @@
       </p:sp>
       <p:sp>
         <p:nvSpPr>
-          <p:cNvPr id="32" name="Text 29"/>
+          <p:cNvPr id="13" name="Text 10"/>
           <p:cNvSpPr txBox="1"/>
           <p:nvPr/>
         </p:nvSpPr>
@@ -9913,7 +8486,7 @@
       </p:sp>
       <p:pic>
         <p:nvPicPr>
-          <p:cNvPr id="6" name="Image 0" descr="/tmp/claude-0/-home-user-BiVLA/4327cefa-ba5d-5e2e-9d87-c73dd3a8ccbb/scratchpad/video_ppt/assets/ov_fusion.png">    </p:cNvPr>
+          <p:cNvPr id="6" name="Image 0" descr="/tmp/claude-0/-home-user-BiVLA/4327cefa-ba5d-5e2e-9d87-c73dd3a8ccbb/scratchpad/video_ppt/assets/m_fusion.png">    </p:cNvPr>
           <p:cNvPicPr>
             <a:picLocks noChangeAspect="1"/>
           </p:cNvPicPr>
@@ -9928,7 +8501,7 @@
         <p:spPr>
           <a:xfrm>
             <a:off x="457200" y="960120"/>
-            <a:ext cx="3931920" cy="1618488"/>
+            <a:ext cx="2331720" cy="1911096"/>
           </a:xfrm>
           <a:prstGeom prst="rect">
             <a:avLst/>
@@ -9943,8 +8516,8 @@
         </p:nvSpPr>
         <p:spPr>
           <a:xfrm>
-            <a:off x="457200" y="2788920"/>
-            <a:ext cx="4023360" cy="1920240"/>
+            <a:off x="2926080" y="960120"/>
+            <a:ext cx="1554480" cy="3291840"/>
           </a:xfrm>
           <a:prstGeom prst="rect">
             <a:avLst/>
@@ -9964,7 +8537,7 @@
               <a:buChar char="•"/>
             </a:pPr>
             <a:r>
-              <a:rPr lang="en-US" sz="1150" dirty="0">
+              <a:rPr lang="en-US" sz="1050" dirty="0">
                 <a:solidFill>
                   <a:srgbClr val="1F2933"/>
                 </a:solidFill>
@@ -9974,7 +8547,7 @@
               </a:rPr>
               <a:t>Reuse projected visual tokens of temporally stable patches from the previous call</a:t>
             </a:r>
-            <a:endParaRPr lang="en-US" sz="1150" dirty="0"/>
+            <a:endParaRPr lang="en-US" sz="1050" dirty="0"/>
           </a:p>
           <a:p>
             <a:pPr marL="177800" indent="-177800">
@@ -9985,7 +8558,7 @@
               <a:buChar char="•"/>
             </a:pPr>
             <a:r>
-              <a:rPr lang="en-US" sz="1150" dirty="0">
+              <a:rPr lang="en-US" sz="1050" dirty="0">
                 <a:solidFill>
                   <a:srgbClr val="1F2933"/>
                 </a:solidFill>
@@ -9995,7 +8568,7 @@
               </a:rPr>
               <a:t>Protect patches with motion, high entropy, high language attention, or interaction regions; recompute those</a:t>
             </a:r>
-            <a:endParaRPr lang="en-US" sz="1150" dirty="0"/>
+            <a:endParaRPr lang="en-US" sz="1050" dirty="0"/>
           </a:p>
           <a:p>
             <a:pPr marL="177800" indent="-177800">
@@ -10006,7 +8579,7 @@
               <a:buChar char="•"/>
             </a:pPr>
             <a:r>
-              <a:rPr lang="en-US" sz="1150" dirty="0">
+              <a:rPr lang="en-US" sz="1050" dirty="0">
                 <a:solidFill>
                   <a:srgbClr val="1F2933"/>
                 </a:solidFill>
@@ -10016,7 +8589,7 @@
               </a:rPr>
               <a:t>The same reuse mask is shared with the generation cache</a:t>
             </a:r>
-            <a:endParaRPr lang="en-US" sz="1150" dirty="0"/>
+            <a:endParaRPr lang="en-US" sz="1050" dirty="0"/>
           </a:p>
           <a:p>
             <a:pPr marL="177800" indent="-177800">
@@ -10027,7 +8600,7 @@
               <a:buChar char="•"/>
             </a:pPr>
             <a:r>
-              <a:rPr lang="en-US" sz="1150" dirty="0">
+              <a:rPr lang="en-US" sz="1050" dirty="0">
                 <a:solidFill>
                   <a:srgbClr val="1F2933"/>
                 </a:solidFill>
@@ -10037,13 +8610,76 @@
               </a:rPr>
               <a:t>Presets: motion-entropy, task-aware, conservative-adaptive</a:t>
             </a:r>
-            <a:endParaRPr lang="en-US" sz="1150" dirty="0"/>
-          </a:p>
-        </p:txBody>
-      </p:sp>
-      <p:sp>
-        <p:nvSpPr>
-          <p:cNvPr id="8" name="Shape 5"/>
+            <a:endParaRPr lang="en-US" sz="1050" dirty="0"/>
+          </a:p>
+        </p:txBody>
+      </p:sp>
+      <p:pic>
+        <p:nvPicPr>
+          <p:cNvPr id="8" name="Image 1" descr="/tmp/claude-0/-home-user-BiVLA/4327cefa-ba5d-5e2e-9d87-c73dd3a8ccbb/scratchpad/video_ppt/assets/m_cache.png">    </p:cNvPr>
+          <p:cNvPicPr>
+            <a:picLocks noChangeAspect="1"/>
+          </p:cNvPicPr>
+          <p:nvPr/>
+        </p:nvPicPr>
+        <p:blipFill>
+          <a:blip r:embed="rId2"/>
+          <a:stretch>
+            <a:fillRect/>
+          </a:stretch>
+        </p:blipFill>
+        <p:spPr>
+          <a:xfrm>
+            <a:off x="457200" y="3017520"/>
+            <a:ext cx="2331720" cy="1417320"/>
+          </a:xfrm>
+          <a:prstGeom prst="rect">
+            <a:avLst/>
+          </a:prstGeom>
+        </p:spPr>
+      </p:pic>
+      <p:sp>
+        <p:nvSpPr>
+          <p:cNvPr id="9" name="Text 5"/>
+          <p:cNvSpPr txBox="1"/>
+          <p:nvPr/>
+        </p:nvSpPr>
+        <p:spPr>
+          <a:xfrm>
+            <a:off x="457200" y="4480560"/>
+            <a:ext cx="2377440" cy="365760"/>
+          </a:xfrm>
+          <a:prstGeom prst="rect">
+            <a:avLst/>
+          </a:prstGeom>
+          <a:noFill/>
+          <a:ln/>
+        </p:spPr>
+        <p:txBody>
+          <a:bodyPr wrap="square" lIns="0" tIns="0" rIns="0" bIns="0" rtlCol="0" anchor="t"/>
+          <a:lstStyle/>
+          <a:p>
+            <a:pPr algn="l" indent="0" marL="0">
+              <a:buNone/>
+            </a:pPr>
+            <a:r>
+              <a:rPr lang="en-US" sz="950" dirty="0">
+                <a:solidFill>
+                  <a:srgbClr val="5F6B7A"/>
+                </a:solidFill>
+                <a:latin typeface="Arial" pitchFamily="34" charset="0"/>
+                <a:ea typeface="Arial" pitchFamily="34" charset="-122"/>
+                <a:cs typeface="Arial" pitchFamily="34" charset="-120"/>
+              </a:rPr>
+              <a:t>Top: fusion mask. Bottom: VLA-Cache criterion (stable, task-irrelevant patches reused).</a:t>
+            </a:r>
+            <a:endParaRPr lang="en-US" sz="950" dirty="0"/>
+          </a:p>
+        </p:txBody>
+      </p:sp>
+      <p:sp>
+        <p:nvSpPr>
+          <p:cNvPr id="10" name="Shape 6"/>
           <p:cNvSpPr/>
           <p:nvPr/>
         </p:nvSpPr>
@@ -10070,7 +8706,7 @@
       </p:sp>
       <p:sp>
         <p:nvSpPr>
-          <p:cNvPr id="9" name="Shape 6"/>
+          <p:cNvPr id="11" name="Shape 7"/>
           <p:cNvSpPr/>
           <p:nvPr/>
         </p:nvSpPr>
@@ -10095,7 +8731,7 @@
       </p:sp>
       <p:sp>
         <p:nvSpPr>
-          <p:cNvPr id="10" name="Shape 7"/>
+          <p:cNvPr id="12" name="Shape 8"/>
           <p:cNvSpPr/>
           <p:nvPr/>
         </p:nvSpPr>
@@ -10120,7 +8756,7 @@
       </p:sp>
       <p:sp>
         <p:nvSpPr>
-          <p:cNvPr id="11" name="Text 8"/>
+          <p:cNvPr id="13" name="Text 9"/>
           <p:cNvSpPr txBox="1"/>
           <p:nvPr/>
         </p:nvSpPr>
@@ -10159,7 +8795,7 @@
       </p:sp>
       <p:sp>
         <p:nvSpPr>
-          <p:cNvPr id="12" name="Text 9"/>
+          <p:cNvPr id="14" name="Text 10"/>
           <p:cNvSpPr txBox="1"/>
           <p:nvPr/>
         </p:nvSpPr>
@@ -10198,7 +8834,7 @@
       </p:sp>
       <p:sp>
         <p:nvSpPr>
-          <p:cNvPr id="13" name="Text 10"/>
+          <p:cNvPr id="15" name="Text 11"/>
           <p:cNvSpPr txBox="1"/>
           <p:nvPr/>
         </p:nvSpPr>

</xml_diff>

<commit_message>
Video deck: clean Fig. 2 panel crops with uniform margins, drop the header tag
Co-Authored-By: Claude Fable 5.1 <noreply@anthropic.com>
Claude-Session: https://claude.ai/code/session_011USoCwMtkSq1wKhwTPjNT9
</commit_message>
<xml_diff>
--- a/experiments/paper/video/ICRA27_video_v2.pptx
+++ b/experiments/paper/video/ICRA27_video_v2.pptx
@@ -2160,7 +2160,7 @@
                 <a:ea typeface="Arial" pitchFamily="34" charset="-122"/>
                 <a:cs typeface="Arial" pitchFamily="34" charset="-120"/>
               </a:rPr>
-              <a:t>Bag of Tricks for Training-Free Vision-Language-Action Models  ·  anonymous submission</a:t>
+              <a:t>Bag of Tricks for Training-Free Vision-Language-Action Models</a:t>
             </a:r>
             <a:endParaRPr lang="en-US" sz="1000" dirty="0"/>
           </a:p>
@@ -2235,8 +2235,8 @@
         </p:blipFill>
         <p:spPr>
           <a:xfrm>
-            <a:off x="457200" y="1051560"/>
-            <a:ext cx="8229600" cy="402336"/>
+            <a:off x="457200" y="1005840"/>
+            <a:ext cx="8229600" cy="429768"/>
           </a:xfrm>
           <a:prstGeom prst="rect">
             <a:avLst/>
@@ -6585,7 +6585,7 @@
         <p:spPr>
           <a:xfrm>
             <a:off x="457200" y="960120"/>
-            <a:ext cx="3931920" cy="2468880"/>
+            <a:ext cx="3931920" cy="2487168"/>
           </a:xfrm>
           <a:prstGeom prst="rect">
             <a:avLst/>
@@ -7064,7 +7064,7 @@
         <p:spPr>
           <a:xfrm>
             <a:off x="457200" y="960120"/>
-            <a:ext cx="3931920" cy="2679192"/>
+            <a:ext cx="3931920" cy="2724912"/>
           </a:xfrm>
           <a:prstGeom prst="rect">
             <a:avLst/>
@@ -7543,7 +7543,7 @@
         <p:spPr>
           <a:xfrm>
             <a:off x="457200" y="960120"/>
-            <a:ext cx="2514600" cy="2542032"/>
+            <a:ext cx="2514600" cy="2587752"/>
           </a:xfrm>
           <a:prstGeom prst="rect">
             <a:avLst/>
@@ -8501,7 +8501,7 @@
         <p:spPr>
           <a:xfrm>
             <a:off x="457200" y="960120"/>
-            <a:ext cx="2331720" cy="1911096"/>
+            <a:ext cx="2331720" cy="1901952"/>
           </a:xfrm>
           <a:prstGeom prst="rect">
             <a:avLst/>
@@ -8630,8 +8630,8 @@
         </p:blipFill>
         <p:spPr>
           <a:xfrm>
-            <a:off x="457200" y="3017520"/>
-            <a:ext cx="2331720" cy="1417320"/>
+            <a:off x="457200" y="2971800"/>
+            <a:ext cx="2331720" cy="1426464"/>
           </a:xfrm>
           <a:prstGeom prst="rect">
             <a:avLst/>

</xml_diff>

<commit_message>
Video deck: shorter depth-pruning and temporal-fusion bullets, no per-slide time tags
Co-Authored-By: Claude Fable 5.1 <noreply@anthropic.com>
Claude-Session: https://claude.ai/code/session_011USoCwMtkSq1wKhwTPjNT9
</commit_message>
<xml_diff>
--- a/experiments/paper/video/ICRA27_video_v2.pptx
+++ b/experiments/paper/video/ICRA27_video_v2.pptx
@@ -2096,8 +2096,8 @@
         </p:nvSpPr>
         <p:spPr>
           <a:xfrm>
-            <a:off x="7680960" y="73152"/>
-            <a:ext cx="1280160" cy="228600"/>
+            <a:off x="457200" y="109728"/>
+            <a:ext cx="7132320" cy="274320"/>
           </a:xfrm>
           <a:prstGeom prst="rect">
             <a:avLst/>
@@ -2106,14 +2106,14 @@
           <a:ln/>
         </p:spPr>
         <p:txBody>
-          <a:bodyPr wrap="square" lIns="0" tIns="0" rIns="0" bIns="0" rtlCol="0" anchor="ctr"/>
-          <a:lstStyle/>
-          <a:p>
-            <a:pPr algn="r" indent="0" marL="0">
+          <a:bodyPr wrap="square" lIns="0" tIns="0" rIns="0" bIns="0" rtlCol="0" anchor="t"/>
+          <a:lstStyle/>
+          <a:p>
+            <a:pPr algn="l" indent="0" marL="0">
               <a:buNone/>
             </a:pPr>
             <a:r>
-              <a:rPr lang="en-US" sz="900" dirty="0">
+              <a:rPr lang="en-US" sz="1000" dirty="0">
                 <a:solidFill>
                   <a:srgbClr val="5F6B7A"/>
                 </a:solidFill>
@@ -2121,9 +2121,9 @@
                 <a:ea typeface="Arial" pitchFamily="34" charset="-122"/>
                 <a:cs typeface="Arial" pitchFamily="34" charset="-120"/>
               </a:rPr>
-              <a:t>1  ·  15s</a:t>
-            </a:r>
-            <a:endParaRPr lang="en-US" sz="900" dirty="0"/>
+              <a:t>Bag of Tricks for Training-Free Vision-Language-Action Models</a:t>
+            </a:r>
+            <a:endParaRPr lang="en-US" sz="1000" dirty="0"/>
           </a:p>
         </p:txBody>
       </p:sp>
@@ -2135,8 +2135,8 @@
         </p:nvSpPr>
         <p:spPr>
           <a:xfrm>
-            <a:off x="457200" y="109728"/>
-            <a:ext cx="7132320" cy="274320"/>
+            <a:off x="457200" y="292608"/>
+            <a:ext cx="8229600" cy="640080"/>
           </a:xfrm>
           <a:prstGeom prst="rect">
             <a:avLst/>
@@ -2145,45 +2145,6 @@
           <a:ln/>
         </p:spPr>
         <p:txBody>
-          <a:bodyPr wrap="square" lIns="0" tIns="0" rIns="0" bIns="0" rtlCol="0" anchor="t"/>
-          <a:lstStyle/>
-          <a:p>
-            <a:pPr algn="l" indent="0" marL="0">
-              <a:buNone/>
-            </a:pPr>
-            <a:r>
-              <a:rPr lang="en-US" sz="1000" dirty="0">
-                <a:solidFill>
-                  <a:srgbClr val="5F6B7A"/>
-                </a:solidFill>
-                <a:latin typeface="Arial" pitchFamily="34" charset="0"/>
-                <a:ea typeface="Arial" pitchFamily="34" charset="-122"/>
-                <a:cs typeface="Arial" pitchFamily="34" charset="-120"/>
-              </a:rPr>
-              <a:t>Bag of Tricks for Training-Free Vision-Language-Action Models</a:t>
-            </a:r>
-            <a:endParaRPr lang="en-US" sz="1000" dirty="0"/>
-          </a:p>
-        </p:txBody>
-      </p:sp>
-      <p:sp>
-        <p:nvSpPr>
-          <p:cNvPr id="4" name="Text 2"/>
-          <p:cNvSpPr txBox="1"/>
-          <p:nvPr/>
-        </p:nvSpPr>
-        <p:spPr>
-          <a:xfrm>
-            <a:off x="457200" y="292608"/>
-            <a:ext cx="8229600" cy="640080"/>
-          </a:xfrm>
-          <a:prstGeom prst="rect">
-            <a:avLst/>
-          </a:prstGeom>
-          <a:noFill/>
-          <a:ln/>
-        </p:spPr>
-        <p:txBody>
           <a:bodyPr wrap="square" lIns="0" tIns="0" rIns="0" bIns="0" rtlCol="0" anchor="ctr"/>
           <a:lstStyle/>
           <a:p>
@@ -2221,7 +2182,7 @@
       </p:sp>
       <p:pic>
         <p:nvPicPr>
-          <p:cNvPr id="5" name="Image 0" descr="/tmp/claude-0/-home-user-BiVLA/4327cefa-ba5d-5e2e-9d87-c73dd3a8ccbb/scratchpad/video_ppt/assets/m_pipeline.png">    </p:cNvPr>
+          <p:cNvPr id="4" name="Image 0" descr="/tmp/claude-0/-home-user-BiVLA/4327cefa-ba5d-5e2e-9d87-c73dd3a8ccbb/scratchpad/video_ppt/assets/m_pipeline.png">    </p:cNvPr>
           <p:cNvPicPr>
             <a:picLocks noChangeAspect="1"/>
           </p:cNvPicPr>
@@ -2245,14 +2206,53 @@
       </p:pic>
       <p:sp>
         <p:nvSpPr>
+          <p:cNvPr id="5" name="Text 2"/>
+          <p:cNvSpPr txBox="1"/>
+          <p:nvPr/>
+        </p:nvSpPr>
+        <p:spPr>
+          <a:xfrm>
+            <a:off x="457200" y="1554480"/>
+            <a:ext cx="8229600" cy="365760"/>
+          </a:xfrm>
+          <a:prstGeom prst="rect">
+            <a:avLst/>
+          </a:prstGeom>
+          <a:noFill/>
+          <a:ln/>
+        </p:spPr>
+        <p:txBody>
+          <a:bodyPr wrap="square" lIns="0" tIns="0" rIns="0" bIns="0" rtlCol="0" anchor="t"/>
+          <a:lstStyle/>
+          <a:p>
+            <a:pPr algn="l" indent="0" marL="0">
+              <a:buNone/>
+            </a:pPr>
+            <a:r>
+              <a:rPr lang="en-US" sz="1100" dirty="0">
+                <a:solidFill>
+                  <a:srgbClr val="5F6B7A"/>
+                </a:solidFill>
+                <a:latin typeface="Arial" pitchFamily="34" charset="0"/>
+                <a:ea typeface="Arial" pitchFamily="34" charset="-122"/>
+                <a:cs typeface="Arial" pitchFamily="34" charset="-120"/>
+              </a:rPr>
+              <a:t>The control loop of a frozen VLA policy (Fig. 2 of the paper). Coloured boxes are where the five tricks enter; the visual encoder and the action decoder run at every step.</a:t>
+            </a:r>
+            <a:endParaRPr lang="en-US" sz="1100" dirty="0"/>
+          </a:p>
+        </p:txBody>
+      </p:sp>
+      <p:sp>
+        <p:nvSpPr>
           <p:cNvPr id="6" name="Text 3"/>
           <p:cNvSpPr txBox="1"/>
           <p:nvPr/>
         </p:nvSpPr>
         <p:spPr>
           <a:xfrm>
-            <a:off x="457200" y="1554480"/>
-            <a:ext cx="8229600" cy="365760"/>
+            <a:off x="457200" y="2240280"/>
+            <a:ext cx="8229600" cy="457200"/>
           </a:xfrm>
           <a:prstGeom prst="rect">
             <a:avLst/>
@@ -2261,24 +2261,52 @@
           <a:ln/>
         </p:spPr>
         <p:txBody>
-          <a:bodyPr wrap="square" lIns="0" tIns="0" rIns="0" bIns="0" rtlCol="0" anchor="t"/>
-          <a:lstStyle/>
-          <a:p>
-            <a:pPr algn="l" indent="0" marL="0">
+          <a:bodyPr wrap="square" lIns="0" tIns="0" rIns="0" bIns="0" rtlCol="0" anchor="ctr"/>
+          <a:lstStyle/>
+          <a:p>
+            <a:pPr indent="0" marL="0">
               <a:buNone/>
             </a:pPr>
             <a:r>
-              <a:rPr lang="en-US" sz="1100" dirty="0">
-                <a:solidFill>
-                  <a:srgbClr val="5F6B7A"/>
-                </a:solidFill>
-                <a:latin typeface="Arial" pitchFamily="34" charset="0"/>
-                <a:ea typeface="Arial" pitchFamily="34" charset="-122"/>
-                <a:cs typeface="Arial" pitchFamily="34" charset="-120"/>
-              </a:rPr>
-              <a:t>The control loop of a frozen VLA policy (Fig. 2 of the paper). Coloured boxes are where the five tricks enter; the visual encoder and the action decoder run at every step.</a:t>
-            </a:r>
-            <a:endParaRPr lang="en-US" sz="1100" dirty="0"/>
+              <a:rPr lang="en-US" sz="1400" b="1" dirty="0">
+                <a:solidFill>
+                  <a:srgbClr val="C00000"/>
+                </a:solidFill>
+                <a:latin typeface="Arial" pitchFamily="34" charset="0"/>
+                <a:ea typeface="Arial" pitchFamily="34" charset="-122"/>
+                <a:cs typeface="Arial" pitchFamily="34" charset="-120"/>
+              </a:rPr>
+              <a:t>[1] </a:t>
+            </a:r>
+            <a:pPr indent="0" marL="0">
+              <a:buNone/>
+            </a:pPr>
+            <a:r>
+              <a:rPr lang="en-US" sz="1400" b="1" dirty="0">
+                <a:solidFill>
+                  <a:srgbClr val="C00000"/>
+                </a:solidFill>
+                <a:latin typeface="Arial" pitchFamily="34" charset="0"/>
+                <a:ea typeface="Arial" pitchFamily="34" charset="-122"/>
+                <a:cs typeface="Arial" pitchFamily="34" charset="-120"/>
+              </a:rPr>
+              <a:t>VLA inference is slow. </a:t>
+            </a:r>
+            <a:pPr indent="0" marL="0">
+              <a:buNone/>
+            </a:pPr>
+            <a:r>
+              <a:rPr lang="en-US" sz="1400" dirty="0">
+                <a:solidFill>
+                  <a:srgbClr val="1F2933"/>
+                </a:solidFill>
+                <a:latin typeface="Arial" pitchFamily="34" charset="0"/>
+                <a:ea typeface="Arial" pitchFamily="34" charset="-122"/>
+                <a:cs typeface="Arial" pitchFamily="34" charset="-120"/>
+              </a:rPr>
+              <a:t>Hundreds of milliseconds per step, which limits how often the policy can observe, decide, and correct.</a:t>
+            </a:r>
+            <a:endParaRPr lang="en-US" sz="1400" dirty="0"/>
           </a:p>
         </p:txBody>
       </p:sp>
@@ -2290,8 +2318,8 @@
         </p:nvSpPr>
         <p:spPr>
           <a:xfrm>
-            <a:off x="457200" y="2240280"/>
-            <a:ext cx="8229600" cy="457200"/>
+            <a:off x="457200" y="2834640"/>
+            <a:ext cx="8229600" cy="548640"/>
           </a:xfrm>
           <a:prstGeom prst="rect">
             <a:avLst/>
@@ -2315,7 +2343,7 @@
                 <a:ea typeface="Arial" pitchFamily="34" charset="-122"/>
                 <a:cs typeface="Arial" pitchFamily="34" charset="-120"/>
               </a:rPr>
-              <a:t>[1] </a:t>
+              <a:t>[2] </a:t>
             </a:r>
             <a:pPr indent="0" marL="0">
               <a:buNone/>
@@ -2329,7 +2357,7 @@
                 <a:ea typeface="Arial" pitchFamily="34" charset="-122"/>
                 <a:cs typeface="Arial" pitchFamily="34" charset="-120"/>
               </a:rPr>
-              <a:t>VLA inference is slow. </a:t>
+              <a:t>Training-free tricks are reported one at a time. </a:t>
             </a:r>
             <a:pPr indent="0" marL="0">
               <a:buNone/>
@@ -2343,7 +2371,7 @@
                 <a:ea typeface="Arial" pitchFamily="34" charset="-122"/>
                 <a:cs typeface="Arial" pitchFamily="34" charset="-120"/>
               </a:rPr>
-              <a:t>Hundreds of milliseconds per step, which limits how often the policy can observe, decide, and correct.</a:t>
+              <a:t>Foveation, action repeat, depth pruning, guarded reuse, temporal fusion: each on one backbone, one benchmark, one implementation.</a:t>
             </a:r>
             <a:endParaRPr lang="en-US" sz="1400" dirty="0"/>
           </a:p>
@@ -2351,74 +2379,7 @@
       </p:sp>
       <p:sp>
         <p:nvSpPr>
-          <p:cNvPr id="8" name="Text 5"/>
-          <p:cNvSpPr txBox="1"/>
-          <p:nvPr/>
-        </p:nvSpPr>
-        <p:spPr>
-          <a:xfrm>
-            <a:off x="457200" y="2834640"/>
-            <a:ext cx="8229600" cy="548640"/>
-          </a:xfrm>
-          <a:prstGeom prst="rect">
-            <a:avLst/>
-          </a:prstGeom>
-          <a:noFill/>
-          <a:ln/>
-        </p:spPr>
-        <p:txBody>
-          <a:bodyPr wrap="square" lIns="0" tIns="0" rIns="0" bIns="0" rtlCol="0" anchor="ctr"/>
-          <a:lstStyle/>
-          <a:p>
-            <a:pPr indent="0" marL="0">
-              <a:buNone/>
-            </a:pPr>
-            <a:r>
-              <a:rPr lang="en-US" sz="1400" b="1" dirty="0">
-                <a:solidFill>
-                  <a:srgbClr val="C00000"/>
-                </a:solidFill>
-                <a:latin typeface="Arial" pitchFamily="34" charset="0"/>
-                <a:ea typeface="Arial" pitchFamily="34" charset="-122"/>
-                <a:cs typeface="Arial" pitchFamily="34" charset="-120"/>
-              </a:rPr>
-              <a:t>[2] </a:t>
-            </a:r>
-            <a:pPr indent="0" marL="0">
-              <a:buNone/>
-            </a:pPr>
-            <a:r>
-              <a:rPr lang="en-US" sz="1400" b="1" dirty="0">
-                <a:solidFill>
-                  <a:srgbClr val="C00000"/>
-                </a:solidFill>
-                <a:latin typeface="Arial" pitchFamily="34" charset="0"/>
-                <a:ea typeface="Arial" pitchFamily="34" charset="-122"/>
-                <a:cs typeface="Arial" pitchFamily="34" charset="-120"/>
-              </a:rPr>
-              <a:t>Training-free tricks are reported one at a time. </a:t>
-            </a:r>
-            <a:pPr indent="0" marL="0">
-              <a:buNone/>
-            </a:pPr>
-            <a:r>
-              <a:rPr lang="en-US" sz="1400" dirty="0">
-                <a:solidFill>
-                  <a:srgbClr val="1F2933"/>
-                </a:solidFill>
-                <a:latin typeface="Arial" pitchFamily="34" charset="0"/>
-                <a:ea typeface="Arial" pitchFamily="34" charset="-122"/>
-                <a:cs typeface="Arial" pitchFamily="34" charset="-120"/>
-              </a:rPr>
-              <a:t>Foveation, action repeat, depth pruning, guarded reuse, temporal fusion: each on one backbone, one benchmark, one implementation.</a:t>
-            </a:r>
-            <a:endParaRPr lang="en-US" sz="1400" dirty="0"/>
-          </a:p>
-        </p:txBody>
-      </p:sp>
-      <p:sp>
-        <p:nvSpPr>
-          <p:cNvPr id="9" name="Shape 6"/>
+          <p:cNvPr id="8" name="Shape 5"/>
           <p:cNvSpPr/>
           <p:nvPr/>
         </p:nvSpPr>
@@ -2445,7 +2406,7 @@
       </p:sp>
       <p:sp>
         <p:nvSpPr>
-          <p:cNvPr id="10" name="Text 7"/>
+          <p:cNvPr id="9" name="Text 6"/>
           <p:cNvSpPr txBox="1"/>
           <p:nvPr/>
         </p:nvSpPr>
@@ -2536,8 +2497,8 @@
         </p:nvSpPr>
         <p:spPr>
           <a:xfrm>
-            <a:off x="7680960" y="73152"/>
-            <a:ext cx="1280160" cy="228600"/>
+            <a:off x="457200" y="292608"/>
+            <a:ext cx="8229600" cy="640080"/>
           </a:xfrm>
           <a:prstGeom prst="rect">
             <a:avLst/>
@@ -2549,45 +2510,6 @@
           <a:bodyPr wrap="square" lIns="0" tIns="0" rIns="0" bIns="0" rtlCol="0" anchor="ctr"/>
           <a:lstStyle/>
           <a:p>
-            <a:pPr algn="r" indent="0" marL="0">
-              <a:buNone/>
-            </a:pPr>
-            <a:r>
-              <a:rPr lang="en-US" sz="900" dirty="0">
-                <a:solidFill>
-                  <a:srgbClr val="5F6B7A"/>
-                </a:solidFill>
-                <a:latin typeface="Arial" pitchFamily="34" charset="0"/>
-                <a:ea typeface="Arial" pitchFamily="34" charset="-122"/>
-                <a:cs typeface="Arial" pitchFamily="34" charset="-120"/>
-              </a:rPr>
-              <a:t>10  ·  10s</a:t>
-            </a:r>
-            <a:endParaRPr lang="en-US" sz="900" dirty="0"/>
-          </a:p>
-        </p:txBody>
-      </p:sp>
-      <p:sp>
-        <p:nvSpPr>
-          <p:cNvPr id="3" name="Text 1"/>
-          <p:cNvSpPr txBox="1"/>
-          <p:nvPr/>
-        </p:nvSpPr>
-        <p:spPr>
-          <a:xfrm>
-            <a:off x="457200" y="292608"/>
-            <a:ext cx="8229600" cy="640080"/>
-          </a:xfrm>
-          <a:prstGeom prst="rect">
-            <a:avLst/>
-          </a:prstGeom>
-          <a:noFill/>
-          <a:ln/>
-        </p:spPr>
-        <p:txBody>
-          <a:bodyPr wrap="square" lIns="0" tIns="0" rIns="0" bIns="0" rtlCol="0" anchor="ctr"/>
-          <a:lstStyle/>
-          <a:p>
             <a:pPr indent="0" marL="0">
               <a:buNone/>
             </a:pPr>
@@ -2608,7 +2530,7 @@
       </p:sp>
       <p:sp>
         <p:nvSpPr>
-          <p:cNvPr id="4" name="Shape 2"/>
+          <p:cNvPr id="3" name="Shape 1"/>
           <p:cNvSpPr/>
           <p:nvPr/>
         </p:nvSpPr>
@@ -2635,7 +2557,7 @@
       </p:sp>
       <p:sp>
         <p:nvSpPr>
-          <p:cNvPr id="5" name="Shape 3"/>
+          <p:cNvPr id="4" name="Shape 2"/>
           <p:cNvSpPr/>
           <p:nvPr/>
         </p:nvSpPr>
@@ -2660,7 +2582,7 @@
       </p:sp>
       <p:sp>
         <p:nvSpPr>
-          <p:cNvPr id="6" name="Shape 4"/>
+          <p:cNvPr id="5" name="Shape 3"/>
           <p:cNvSpPr/>
           <p:nvPr/>
         </p:nvSpPr>
@@ -2685,14 +2607,53 @@
       </p:sp>
       <p:sp>
         <p:nvSpPr>
+          <p:cNvPr id="6" name="Text 4"/>
+          <p:cNvSpPr txBox="1"/>
+          <p:nvPr/>
+        </p:nvSpPr>
+        <p:spPr>
+          <a:xfrm>
+            <a:off x="548640" y="2377440"/>
+            <a:ext cx="2468880" cy="274320"/>
+          </a:xfrm>
+          <a:prstGeom prst="rect">
+            <a:avLst/>
+          </a:prstGeom>
+          <a:noFill/>
+          <a:ln/>
+        </p:spPr>
+        <p:txBody>
+          <a:bodyPr wrap="square" lIns="0" tIns="0" rIns="0" bIns="0" rtlCol="0" anchor="ctr"/>
+          <a:lstStyle/>
+          <a:p>
+            <a:pPr algn="ctr" indent="0" marL="0">
+              <a:buNone/>
+            </a:pPr>
+            <a:r>
+              <a:rPr lang="en-US" sz="1200" b="1" dirty="0">
+                <a:solidFill>
+                  <a:srgbClr val="FFFFFF"/>
+                </a:solidFill>
+                <a:latin typeface="Arial" pitchFamily="34" charset="0"/>
+                <a:ea typeface="Arial" pitchFamily="34" charset="-122"/>
+                <a:cs typeface="Arial" pitchFamily="34" charset="-120"/>
+              </a:rPr>
+              <a:t>CLIP: MiniVLA original</a:t>
+            </a:r>
+            <a:endParaRPr lang="en-US" sz="1200" dirty="0"/>
+          </a:p>
+        </p:txBody>
+      </p:sp>
+      <p:sp>
+        <p:nvSpPr>
           <p:cNvPr id="7" name="Text 5"/>
           <p:cNvSpPr txBox="1"/>
           <p:nvPr/>
         </p:nvSpPr>
         <p:spPr>
           <a:xfrm>
-            <a:off x="548640" y="2377440"/>
-            <a:ext cx="2468880" cy="274320"/>
+            <a:off x="548640" y="2624328"/>
+            <a:ext cx="2468880" cy="365760"/>
           </a:xfrm>
           <a:prstGeom prst="rect">
             <a:avLst/>
@@ -2701,52 +2662,13 @@
           <a:ln/>
         </p:spPr>
         <p:txBody>
-          <a:bodyPr wrap="square" lIns="0" tIns="0" rIns="0" bIns="0" rtlCol="0" anchor="ctr"/>
+          <a:bodyPr wrap="square" lIns="0" tIns="0" rIns="0" bIns="0" rtlCol="0" anchor="t"/>
           <a:lstStyle/>
           <a:p>
             <a:pPr algn="ctr" indent="0" marL="0">
               <a:buNone/>
             </a:pPr>
             <a:r>
-              <a:rPr lang="en-US" sz="1200" b="1" dirty="0">
-                <a:solidFill>
-                  <a:srgbClr val="FFFFFF"/>
-                </a:solidFill>
-                <a:latin typeface="Arial" pitchFamily="34" charset="0"/>
-                <a:ea typeface="Arial" pitchFamily="34" charset="-122"/>
-                <a:cs typeface="Arial" pitchFamily="34" charset="-120"/>
-              </a:rPr>
-              <a:t>CLIP: MiniVLA original</a:t>
-            </a:r>
-            <a:endParaRPr lang="en-US" sz="1200" dirty="0"/>
-          </a:p>
-        </p:txBody>
-      </p:sp>
-      <p:sp>
-        <p:nvSpPr>
-          <p:cNvPr id="8" name="Text 6"/>
-          <p:cNvSpPr txBox="1"/>
-          <p:nvPr/>
-        </p:nvSpPr>
-        <p:spPr>
-          <a:xfrm>
-            <a:off x="548640" y="2624328"/>
-            <a:ext cx="2468880" cy="365760"/>
-          </a:xfrm>
-          <a:prstGeom prst="rect">
-            <a:avLst/>
-          </a:prstGeom>
-          <a:noFill/>
-          <a:ln/>
-        </p:spPr>
-        <p:txBody>
-          <a:bodyPr wrap="square" lIns="0" tIns="0" rIns="0" bIns="0" rtlCol="0" anchor="t"/>
-          <a:lstStyle/>
-          <a:p>
-            <a:pPr algn="ctr" indent="0" marL="0">
-              <a:buNone/>
-            </a:pPr>
-            <a:r>
               <a:rPr lang="en-US" sz="950" dirty="0">
                 <a:solidFill>
                   <a:srgbClr val="C9D1DC"/>
@@ -2763,7 +2685,7 @@
       </p:sp>
       <p:sp>
         <p:nvSpPr>
-          <p:cNvPr id="9" name="Shape 7"/>
+          <p:cNvPr id="8" name="Shape 6"/>
           <p:cNvSpPr/>
           <p:nvPr/>
         </p:nvSpPr>
@@ -2790,7 +2712,7 @@
       </p:sp>
       <p:sp>
         <p:nvSpPr>
-          <p:cNvPr id="10" name="Shape 8"/>
+          <p:cNvPr id="9" name="Shape 7"/>
           <p:cNvSpPr/>
           <p:nvPr/>
         </p:nvSpPr>
@@ -2815,7 +2737,7 @@
       </p:sp>
       <p:sp>
         <p:nvSpPr>
-          <p:cNvPr id="11" name="Shape 9"/>
+          <p:cNvPr id="10" name="Shape 8"/>
           <p:cNvSpPr/>
           <p:nvPr/>
         </p:nvSpPr>
@@ -2840,14 +2762,53 @@
       </p:sp>
       <p:sp>
         <p:nvSpPr>
+          <p:cNvPr id="11" name="Text 9"/>
+          <p:cNvSpPr txBox="1"/>
+          <p:nvPr/>
+        </p:nvSpPr>
+        <p:spPr>
+          <a:xfrm>
+            <a:off x="3337560" y="2377440"/>
+            <a:ext cx="2468880" cy="274320"/>
+          </a:xfrm>
+          <a:prstGeom prst="rect">
+            <a:avLst/>
+          </a:prstGeom>
+          <a:noFill/>
+          <a:ln/>
+        </p:spPr>
+        <p:txBody>
+          <a:bodyPr wrap="square" lIns="0" tIns="0" rIns="0" bIns="0" rtlCol="0" anchor="ctr"/>
+          <a:lstStyle/>
+          <a:p>
+            <a:pPr algn="ctr" indent="0" marL="0">
+              <a:buNone/>
+            </a:pPr>
+            <a:r>
+              <a:rPr lang="en-US" sz="1200" b="1" dirty="0">
+                <a:solidFill>
+                  <a:srgbClr val="FFFFFF"/>
+                </a:solidFill>
+                <a:latin typeface="Arial" pitchFamily="34" charset="0"/>
+                <a:ea typeface="Arial" pitchFamily="34" charset="-122"/>
+                <a:cs typeface="Arial" pitchFamily="34" charset="-120"/>
+              </a:rPr>
+              <a:t>CLIP: MiniVLA + pruning</a:t>
+            </a:r>
+            <a:endParaRPr lang="en-US" sz="1200" dirty="0"/>
+          </a:p>
+        </p:txBody>
+      </p:sp>
+      <p:sp>
+        <p:nvSpPr>
           <p:cNvPr id="12" name="Text 10"/>
           <p:cNvSpPr txBox="1"/>
           <p:nvPr/>
         </p:nvSpPr>
         <p:spPr>
           <a:xfrm>
-            <a:off x="3337560" y="2377440"/>
-            <a:ext cx="2468880" cy="274320"/>
+            <a:off x="3337560" y="2624328"/>
+            <a:ext cx="2468880" cy="365760"/>
           </a:xfrm>
           <a:prstGeom prst="rect">
             <a:avLst/>
@@ -2856,24 +2817,24 @@
           <a:ln/>
         </p:spPr>
         <p:txBody>
-          <a:bodyPr wrap="square" lIns="0" tIns="0" rIns="0" bIns="0" rtlCol="0" anchor="ctr"/>
+          <a:bodyPr wrap="square" lIns="0" tIns="0" rIns="0" bIns="0" rtlCol="0" anchor="t"/>
           <a:lstStyle/>
           <a:p>
             <a:pPr algn="ctr" indent="0" marL="0">
               <a:buNone/>
             </a:pPr>
             <a:r>
-              <a:rPr lang="en-US" sz="1200" b="1" dirty="0">
-                <a:solidFill>
-                  <a:srgbClr val="FFFFFF"/>
-                </a:solidFill>
-                <a:latin typeface="Arial" pitchFamily="34" charset="0"/>
-                <a:ea typeface="Arial" pitchFamily="34" charset="-122"/>
-                <a:cs typeface="Arial" pitchFamily="34" charset="-120"/>
-              </a:rPr>
-              <a:t>CLIP: MiniVLA + pruning</a:t>
-            </a:r>
-            <a:endParaRPr lang="en-US" sz="1200" dirty="0"/>
+              <a:rPr lang="en-US" sz="950" dirty="0">
+                <a:solidFill>
+                  <a:srgbClr val="C9D1DC"/>
+                </a:solidFill>
+                <a:latin typeface="Arial" pitchFamily="34" charset="0"/>
+                <a:ea typeface="Arial" pitchFamily="34" charset="-122"/>
+                <a:cs typeface="Arial" pitchFamily="34" charset="-120"/>
+              </a:rPr>
+              <a:t>fails (red border)</a:t>
+            </a:r>
+            <a:endParaRPr lang="en-US" sz="950" dirty="0"/>
           </a:p>
         </p:txBody>
       </p:sp>
@@ -2885,8 +2846,8 @@
         </p:nvSpPr>
         <p:spPr>
           <a:xfrm>
-            <a:off x="3337560" y="2624328"/>
-            <a:ext cx="2468880" cy="365760"/>
+            <a:off x="457200" y="3401568"/>
+            <a:ext cx="5440680" cy="274320"/>
           </a:xfrm>
           <a:prstGeom prst="rect">
             <a:avLst/>
@@ -2898,45 +2859,6 @@
           <a:bodyPr wrap="square" lIns="0" tIns="0" rIns="0" bIns="0" rtlCol="0" anchor="t"/>
           <a:lstStyle/>
           <a:p>
-            <a:pPr algn="ctr" indent="0" marL="0">
-              <a:buNone/>
-            </a:pPr>
-            <a:r>
-              <a:rPr lang="en-US" sz="950" dirty="0">
-                <a:solidFill>
-                  <a:srgbClr val="C9D1DC"/>
-                </a:solidFill>
-                <a:latin typeface="Arial" pitchFamily="34" charset="0"/>
-                <a:ea typeface="Arial" pitchFamily="34" charset="-122"/>
-                <a:cs typeface="Arial" pitchFamily="34" charset="-120"/>
-              </a:rPr>
-              <a:t>fails (red border)</a:t>
-            </a:r>
-            <a:endParaRPr lang="en-US" sz="950" dirty="0"/>
-          </a:p>
-        </p:txBody>
-      </p:sp>
-      <p:sp>
-        <p:nvSpPr>
-          <p:cNvPr id="14" name="Text 12"/>
-          <p:cNvSpPr txBox="1"/>
-          <p:nvPr/>
-        </p:nvSpPr>
-        <p:spPr>
-          <a:xfrm>
-            <a:off x="457200" y="3401568"/>
-            <a:ext cx="5440680" cy="274320"/>
-          </a:xfrm>
-          <a:prstGeom prst="rect">
-            <a:avLst/>
-          </a:prstGeom>
-          <a:noFill/>
-          <a:ln/>
-        </p:spPr>
-        <p:txBody>
-          <a:bodyPr wrap="square" lIns="0" tIns="0" rIns="0" bIns="0" rtlCol="0" anchor="t"/>
-          <a:lstStyle/>
-          <a:p>
             <a:pPr algn="l" indent="0" marL="0">
               <a:buNone/>
             </a:pPr>
@@ -2957,7 +2879,7 @@
       </p:sp>
       <p:sp>
         <p:nvSpPr>
-          <p:cNvPr id="15" name="Shape 13"/>
+          <p:cNvPr id="14" name="Shape 12"/>
           <p:cNvSpPr/>
           <p:nvPr/>
         </p:nvSpPr>
@@ -2984,7 +2906,7 @@
       </p:sp>
       <p:sp>
         <p:nvSpPr>
-          <p:cNvPr id="16" name="Text 14"/>
+          <p:cNvPr id="15" name="Text 13"/>
           <p:cNvSpPr txBox="1"/>
           <p:nvPr/>
         </p:nvSpPr>
@@ -3023,7 +2945,7 @@
       </p:sp>
       <p:sp>
         <p:nvSpPr>
-          <p:cNvPr id="17" name="Shape 15"/>
+          <p:cNvPr id="16" name="Shape 14"/>
           <p:cNvSpPr/>
           <p:nvPr/>
         </p:nvSpPr>
@@ -3050,7 +2972,7 @@
       </p:sp>
       <p:sp>
         <p:nvSpPr>
-          <p:cNvPr id="18" name="Text 16"/>
+          <p:cNvPr id="17" name="Text 15"/>
           <p:cNvSpPr txBox="1"/>
           <p:nvPr/>
         </p:nvSpPr>
@@ -3089,7 +3011,7 @@
       </p:sp>
       <p:sp>
         <p:nvSpPr>
-          <p:cNvPr id="19" name="Shape 17"/>
+          <p:cNvPr id="18" name="Shape 16"/>
           <p:cNvSpPr/>
           <p:nvPr/>
         </p:nvSpPr>
@@ -3116,7 +3038,7 @@
       </p:sp>
       <p:sp>
         <p:nvSpPr>
-          <p:cNvPr id="20" name="Text 18"/>
+          <p:cNvPr id="19" name="Text 17"/>
           <p:cNvSpPr txBox="1"/>
           <p:nvPr/>
         </p:nvSpPr>
@@ -3155,7 +3077,7 @@
       </p:sp>
       <p:sp>
         <p:nvSpPr>
-          <p:cNvPr id="21" name="Shape 19"/>
+          <p:cNvPr id="20" name="Shape 18"/>
           <p:cNvSpPr/>
           <p:nvPr/>
         </p:nvSpPr>
@@ -3182,7 +3104,7 @@
       </p:sp>
       <p:sp>
         <p:nvSpPr>
-          <p:cNvPr id="22" name="Text 20"/>
+          <p:cNvPr id="21" name="Text 19"/>
           <p:cNvSpPr txBox="1"/>
           <p:nvPr/>
         </p:nvSpPr>
@@ -3221,7 +3143,7 @@
       </p:sp>
       <p:sp>
         <p:nvSpPr>
-          <p:cNvPr id="23" name="Shape 21"/>
+          <p:cNvPr id="22" name="Shape 20"/>
           <p:cNvSpPr/>
           <p:nvPr/>
         </p:nvSpPr>
@@ -3248,7 +3170,7 @@
       </p:sp>
       <p:sp>
         <p:nvSpPr>
-          <p:cNvPr id="24" name="Text 22"/>
+          <p:cNvPr id="23" name="Text 21"/>
           <p:cNvSpPr txBox="1"/>
           <p:nvPr/>
         </p:nvSpPr>
@@ -3325,8 +3247,8 @@
         </p:nvSpPr>
         <p:spPr>
           <a:xfrm>
-            <a:off x="7680960" y="73152"/>
-            <a:ext cx="1280160" cy="228600"/>
+            <a:off x="457200" y="292608"/>
+            <a:ext cx="8229600" cy="640080"/>
           </a:xfrm>
           <a:prstGeom prst="rect">
             <a:avLst/>
@@ -3338,45 +3260,6 @@
           <a:bodyPr wrap="square" lIns="0" tIns="0" rIns="0" bIns="0" rtlCol="0" anchor="ctr"/>
           <a:lstStyle/>
           <a:p>
-            <a:pPr algn="r" indent="0" marL="0">
-              <a:buNone/>
-            </a:pPr>
-            <a:r>
-              <a:rPr lang="en-US" sz="900" dirty="0">
-                <a:solidFill>
-                  <a:srgbClr val="5F6B7A"/>
-                </a:solidFill>
-                <a:latin typeface="Arial" pitchFamily="34" charset="0"/>
-                <a:ea typeface="Arial" pitchFamily="34" charset="-122"/>
-                <a:cs typeface="Arial" pitchFamily="34" charset="-120"/>
-              </a:rPr>
-              <a:t>11  ·  13s</a:t>
-            </a:r>
-            <a:endParaRPr lang="en-US" sz="900" dirty="0"/>
-          </a:p>
-        </p:txBody>
-      </p:sp>
-      <p:sp>
-        <p:nvSpPr>
-          <p:cNvPr id="3" name="Text 1"/>
-          <p:cNvSpPr txBox="1"/>
-          <p:nvPr/>
-        </p:nvSpPr>
-        <p:spPr>
-          <a:xfrm>
-            <a:off x="457200" y="292608"/>
-            <a:ext cx="8229600" cy="640080"/>
-          </a:xfrm>
-          <a:prstGeom prst="rect">
-            <a:avLst/>
-          </a:prstGeom>
-          <a:noFill/>
-          <a:ln/>
-        </p:spPr>
-        <p:txBody>
-          <a:bodyPr wrap="square" lIns="0" tIns="0" rIns="0" bIns="0" rtlCol="0" anchor="ctr"/>
-          <a:lstStyle/>
-          <a:p>
             <a:pPr indent="0" marL="0">
               <a:buNone/>
             </a:pPr>
@@ -3397,7 +3280,7 @@
       </p:sp>
       <p:pic>
         <p:nvPicPr>
-          <p:cNvPr id="4" name="Image 0" descr="/tmp/claude-0/-home-user-BiVLA/4327cefa-ba5d-5e2e-9d87-c73dd3a8ccbb/scratchpad/video_ppt/assets/fig4_tradeoff_row.png">    </p:cNvPr>
+          <p:cNvPr id="3" name="Image 0" descr="/tmp/claude-0/-home-user-BiVLA/4327cefa-ba5d-5e2e-9d87-c73dd3a8ccbb/scratchpad/video_ppt/assets/fig4_tradeoff_row.png">    </p:cNvPr>
           <p:cNvPicPr>
             <a:picLocks noChangeAspect="1"/>
           </p:cNvPicPr>
@@ -3421,7 +3304,7 @@
       </p:pic>
       <p:sp>
         <p:nvSpPr>
-          <p:cNvPr id="5" name="Text 2"/>
+          <p:cNvPr id="4" name="Text 1"/>
           <p:cNvSpPr txBox="1"/>
           <p:nvPr/>
         </p:nvSpPr>
@@ -3460,7 +3343,7 @@
       </p:sp>
       <p:sp>
         <p:nvSpPr>
-          <p:cNvPr id="6" name="Shape 3"/>
+          <p:cNvPr id="5" name="Shape 2"/>
           <p:cNvSpPr/>
           <p:nvPr/>
         </p:nvSpPr>
@@ -3487,7 +3370,7 @@
       </p:sp>
       <p:sp>
         <p:nvSpPr>
-          <p:cNvPr id="7" name="Text 4"/>
+          <p:cNvPr id="6" name="Text 3"/>
           <p:cNvSpPr txBox="1"/>
           <p:nvPr/>
         </p:nvSpPr>
@@ -3526,7 +3409,7 @@
       </p:sp>
       <p:sp>
         <p:nvSpPr>
-          <p:cNvPr id="8" name="Text 5"/>
+          <p:cNvPr id="7" name="Text 4"/>
           <p:cNvSpPr txBox="1"/>
           <p:nvPr/>
         </p:nvSpPr>
@@ -4299,8 +4182,8 @@
         </p:nvSpPr>
         <p:spPr>
           <a:xfrm>
-            <a:off x="7680960" y="73152"/>
-            <a:ext cx="1280160" cy="228600"/>
+            <a:off x="457200" y="292608"/>
+            <a:ext cx="8229600" cy="640080"/>
           </a:xfrm>
           <a:prstGeom prst="rect">
             <a:avLst/>
@@ -4312,45 +4195,6 @@
           <a:bodyPr wrap="square" lIns="0" tIns="0" rIns="0" bIns="0" rtlCol="0" anchor="ctr"/>
           <a:lstStyle/>
           <a:p>
-            <a:pPr algn="r" indent="0" marL="0">
-              <a:buNone/>
-            </a:pPr>
-            <a:r>
-              <a:rPr lang="en-US" sz="900" dirty="0">
-                <a:solidFill>
-                  <a:srgbClr val="5F6B7A"/>
-                </a:solidFill>
-                <a:latin typeface="Arial" pitchFamily="34" charset="0"/>
-                <a:ea typeface="Arial" pitchFamily="34" charset="-122"/>
-                <a:cs typeface="Arial" pitchFamily="34" charset="-120"/>
-              </a:rPr>
-              <a:t>12  ·  13s</a:t>
-            </a:r>
-            <a:endParaRPr lang="en-US" sz="900" dirty="0"/>
-          </a:p>
-        </p:txBody>
-      </p:sp>
-      <p:sp>
-        <p:nvSpPr>
-          <p:cNvPr id="3" name="Text 1"/>
-          <p:cNvSpPr txBox="1"/>
-          <p:nvPr/>
-        </p:nvSpPr>
-        <p:spPr>
-          <a:xfrm>
-            <a:off x="457200" y="292608"/>
-            <a:ext cx="8229600" cy="640080"/>
-          </a:xfrm>
-          <a:prstGeom prst="rect">
-            <a:avLst/>
-          </a:prstGeom>
-          <a:noFill/>
-          <a:ln/>
-        </p:spPr>
-        <p:txBody>
-          <a:bodyPr wrap="square" lIns="0" tIns="0" rIns="0" bIns="0" rtlCol="0" anchor="ctr"/>
-          <a:lstStyle/>
-          <a:p>
             <a:pPr indent="0" marL="0">
               <a:buNone/>
             </a:pPr>
@@ -4371,7 +4215,7 @@
       </p:sp>
       <p:sp>
         <p:nvSpPr>
-          <p:cNvPr id="4" name="Shape 2"/>
+          <p:cNvPr id="3" name="Shape 1"/>
           <p:cNvSpPr/>
           <p:nvPr/>
         </p:nvSpPr>
@@ -4398,7 +4242,7 @@
       </p:sp>
       <p:sp>
         <p:nvSpPr>
-          <p:cNvPr id="5" name="Shape 3"/>
+          <p:cNvPr id="4" name="Shape 2"/>
           <p:cNvSpPr/>
           <p:nvPr/>
         </p:nvSpPr>
@@ -4423,7 +4267,7 @@
       </p:sp>
       <p:sp>
         <p:nvSpPr>
-          <p:cNvPr id="6" name="Shape 4"/>
+          <p:cNvPr id="5" name="Shape 3"/>
           <p:cNvSpPr/>
           <p:nvPr/>
         </p:nvSpPr>
@@ -4448,14 +4292,53 @@
       </p:sp>
       <p:sp>
         <p:nvSpPr>
+          <p:cNvPr id="6" name="Text 4"/>
+          <p:cNvSpPr txBox="1"/>
+          <p:nvPr/>
+        </p:nvSpPr>
+        <p:spPr>
+          <a:xfrm>
+            <a:off x="548640" y="2171700"/>
+            <a:ext cx="2468880" cy="274320"/>
+          </a:xfrm>
+          <a:prstGeom prst="rect">
+            <a:avLst/>
+          </a:prstGeom>
+          <a:noFill/>
+          <a:ln/>
+        </p:spPr>
+        <p:txBody>
+          <a:bodyPr wrap="square" lIns="0" tIns="0" rIns="0" bIns="0" rtlCol="0" anchor="ctr"/>
+          <a:lstStyle/>
+          <a:p>
+            <a:pPr algn="ctr" indent="0" marL="0">
+              <a:buNone/>
+            </a:pPr>
+            <a:r>
+              <a:rPr lang="en-US" sz="1200" b="1" dirty="0">
+                <a:solidFill>
+                  <a:srgbClr val="FFFFFF"/>
+                </a:solidFill>
+                <a:latin typeface="Arial" pitchFamily="34" charset="0"/>
+                <a:ea typeface="Arial" pitchFamily="34" charset="-122"/>
+                <a:cs typeface="Arial" pitchFamily="34" charset="-120"/>
+              </a:rPr>
+              <a:t>CLIP: Original</a:t>
+            </a:r>
+            <a:endParaRPr lang="en-US" sz="1200" dirty="0"/>
+          </a:p>
+        </p:txBody>
+      </p:sp>
+      <p:sp>
+        <p:nvSpPr>
           <p:cNvPr id="7" name="Text 5"/>
           <p:cNvSpPr txBox="1"/>
           <p:nvPr/>
         </p:nvSpPr>
         <p:spPr>
           <a:xfrm>
-            <a:off x="548640" y="2171700"/>
-            <a:ext cx="2468880" cy="274320"/>
+            <a:off x="548640" y="2418588"/>
+            <a:ext cx="2468880" cy="365760"/>
           </a:xfrm>
           <a:prstGeom prst="rect">
             <a:avLst/>
@@ -4464,24 +4347,24 @@
           <a:ln/>
         </p:spPr>
         <p:txBody>
-          <a:bodyPr wrap="square" lIns="0" tIns="0" rIns="0" bIns="0" rtlCol="0" anchor="ctr"/>
+          <a:bodyPr wrap="square" lIns="0" tIns="0" rIns="0" bIns="0" rtlCol="0" anchor="t"/>
           <a:lstStyle/>
           <a:p>
             <a:pPr algn="ctr" indent="0" marL="0">
               <a:buNone/>
             </a:pPr>
             <a:r>
-              <a:rPr lang="en-US" sz="1200" b="1" dirty="0">
-                <a:solidFill>
-                  <a:srgbClr val="FFFFFF"/>
-                </a:solidFill>
-                <a:latin typeface="Arial" pitchFamily="34" charset="0"/>
-                <a:ea typeface="Arial" pitchFamily="34" charset="-122"/>
-                <a:cs typeface="Arial" pitchFamily="34" charset="-120"/>
-              </a:rPr>
-              <a:t>CLIP: Original</a:t>
-            </a:r>
-            <a:endParaRPr lang="en-US" sz="1200" dirty="0"/>
+              <a:rPr lang="en-US" sz="950" dirty="0">
+                <a:solidFill>
+                  <a:srgbClr val="C9D1DC"/>
+                </a:solidFill>
+                <a:latin typeface="Arial" pitchFamily="34" charset="0"/>
+                <a:ea typeface="Arial" pitchFamily="34" charset="-122"/>
+                <a:cs typeface="Arial" pitchFamily="34" charset="-120"/>
+              </a:rPr>
+              <a:t>policy call every step</a:t>
+            </a:r>
+            <a:endParaRPr lang="en-US" sz="950" dirty="0"/>
           </a:p>
         </p:txBody>
       </p:sp>
@@ -4493,8 +4376,8 @@
         </p:nvSpPr>
         <p:spPr>
           <a:xfrm>
-            <a:off x="548640" y="2418588"/>
-            <a:ext cx="2468880" cy="365760"/>
+            <a:off x="457200" y="2971800"/>
+            <a:ext cx="2651760" cy="274320"/>
           </a:xfrm>
           <a:prstGeom prst="rect">
             <a:avLst/>
@@ -4510,45 +4393,6 @@
               <a:buNone/>
             </a:pPr>
             <a:r>
-              <a:rPr lang="en-US" sz="950" dirty="0">
-                <a:solidFill>
-                  <a:srgbClr val="C9D1DC"/>
-                </a:solidFill>
-                <a:latin typeface="Arial" pitchFamily="34" charset="0"/>
-                <a:ea typeface="Arial" pitchFamily="34" charset="-122"/>
-                <a:cs typeface="Arial" pitchFamily="34" charset="-120"/>
-              </a:rPr>
-              <a:t>policy call every step</a:t>
-            </a:r>
-            <a:endParaRPr lang="en-US" sz="950" dirty="0"/>
-          </a:p>
-        </p:txBody>
-      </p:sp>
-      <p:sp>
-        <p:nvSpPr>
-          <p:cNvPr id="9" name="Text 7"/>
-          <p:cNvSpPr txBox="1"/>
-          <p:nvPr/>
-        </p:nvSpPr>
-        <p:spPr>
-          <a:xfrm>
-            <a:off x="457200" y="2971800"/>
-            <a:ext cx="2651760" cy="274320"/>
-          </a:xfrm>
-          <a:prstGeom prst="rect">
-            <a:avLst/>
-          </a:prstGeom>
-          <a:noFill/>
-          <a:ln/>
-        </p:spPr>
-        <p:txBody>
-          <a:bodyPr wrap="square" lIns="0" tIns="0" rIns="0" bIns="0" rtlCol="0" anchor="t"/>
-          <a:lstStyle/>
-          <a:p>
-            <a:pPr algn="ctr" indent="0" marL="0">
-              <a:buNone/>
-            </a:pPr>
-            <a:r>
               <a:rPr lang="en-US" sz="1000" dirty="0">
                 <a:solidFill>
                   <a:srgbClr val="5F6B7A"/>
@@ -4565,7 +4409,7 @@
       </p:sp>
       <p:sp>
         <p:nvSpPr>
-          <p:cNvPr id="10" name="Shape 8"/>
+          <p:cNvPr id="9" name="Shape 7"/>
           <p:cNvSpPr/>
           <p:nvPr/>
         </p:nvSpPr>
@@ -4592,7 +4436,7 @@
       </p:sp>
       <p:sp>
         <p:nvSpPr>
-          <p:cNvPr id="11" name="Shape 9"/>
+          <p:cNvPr id="10" name="Shape 8"/>
           <p:cNvSpPr/>
           <p:nvPr/>
         </p:nvSpPr>
@@ -4617,7 +4461,7 @@
       </p:sp>
       <p:sp>
         <p:nvSpPr>
-          <p:cNvPr id="12" name="Shape 10"/>
+          <p:cNvPr id="11" name="Shape 9"/>
           <p:cNvSpPr/>
           <p:nvPr/>
         </p:nvSpPr>
@@ -4642,14 +4486,53 @@
       </p:sp>
       <p:sp>
         <p:nvSpPr>
+          <p:cNvPr id="12" name="Text 10"/>
+          <p:cNvSpPr txBox="1"/>
+          <p:nvPr/>
+        </p:nvSpPr>
+        <p:spPr>
+          <a:xfrm>
+            <a:off x="3337560" y="2171700"/>
+            <a:ext cx="2468880" cy="274320"/>
+          </a:xfrm>
+          <a:prstGeom prst="rect">
+            <a:avLst/>
+          </a:prstGeom>
+          <a:noFill/>
+          <a:ln/>
+        </p:spPr>
+        <p:txBody>
+          <a:bodyPr wrap="square" lIns="0" tIns="0" rIns="0" bIns="0" rtlCol="0" anchor="ctr"/>
+          <a:lstStyle/>
+          <a:p>
+            <a:pPr algn="ctr" indent="0" marL="0">
+              <a:buNone/>
+            </a:pPr>
+            <a:r>
+              <a:rPr lang="en-US" sz="1200" b="1" dirty="0">
+                <a:solidFill>
+                  <a:srgbClr val="FFFFFF"/>
+                </a:solidFill>
+                <a:latin typeface="Arial" pitchFamily="34" charset="0"/>
+                <a:ea typeface="Arial" pitchFamily="34" charset="-122"/>
+                <a:cs typeface="Arial" pitchFamily="34" charset="-120"/>
+              </a:rPr>
+              <a:t>CLIP: Action repeat k = 4</a:t>
+            </a:r>
+            <a:endParaRPr lang="en-US" sz="1200" dirty="0"/>
+          </a:p>
+        </p:txBody>
+      </p:sp>
+      <p:sp>
+        <p:nvSpPr>
           <p:cNvPr id="13" name="Text 11"/>
           <p:cNvSpPr txBox="1"/>
           <p:nvPr/>
         </p:nvSpPr>
         <p:spPr>
           <a:xfrm>
-            <a:off x="3337560" y="2171700"/>
-            <a:ext cx="2468880" cy="274320"/>
+            <a:off x="3337560" y="2418588"/>
+            <a:ext cx="2468880" cy="365760"/>
           </a:xfrm>
           <a:prstGeom prst="rect">
             <a:avLst/>
@@ -4658,24 +4541,24 @@
           <a:ln/>
         </p:spPr>
         <p:txBody>
-          <a:bodyPr wrap="square" lIns="0" tIns="0" rIns="0" bIns="0" rtlCol="0" anchor="ctr"/>
+          <a:bodyPr wrap="square" lIns="0" tIns="0" rIns="0" bIns="0" rtlCol="0" anchor="t"/>
           <a:lstStyle/>
           <a:p>
             <a:pPr algn="ctr" indent="0" marL="0">
               <a:buNone/>
             </a:pPr>
             <a:r>
-              <a:rPr lang="en-US" sz="1200" b="1" dirty="0">
-                <a:solidFill>
-                  <a:srgbClr val="FFFFFF"/>
-                </a:solidFill>
-                <a:latin typeface="Arial" pitchFamily="34" charset="0"/>
-                <a:ea typeface="Arial" pitchFamily="34" charset="-122"/>
-                <a:cs typeface="Arial" pitchFamily="34" charset="-120"/>
-              </a:rPr>
-              <a:t>CLIP: Action repeat k = 4</a:t>
-            </a:r>
-            <a:endParaRPr lang="en-US" sz="1200" dirty="0"/>
+              <a:rPr lang="en-US" sz="950" dirty="0">
+                <a:solidFill>
+                  <a:srgbClr val="C9D1DC"/>
+                </a:solidFill>
+                <a:latin typeface="Arial" pitchFamily="34" charset="0"/>
+                <a:ea typeface="Arial" pitchFamily="34" charset="-122"/>
+                <a:cs typeface="Arial" pitchFamily="34" charset="-120"/>
+              </a:rPr>
+              <a:t>held actions, episode fails</a:t>
+            </a:r>
+            <a:endParaRPr lang="en-US" sz="950" dirty="0"/>
           </a:p>
         </p:txBody>
       </p:sp>
@@ -4687,8 +4570,8 @@
         </p:nvSpPr>
         <p:spPr>
           <a:xfrm>
-            <a:off x="3337560" y="2418588"/>
-            <a:ext cx="2468880" cy="365760"/>
+            <a:off x="3246120" y="2971800"/>
+            <a:ext cx="2651760" cy="274320"/>
           </a:xfrm>
           <a:prstGeom prst="rect">
             <a:avLst/>
@@ -4704,45 +4587,6 @@
               <a:buNone/>
             </a:pPr>
             <a:r>
-              <a:rPr lang="en-US" sz="950" dirty="0">
-                <a:solidFill>
-                  <a:srgbClr val="C9D1DC"/>
-                </a:solidFill>
-                <a:latin typeface="Arial" pitchFamily="34" charset="0"/>
-                <a:ea typeface="Arial" pitchFamily="34" charset="-122"/>
-                <a:cs typeface="Arial" pitchFamily="34" charset="-120"/>
-              </a:rPr>
-              <a:t>held actions, episode fails</a:t>
-            </a:r>
-            <a:endParaRPr lang="en-US" sz="950" dirty="0"/>
-          </a:p>
-        </p:txBody>
-      </p:sp>
-      <p:sp>
-        <p:nvSpPr>
-          <p:cNvPr id="15" name="Text 13"/>
-          <p:cNvSpPr txBox="1"/>
-          <p:nvPr/>
-        </p:nvSpPr>
-        <p:spPr>
-          <a:xfrm>
-            <a:off x="3246120" y="2971800"/>
-            <a:ext cx="2651760" cy="274320"/>
-          </a:xfrm>
-          <a:prstGeom prst="rect">
-            <a:avLst/>
-          </a:prstGeom>
-          <a:noFill/>
-          <a:ln/>
-        </p:spPr>
-        <p:txBody>
-          <a:bodyPr wrap="square" lIns="0" tIns="0" rIns="0" bIns="0" rtlCol="0" anchor="t"/>
-          <a:lstStyle/>
-          <a:p>
-            <a:pPr algn="ctr" indent="0" marL="0">
-              <a:buNone/>
-            </a:pPr>
-            <a:r>
               <a:rPr lang="en-US" sz="1000" dirty="0">
                 <a:solidFill>
                   <a:srgbClr val="5F6B7A"/>
@@ -4759,7 +4603,7 @@
       </p:sp>
       <p:sp>
         <p:nvSpPr>
-          <p:cNvPr id="16" name="Shape 14"/>
+          <p:cNvPr id="15" name="Shape 13"/>
           <p:cNvSpPr/>
           <p:nvPr/>
         </p:nvSpPr>
@@ -4786,7 +4630,7 @@
       </p:sp>
       <p:sp>
         <p:nvSpPr>
-          <p:cNvPr id="17" name="Shape 15"/>
+          <p:cNvPr id="16" name="Shape 14"/>
           <p:cNvSpPr/>
           <p:nvPr/>
         </p:nvSpPr>
@@ -4811,7 +4655,7 @@
       </p:sp>
       <p:sp>
         <p:nvSpPr>
-          <p:cNvPr id="18" name="Shape 16"/>
+          <p:cNvPr id="17" name="Shape 15"/>
           <p:cNvSpPr/>
           <p:nvPr/>
         </p:nvSpPr>
@@ -4836,14 +4680,53 @@
       </p:sp>
       <p:sp>
         <p:nvSpPr>
+          <p:cNvPr id="18" name="Text 16"/>
+          <p:cNvSpPr txBox="1"/>
+          <p:nvPr/>
+        </p:nvSpPr>
+        <p:spPr>
+          <a:xfrm>
+            <a:off x="6126480" y="2171700"/>
+            <a:ext cx="2468880" cy="274320"/>
+          </a:xfrm>
+          <a:prstGeom prst="rect">
+            <a:avLst/>
+          </a:prstGeom>
+          <a:noFill/>
+          <a:ln/>
+        </p:spPr>
+        <p:txBody>
+          <a:bodyPr wrap="square" lIns="0" tIns="0" rIns="0" bIns="0" rtlCol="0" anchor="ctr"/>
+          <a:lstStyle/>
+          <a:p>
+            <a:pPr algn="ctr" indent="0" marL="0">
+              <a:buNone/>
+            </a:pPr>
+            <a:r>
+              <a:rPr lang="en-US" sz="1200" b="1" dirty="0">
+                <a:solidFill>
+                  <a:srgbClr val="FFFFFF"/>
+                </a:solidFill>
+                <a:latin typeface="Arial" pitchFamily="34" charset="0"/>
+                <a:ea typeface="Arial" pitchFamily="34" charset="-122"/>
+                <a:cs typeface="Arial" pitchFamily="34" charset="-120"/>
+              </a:rPr>
+              <a:t>CLIP: Guarded reuse</a:t>
+            </a:r>
+            <a:endParaRPr lang="en-US" sz="1200" dirty="0"/>
+          </a:p>
+        </p:txBody>
+      </p:sp>
+      <p:sp>
+        <p:nvSpPr>
           <p:cNvPr id="19" name="Text 17"/>
           <p:cNvSpPr txBox="1"/>
           <p:nvPr/>
         </p:nvSpPr>
         <p:spPr>
           <a:xfrm>
-            <a:off x="6126480" y="2171700"/>
-            <a:ext cx="2468880" cy="274320"/>
+            <a:off x="6126480" y="2418588"/>
+            <a:ext cx="2468880" cy="365760"/>
           </a:xfrm>
           <a:prstGeom prst="rect">
             <a:avLst/>
@@ -4852,24 +4735,24 @@
           <a:ln/>
         </p:spPr>
         <p:txBody>
-          <a:bodyPr wrap="square" lIns="0" tIns="0" rIns="0" bIns="0" rtlCol="0" anchor="ctr"/>
+          <a:bodyPr wrap="square" lIns="0" tIns="0" rIns="0" bIns="0" rtlCol="0" anchor="t"/>
           <a:lstStyle/>
           <a:p>
             <a:pPr algn="ctr" indent="0" marL="0">
               <a:buNone/>
             </a:pPr>
             <a:r>
-              <a:rPr lang="en-US" sz="1200" b="1" dirty="0">
-                <a:solidFill>
-                  <a:srgbClr val="FFFFFF"/>
-                </a:solidFill>
-                <a:latin typeface="Arial" pitchFamily="34" charset="0"/>
-                <a:ea typeface="Arial" pitchFamily="34" charset="-122"/>
-                <a:cs typeface="Arial" pitchFamily="34" charset="-120"/>
-              </a:rPr>
-              <a:t>CLIP: Guarded reuse</a:t>
-            </a:r>
-            <a:endParaRPr lang="en-US" sz="1200" dirty="0"/>
+              <a:rPr lang="en-US" sz="950" dirty="0">
+                <a:solidFill>
+                  <a:srgbClr val="C9D1DC"/>
+                </a:solidFill>
+                <a:latin typeface="Arial" pitchFamily="34" charset="0"/>
+                <a:ea typeface="Arial" pitchFamily="34" charset="-122"/>
+                <a:cs typeface="Arial" pitchFamily="34" charset="-120"/>
+              </a:rPr>
+              <a:t>calls skipped only when the gates pass</a:t>
+            </a:r>
+            <a:endParaRPr lang="en-US" sz="950" dirty="0"/>
           </a:p>
         </p:txBody>
       </p:sp>
@@ -4881,8 +4764,8 @@
         </p:nvSpPr>
         <p:spPr>
           <a:xfrm>
-            <a:off x="6126480" y="2418588"/>
-            <a:ext cx="2468880" cy="365760"/>
+            <a:off x="6035040" y="2971800"/>
+            <a:ext cx="2651760" cy="274320"/>
           </a:xfrm>
           <a:prstGeom prst="rect">
             <a:avLst/>
@@ -4898,45 +4781,6 @@
               <a:buNone/>
             </a:pPr>
             <a:r>
-              <a:rPr lang="en-US" sz="950" dirty="0">
-                <a:solidFill>
-                  <a:srgbClr val="C9D1DC"/>
-                </a:solidFill>
-                <a:latin typeface="Arial" pitchFamily="34" charset="0"/>
-                <a:ea typeface="Arial" pitchFamily="34" charset="-122"/>
-                <a:cs typeface="Arial" pitchFamily="34" charset="-120"/>
-              </a:rPr>
-              <a:t>calls skipped only when the gates pass</a:t>
-            </a:r>
-            <a:endParaRPr lang="en-US" sz="950" dirty="0"/>
-          </a:p>
-        </p:txBody>
-      </p:sp>
-      <p:sp>
-        <p:nvSpPr>
-          <p:cNvPr id="21" name="Text 19"/>
-          <p:cNvSpPr txBox="1"/>
-          <p:nvPr/>
-        </p:nvSpPr>
-        <p:spPr>
-          <a:xfrm>
-            <a:off x="6035040" y="2971800"/>
-            <a:ext cx="2651760" cy="274320"/>
-          </a:xfrm>
-          <a:prstGeom prst="rect">
-            <a:avLst/>
-          </a:prstGeom>
-          <a:noFill/>
-          <a:ln/>
-        </p:spPr>
-        <p:txBody>
-          <a:bodyPr wrap="square" lIns="0" tIns="0" rIns="0" bIns="0" rtlCol="0" anchor="t"/>
-          <a:lstStyle/>
-          <a:p>
-            <a:pPr algn="ctr" indent="0" marL="0">
-              <a:buNone/>
-            </a:pPr>
-            <a:r>
               <a:rPr lang="en-US" sz="1000" dirty="0">
                 <a:solidFill>
                   <a:srgbClr val="5F6B7A"/>
@@ -4953,7 +4797,7 @@
       </p:sp>
       <p:sp>
         <p:nvSpPr>
-          <p:cNvPr id="22" name="Shape 20"/>
+          <p:cNvPr id="21" name="Shape 19"/>
           <p:cNvSpPr/>
           <p:nvPr/>
         </p:nvSpPr>
@@ -4980,7 +4824,7 @@
       </p:sp>
       <p:sp>
         <p:nvSpPr>
-          <p:cNvPr id="23" name="Text 21"/>
+          <p:cNvPr id="22" name="Text 20"/>
           <p:cNvSpPr txBox="1"/>
           <p:nvPr/>
         </p:nvSpPr>
@@ -5019,7 +4863,7 @@
       </p:sp>
       <p:sp>
         <p:nvSpPr>
-          <p:cNvPr id="24" name="Shape 22"/>
+          <p:cNvPr id="23" name="Shape 21"/>
           <p:cNvSpPr/>
           <p:nvPr/>
         </p:nvSpPr>
@@ -5046,7 +4890,7 @@
       </p:sp>
       <p:sp>
         <p:nvSpPr>
-          <p:cNvPr id="25" name="Text 23"/>
+          <p:cNvPr id="24" name="Text 22"/>
           <p:cNvSpPr txBox="1"/>
           <p:nvPr/>
         </p:nvSpPr>
@@ -5085,7 +4929,7 @@
       </p:sp>
       <p:sp>
         <p:nvSpPr>
-          <p:cNvPr id="26" name="Shape 24"/>
+          <p:cNvPr id="25" name="Shape 23"/>
           <p:cNvSpPr/>
           <p:nvPr/>
         </p:nvSpPr>
@@ -5112,7 +4956,7 @@
       </p:sp>
       <p:sp>
         <p:nvSpPr>
-          <p:cNvPr id="27" name="Text 25"/>
+          <p:cNvPr id="26" name="Text 24"/>
           <p:cNvSpPr txBox="1"/>
           <p:nvPr/>
         </p:nvSpPr>
@@ -5151,7 +4995,7 @@
       </p:sp>
       <p:sp>
         <p:nvSpPr>
-          <p:cNvPr id="28" name="Shape 26"/>
+          <p:cNvPr id="27" name="Shape 25"/>
           <p:cNvSpPr/>
           <p:nvPr/>
         </p:nvSpPr>
@@ -5178,7 +5022,7 @@
       </p:sp>
       <p:sp>
         <p:nvSpPr>
-          <p:cNvPr id="29" name="Text 27"/>
+          <p:cNvPr id="28" name="Text 26"/>
           <p:cNvSpPr txBox="1"/>
           <p:nvPr/>
         </p:nvSpPr>
@@ -5217,7 +5061,7 @@
       </p:sp>
       <p:sp>
         <p:nvSpPr>
-          <p:cNvPr id="30" name="Text 28"/>
+          <p:cNvPr id="29" name="Text 27"/>
           <p:cNvSpPr txBox="1"/>
           <p:nvPr/>
         </p:nvSpPr>
@@ -5294,8 +5138,8 @@
         </p:nvSpPr>
         <p:spPr>
           <a:xfrm>
-            <a:off x="7680960" y="73152"/>
-            <a:ext cx="1280160" cy="228600"/>
+            <a:off x="457200" y="292608"/>
+            <a:ext cx="8229600" cy="640080"/>
           </a:xfrm>
           <a:prstGeom prst="rect">
             <a:avLst/>
@@ -5307,45 +5151,6 @@
           <a:bodyPr wrap="square" lIns="0" tIns="0" rIns="0" bIns="0" rtlCol="0" anchor="ctr"/>
           <a:lstStyle/>
           <a:p>
-            <a:pPr algn="r" indent="0" marL="0">
-              <a:buNone/>
-            </a:pPr>
-            <a:r>
-              <a:rPr lang="en-US" sz="900" dirty="0">
-                <a:solidFill>
-                  <a:srgbClr val="5F6B7A"/>
-                </a:solidFill>
-                <a:latin typeface="Arial" pitchFamily="34" charset="0"/>
-                <a:ea typeface="Arial" pitchFamily="34" charset="-122"/>
-                <a:cs typeface="Arial" pitchFamily="34" charset="-120"/>
-              </a:rPr>
-              <a:t>13  ·  12s</a:t>
-            </a:r>
-            <a:endParaRPr lang="en-US" sz="900" dirty="0"/>
-          </a:p>
-        </p:txBody>
-      </p:sp>
-      <p:sp>
-        <p:nvSpPr>
-          <p:cNvPr id="3" name="Text 1"/>
-          <p:cNvSpPr txBox="1"/>
-          <p:nvPr/>
-        </p:nvSpPr>
-        <p:spPr>
-          <a:xfrm>
-            <a:off x="457200" y="292608"/>
-            <a:ext cx="8229600" cy="640080"/>
-          </a:xfrm>
-          <a:prstGeom prst="rect">
-            <a:avLst/>
-          </a:prstGeom>
-          <a:noFill/>
-          <a:ln/>
-        </p:spPr>
-        <p:txBody>
-          <a:bodyPr wrap="square" lIns="0" tIns="0" rIns="0" bIns="0" rtlCol="0" anchor="ctr"/>
-          <a:lstStyle/>
-          <a:p>
             <a:pPr indent="0" marL="0">
               <a:buNone/>
             </a:pPr>
@@ -5366,7 +5171,7 @@
       </p:sp>
       <p:pic>
         <p:nvPicPr>
-          <p:cNvPr id="4" name="Image 0" descr="/tmp/claude-0/-home-user-BiVLA/4327cefa-ba5d-5e2e-9d87-c73dd3a8ccbb/scratchpad/video_ppt/assets/consistency.png">    </p:cNvPr>
+          <p:cNvPr id="3" name="Image 0" descr="/tmp/claude-0/-home-user-BiVLA/4327cefa-ba5d-5e2e-9d87-c73dd3a8ccbb/scratchpad/video_ppt/assets/consistency.png">    </p:cNvPr>
           <p:cNvPicPr>
             <a:picLocks noChangeAspect="1"/>
           </p:cNvPicPr>
@@ -5390,7 +5195,7 @@
       </p:pic>
       <p:sp>
         <p:nvSpPr>
-          <p:cNvPr id="5" name="Text 2"/>
+          <p:cNvPr id="4" name="Text 1"/>
           <p:cNvSpPr txBox="1"/>
           <p:nvPr/>
         </p:nvSpPr>
@@ -5429,7 +5234,7 @@
       </p:sp>
       <p:sp>
         <p:nvSpPr>
-          <p:cNvPr id="6" name="Shape 3"/>
+          <p:cNvPr id="5" name="Shape 2"/>
           <p:cNvSpPr/>
           <p:nvPr/>
         </p:nvSpPr>
@@ -5456,14 +5261,53 @@
       </p:sp>
       <p:sp>
         <p:nvSpPr>
+          <p:cNvPr id="6" name="Text 3"/>
+          <p:cNvSpPr txBox="1"/>
+          <p:nvPr/>
+        </p:nvSpPr>
+        <p:spPr>
+          <a:xfrm>
+            <a:off x="5852160" y="1005840"/>
+            <a:ext cx="1234440" cy="365760"/>
+          </a:xfrm>
+          <a:prstGeom prst="rect">
+            <a:avLst/>
+          </a:prstGeom>
+          <a:noFill/>
+          <a:ln/>
+        </p:spPr>
+        <p:txBody>
+          <a:bodyPr wrap="square" lIns="0" tIns="0" rIns="0" bIns="0" rtlCol="0" anchor="ctr"/>
+          <a:lstStyle/>
+          <a:p>
+            <a:pPr algn="ctr" indent="0" marL="0">
+              <a:buNone/>
+            </a:pPr>
+            <a:r>
+              <a:rPr lang="en-US" sz="1100" b="1" dirty="0">
+                <a:solidFill>
+                  <a:srgbClr val="F5F7FA"/>
+                </a:solidFill>
+                <a:latin typeface="Arial" pitchFamily="34" charset="0"/>
+                <a:ea typeface="Arial" pitchFamily="34" charset="-122"/>
+                <a:cs typeface="Arial" pitchFamily="34" charset="-120"/>
+              </a:rPr>
+              <a:t>Q3  Transfer</a:t>
+            </a:r>
+            <a:endParaRPr lang="en-US" sz="1100" dirty="0"/>
+          </a:p>
+        </p:txBody>
+      </p:sp>
+      <p:sp>
+        <p:nvSpPr>
           <p:cNvPr id="7" name="Text 4"/>
           <p:cNvSpPr txBox="1"/>
           <p:nvPr/>
         </p:nvSpPr>
         <p:spPr>
           <a:xfrm>
-            <a:off x="5852160" y="1005840"/>
-            <a:ext cx="1234440" cy="365760"/>
+            <a:off x="5852160" y="1417320"/>
+            <a:ext cx="2834640" cy="502920"/>
           </a:xfrm>
           <a:prstGeom prst="rect">
             <a:avLst/>
@@ -5475,45 +5319,6 @@
           <a:bodyPr wrap="square" lIns="0" tIns="0" rIns="0" bIns="0" rtlCol="0" anchor="ctr"/>
           <a:lstStyle/>
           <a:p>
-            <a:pPr algn="ctr" indent="0" marL="0">
-              <a:buNone/>
-            </a:pPr>
-            <a:r>
-              <a:rPr lang="en-US" sz="1100" b="1" dirty="0">
-                <a:solidFill>
-                  <a:srgbClr val="F5F7FA"/>
-                </a:solidFill>
-                <a:latin typeface="Arial" pitchFamily="34" charset="0"/>
-                <a:ea typeface="Arial" pitchFamily="34" charset="-122"/>
-                <a:cs typeface="Arial" pitchFamily="34" charset="-120"/>
-              </a:rPr>
-              <a:t>Q3  Transfer</a:t>
-            </a:r>
-            <a:endParaRPr lang="en-US" sz="1100" dirty="0"/>
-          </a:p>
-        </p:txBody>
-      </p:sp>
-      <p:sp>
-        <p:nvSpPr>
-          <p:cNvPr id="8" name="Text 5"/>
-          <p:cNvSpPr txBox="1"/>
-          <p:nvPr/>
-        </p:nvSpPr>
-        <p:spPr>
-          <a:xfrm>
-            <a:off x="5852160" y="1417320"/>
-            <a:ext cx="2834640" cy="502920"/>
-          </a:xfrm>
-          <a:prstGeom prst="rect">
-            <a:avLst/>
-          </a:prstGeom>
-          <a:noFill/>
-          <a:ln/>
-        </p:spPr>
-        <p:txBody>
-          <a:bodyPr wrap="square" lIns="0" tIns="0" rIns="0" bIns="0" rtlCol="0" anchor="ctr"/>
-          <a:lstStyle/>
-          <a:p>
             <a:pPr indent="0" marL="0">
               <a:buNone/>
             </a:pPr>
@@ -5534,7 +5339,7 @@
       </p:sp>
       <p:sp>
         <p:nvSpPr>
-          <p:cNvPr id="9" name="Shape 6"/>
+          <p:cNvPr id="8" name="Shape 5"/>
           <p:cNvSpPr/>
           <p:nvPr/>
         </p:nvSpPr>
@@ -5561,7 +5366,7 @@
       </p:sp>
       <p:sp>
         <p:nvSpPr>
-          <p:cNvPr id="10" name="Text 7"/>
+          <p:cNvPr id="9" name="Text 6"/>
           <p:cNvSpPr txBox="1"/>
           <p:nvPr/>
         </p:nvSpPr>
@@ -5600,7 +5405,7 @@
       </p:sp>
       <p:sp>
         <p:nvSpPr>
-          <p:cNvPr id="11" name="Shape 8"/>
+          <p:cNvPr id="10" name="Shape 7"/>
           <p:cNvSpPr/>
           <p:nvPr/>
         </p:nvSpPr>
@@ -5627,7 +5432,7 @@
       </p:sp>
       <p:sp>
         <p:nvSpPr>
-          <p:cNvPr id="12" name="Text 9"/>
+          <p:cNvPr id="11" name="Text 8"/>
           <p:cNvSpPr txBox="1"/>
           <p:nvPr/>
         </p:nvSpPr>
@@ -5666,7 +5471,7 @@
       </p:sp>
       <p:sp>
         <p:nvSpPr>
-          <p:cNvPr id="13" name="Shape 10"/>
+          <p:cNvPr id="12" name="Shape 9"/>
           <p:cNvSpPr/>
           <p:nvPr/>
         </p:nvSpPr>
@@ -5693,7 +5498,7 @@
       </p:sp>
       <p:sp>
         <p:nvSpPr>
-          <p:cNvPr id="14" name="Text 11"/>
+          <p:cNvPr id="13" name="Text 10"/>
           <p:cNvSpPr txBox="1"/>
           <p:nvPr/>
         </p:nvSpPr>
@@ -5732,7 +5537,7 @@
       </p:sp>
       <p:sp>
         <p:nvSpPr>
-          <p:cNvPr id="15" name="Shape 12"/>
+          <p:cNvPr id="14" name="Shape 11"/>
           <p:cNvSpPr/>
           <p:nvPr/>
         </p:nvSpPr>
@@ -5759,7 +5564,7 @@
       </p:sp>
       <p:sp>
         <p:nvSpPr>
-          <p:cNvPr id="16" name="Text 13"/>
+          <p:cNvPr id="15" name="Text 12"/>
           <p:cNvSpPr txBox="1"/>
           <p:nvPr/>
         </p:nvSpPr>
@@ -5836,8 +5641,8 @@
         </p:nvSpPr>
         <p:spPr>
           <a:xfrm>
-            <a:off x="7680960" y="73152"/>
-            <a:ext cx="1280160" cy="228600"/>
+            <a:off x="457200" y="292608"/>
+            <a:ext cx="8229600" cy="640080"/>
           </a:xfrm>
           <a:prstGeom prst="rect">
             <a:avLst/>
@@ -5849,45 +5654,6 @@
           <a:bodyPr wrap="square" lIns="0" tIns="0" rIns="0" bIns="0" rtlCol="0" anchor="ctr"/>
           <a:lstStyle/>
           <a:p>
-            <a:pPr algn="r" indent="0" marL="0">
-              <a:buNone/>
-            </a:pPr>
-            <a:r>
-              <a:rPr lang="en-US" sz="900" dirty="0">
-                <a:solidFill>
-                  <a:srgbClr val="5F6B7A"/>
-                </a:solidFill>
-                <a:latin typeface="Arial" pitchFamily="34" charset="0"/>
-                <a:ea typeface="Arial" pitchFamily="34" charset="-122"/>
-                <a:cs typeface="Arial" pitchFamily="34" charset="-120"/>
-              </a:rPr>
-              <a:t>14  ·  12s</a:t>
-            </a:r>
-            <a:endParaRPr lang="en-US" sz="900" dirty="0"/>
-          </a:p>
-        </p:txBody>
-      </p:sp>
-      <p:sp>
-        <p:nvSpPr>
-          <p:cNvPr id="3" name="Text 1"/>
-          <p:cNvSpPr txBox="1"/>
-          <p:nvPr/>
-        </p:nvSpPr>
-        <p:spPr>
-          <a:xfrm>
-            <a:off x="457200" y="292608"/>
-            <a:ext cx="8229600" cy="640080"/>
-          </a:xfrm>
-          <a:prstGeom prst="rect">
-            <a:avLst/>
-          </a:prstGeom>
-          <a:noFill/>
-          <a:ln/>
-        </p:spPr>
-        <p:txBody>
-          <a:bodyPr wrap="square" lIns="0" tIns="0" rIns="0" bIns="0" rtlCol="0" anchor="ctr"/>
-          <a:lstStyle/>
-          <a:p>
             <a:pPr indent="0" marL="0">
               <a:buNone/>
             </a:pPr>
@@ -5908,7 +5674,7 @@
       </p:sp>
       <p:sp>
         <p:nvSpPr>
-          <p:cNvPr id="4" name="Shape 2"/>
+          <p:cNvPr id="3" name="Shape 1"/>
           <p:cNvSpPr/>
           <p:nvPr/>
         </p:nvSpPr>
@@ -5935,14 +5701,53 @@
       </p:sp>
       <p:sp>
         <p:nvSpPr>
+          <p:cNvPr id="4" name="Text 2"/>
+          <p:cNvSpPr txBox="1"/>
+          <p:nvPr/>
+        </p:nvSpPr>
+        <p:spPr>
+          <a:xfrm>
+            <a:off x="640080" y="1115568"/>
+            <a:ext cx="3657600" cy="365760"/>
+          </a:xfrm>
+          <a:prstGeom prst="rect">
+            <a:avLst/>
+          </a:prstGeom>
+          <a:noFill/>
+          <a:ln/>
+        </p:spPr>
+        <p:txBody>
+          <a:bodyPr wrap="square" lIns="0" tIns="0" rIns="0" bIns="0" rtlCol="0" anchor="ctr"/>
+          <a:lstStyle/>
+          <a:p>
+            <a:pPr indent="0" marL="0">
+              <a:buNone/>
+            </a:pPr>
+            <a:r>
+              <a:rPr lang="en-US" sz="1600" b="1" dirty="0">
+                <a:solidFill>
+                  <a:srgbClr val="2E8B57"/>
+                </a:solidFill>
+                <a:latin typeface="Arial" pitchFamily="34" charset="0"/>
+                <a:ea typeface="Arial" pitchFamily="34" charset="-122"/>
+                <a:cs typeface="Arial" pitchFamily="34" charset="-120"/>
+              </a:rPr>
+              <a:t>Guarded reuse</a:t>
+            </a:r>
+            <a:endParaRPr lang="en-US" sz="1600" dirty="0"/>
+          </a:p>
+        </p:txBody>
+      </p:sp>
+      <p:sp>
+        <p:nvSpPr>
           <p:cNvPr id="5" name="Text 3"/>
           <p:cNvSpPr txBox="1"/>
           <p:nvPr/>
         </p:nvSpPr>
         <p:spPr>
           <a:xfrm>
-            <a:off x="640080" y="1115568"/>
-            <a:ext cx="3657600" cy="365760"/>
+            <a:off x="640080" y="1481328"/>
+            <a:ext cx="3657600" cy="640080"/>
           </a:xfrm>
           <a:prstGeom prst="rect">
             <a:avLst/>
@@ -5951,52 +5756,13 @@
           <a:ln/>
         </p:spPr>
         <p:txBody>
-          <a:bodyPr wrap="square" lIns="0" tIns="0" rIns="0" bIns="0" rtlCol="0" anchor="ctr"/>
+          <a:bodyPr wrap="square" lIns="0" tIns="0" rIns="0" bIns="0" rtlCol="0" anchor="t"/>
           <a:lstStyle/>
           <a:p>
             <a:pPr indent="0" marL="0">
               <a:buNone/>
             </a:pPr>
             <a:r>
-              <a:rPr lang="en-US" sz="1600" b="1" dirty="0">
-                <a:solidFill>
-                  <a:srgbClr val="2E8B57"/>
-                </a:solidFill>
-                <a:latin typeface="Arial" pitchFamily="34" charset="0"/>
-                <a:ea typeface="Arial" pitchFamily="34" charset="-122"/>
-                <a:cs typeface="Arial" pitchFamily="34" charset="-120"/>
-              </a:rPr>
-              <a:t>Guarded reuse</a:t>
-            </a:r>
-            <a:endParaRPr lang="en-US" sz="1600" dirty="0"/>
-          </a:p>
-        </p:txBody>
-      </p:sp>
-      <p:sp>
-        <p:nvSpPr>
-          <p:cNvPr id="6" name="Text 4"/>
-          <p:cNvSpPr txBox="1"/>
-          <p:nvPr/>
-        </p:nvSpPr>
-        <p:spPr>
-          <a:xfrm>
-            <a:off x="640080" y="1481328"/>
-            <a:ext cx="3657600" cy="640080"/>
-          </a:xfrm>
-          <a:prstGeom prst="rect">
-            <a:avLst/>
-          </a:prstGeom>
-          <a:noFill/>
-          <a:ln/>
-        </p:spPr>
-        <p:txBody>
-          <a:bodyPr wrap="square" lIns="0" tIns="0" rIns="0" bIns="0" rtlCol="0" anchor="t"/>
-          <a:lstStyle/>
-          <a:p>
-            <a:pPr indent="0" marL="0">
-              <a:buNone/>
-            </a:pPr>
-            <a:r>
               <a:rPr lang="en-US" sz="1250" dirty="0">
                 <a:solidFill>
                   <a:srgbClr val="1F2933"/>
@@ -6013,7 +5779,7 @@
       </p:sp>
       <p:sp>
         <p:nvSpPr>
-          <p:cNvPr id="7" name="Shape 5"/>
+          <p:cNvPr id="6" name="Shape 4"/>
           <p:cNvSpPr/>
           <p:nvPr/>
         </p:nvSpPr>
@@ -6040,14 +5806,53 @@
       </p:sp>
       <p:sp>
         <p:nvSpPr>
+          <p:cNvPr id="7" name="Text 5"/>
+          <p:cNvSpPr txBox="1"/>
+          <p:nvPr/>
+        </p:nvSpPr>
+        <p:spPr>
+          <a:xfrm>
+            <a:off x="4846320" y="1115568"/>
+            <a:ext cx="3657600" cy="365760"/>
+          </a:xfrm>
+          <a:prstGeom prst="rect">
+            <a:avLst/>
+          </a:prstGeom>
+          <a:noFill/>
+          <a:ln/>
+        </p:spPr>
+        <p:txBody>
+          <a:bodyPr wrap="square" lIns="0" tIns="0" rIns="0" bIns="0" rtlCol="0" anchor="ctr"/>
+          <a:lstStyle/>
+          <a:p>
+            <a:pPr indent="0" marL="0">
+              <a:buNone/>
+            </a:pPr>
+            <a:r>
+              <a:rPr lang="en-US" sz="1600" b="1" dirty="0">
+                <a:solidFill>
+                  <a:srgbClr val="C8641E"/>
+                </a:solidFill>
+                <a:latin typeface="Arial" pitchFamily="34" charset="0"/>
+                <a:ea typeface="Arial" pitchFamily="34" charset="-122"/>
+                <a:cs typeface="Arial" pitchFamily="34" charset="-120"/>
+              </a:rPr>
+              <a:t>Action repeat</a:t>
+            </a:r>
+            <a:endParaRPr lang="en-US" sz="1600" dirty="0"/>
+          </a:p>
+        </p:txBody>
+      </p:sp>
+      <p:sp>
+        <p:nvSpPr>
           <p:cNvPr id="8" name="Text 6"/>
           <p:cNvSpPr txBox="1"/>
           <p:nvPr/>
         </p:nvSpPr>
         <p:spPr>
           <a:xfrm>
-            <a:off x="4846320" y="1115568"/>
-            <a:ext cx="3657600" cy="365760"/>
+            <a:off x="4846320" y="1481328"/>
+            <a:ext cx="3657600" cy="640080"/>
           </a:xfrm>
           <a:prstGeom prst="rect">
             <a:avLst/>
@@ -6056,52 +5861,13 @@
           <a:ln/>
         </p:spPr>
         <p:txBody>
-          <a:bodyPr wrap="square" lIns="0" tIns="0" rIns="0" bIns="0" rtlCol="0" anchor="ctr"/>
+          <a:bodyPr wrap="square" lIns="0" tIns="0" rIns="0" bIns="0" rtlCol="0" anchor="t"/>
           <a:lstStyle/>
           <a:p>
             <a:pPr indent="0" marL="0">
               <a:buNone/>
             </a:pPr>
             <a:r>
-              <a:rPr lang="en-US" sz="1600" b="1" dirty="0">
-                <a:solidFill>
-                  <a:srgbClr val="C8641E"/>
-                </a:solidFill>
-                <a:latin typeface="Arial" pitchFamily="34" charset="0"/>
-                <a:ea typeface="Arial" pitchFamily="34" charset="-122"/>
-                <a:cs typeface="Arial" pitchFamily="34" charset="-120"/>
-              </a:rPr>
-              <a:t>Action repeat</a:t>
-            </a:r>
-            <a:endParaRPr lang="en-US" sz="1600" dirty="0"/>
-          </a:p>
-        </p:txBody>
-      </p:sp>
-      <p:sp>
-        <p:nvSpPr>
-          <p:cNvPr id="9" name="Text 7"/>
-          <p:cNvSpPr txBox="1"/>
-          <p:nvPr/>
-        </p:nvSpPr>
-        <p:spPr>
-          <a:xfrm>
-            <a:off x="4846320" y="1481328"/>
-            <a:ext cx="3657600" cy="640080"/>
-          </a:xfrm>
-          <a:prstGeom prst="rect">
-            <a:avLst/>
-          </a:prstGeom>
-          <a:noFill/>
-          <a:ln/>
-        </p:spPr>
-        <p:txBody>
-          <a:bodyPr wrap="square" lIns="0" tIns="0" rIns="0" bIns="0" rtlCol="0" anchor="t"/>
-          <a:lstStyle/>
-          <a:p>
-            <a:pPr indent="0" marL="0">
-              <a:buNone/>
-            </a:pPr>
-            <a:r>
               <a:rPr lang="en-US" sz="1250" dirty="0">
                 <a:solidFill>
                   <a:srgbClr val="1F2933"/>
@@ -6118,7 +5884,7 @@
       </p:sp>
       <p:sp>
         <p:nvSpPr>
-          <p:cNvPr id="10" name="Shape 8"/>
+          <p:cNvPr id="9" name="Shape 7"/>
           <p:cNvSpPr/>
           <p:nvPr/>
         </p:nvSpPr>
@@ -6145,14 +5911,53 @@
       </p:sp>
       <p:sp>
         <p:nvSpPr>
+          <p:cNvPr id="10" name="Text 8"/>
+          <p:cNvSpPr txBox="1"/>
+          <p:nvPr/>
+        </p:nvSpPr>
+        <p:spPr>
+          <a:xfrm>
+            <a:off x="640080" y="2487168"/>
+            <a:ext cx="3657600" cy="365760"/>
+          </a:xfrm>
+          <a:prstGeom prst="rect">
+            <a:avLst/>
+          </a:prstGeom>
+          <a:noFill/>
+          <a:ln/>
+        </p:spPr>
+        <p:txBody>
+          <a:bodyPr wrap="square" lIns="0" tIns="0" rIns="0" bIns="0" rtlCol="0" anchor="ctr"/>
+          <a:lstStyle/>
+          <a:p>
+            <a:pPr indent="0" marL="0">
+              <a:buNone/>
+            </a:pPr>
+            <a:r>
+              <a:rPr lang="en-US" sz="1600" b="1" dirty="0">
+                <a:solidFill>
+                  <a:srgbClr val="1B7F79"/>
+                </a:solidFill>
+                <a:latin typeface="Arial" pitchFamily="34" charset="0"/>
+                <a:ea typeface="Arial" pitchFamily="34" charset="-122"/>
+                <a:cs typeface="Arial" pitchFamily="34" charset="-120"/>
+              </a:rPr>
+              <a:t>Depth pruning</a:t>
+            </a:r>
+            <a:endParaRPr lang="en-US" sz="1600" dirty="0"/>
+          </a:p>
+        </p:txBody>
+      </p:sp>
+      <p:sp>
+        <p:nvSpPr>
           <p:cNvPr id="11" name="Text 9"/>
           <p:cNvSpPr txBox="1"/>
           <p:nvPr/>
         </p:nvSpPr>
         <p:spPr>
           <a:xfrm>
-            <a:off x="640080" y="2487168"/>
-            <a:ext cx="3657600" cy="365760"/>
+            <a:off x="640080" y="2852928"/>
+            <a:ext cx="3657600" cy="640080"/>
           </a:xfrm>
           <a:prstGeom prst="rect">
             <a:avLst/>
@@ -6161,52 +5966,13 @@
           <a:ln/>
         </p:spPr>
         <p:txBody>
-          <a:bodyPr wrap="square" lIns="0" tIns="0" rIns="0" bIns="0" rtlCol="0" anchor="ctr"/>
+          <a:bodyPr wrap="square" lIns="0" tIns="0" rIns="0" bIns="0" rtlCol="0" anchor="t"/>
           <a:lstStyle/>
           <a:p>
             <a:pPr indent="0" marL="0">
               <a:buNone/>
             </a:pPr>
             <a:r>
-              <a:rPr lang="en-US" sz="1600" b="1" dirty="0">
-                <a:solidFill>
-                  <a:srgbClr val="1B7F79"/>
-                </a:solidFill>
-                <a:latin typeface="Arial" pitchFamily="34" charset="0"/>
-                <a:ea typeface="Arial" pitchFamily="34" charset="-122"/>
-                <a:cs typeface="Arial" pitchFamily="34" charset="-120"/>
-              </a:rPr>
-              <a:t>Depth pruning</a:t>
-            </a:r>
-            <a:endParaRPr lang="en-US" sz="1600" dirty="0"/>
-          </a:p>
-        </p:txBody>
-      </p:sp>
-      <p:sp>
-        <p:nvSpPr>
-          <p:cNvPr id="12" name="Text 10"/>
-          <p:cNvSpPr txBox="1"/>
-          <p:nvPr/>
-        </p:nvSpPr>
-        <p:spPr>
-          <a:xfrm>
-            <a:off x="640080" y="2852928"/>
-            <a:ext cx="3657600" cy="640080"/>
-          </a:xfrm>
-          <a:prstGeom prst="rect">
-            <a:avLst/>
-          </a:prstGeom>
-          <a:noFill/>
-          <a:ln/>
-        </p:spPr>
-        <p:txBody>
-          <a:bodyPr wrap="square" lIns="0" tIns="0" rIns="0" bIns="0" rtlCol="0" anchor="t"/>
-          <a:lstStyle/>
-          <a:p>
-            <a:pPr indent="0" marL="0">
-              <a:buNone/>
-            </a:pPr>
-            <a:r>
               <a:rPr lang="en-US" sz="1250" dirty="0">
                 <a:solidFill>
                   <a:srgbClr val="1F2933"/>
@@ -6223,7 +5989,7 @@
       </p:sp>
       <p:sp>
         <p:nvSpPr>
-          <p:cNvPr id="13" name="Shape 11"/>
+          <p:cNvPr id="12" name="Shape 10"/>
           <p:cNvSpPr/>
           <p:nvPr/>
         </p:nvSpPr>
@@ -6250,14 +6016,53 @@
       </p:sp>
       <p:sp>
         <p:nvSpPr>
+          <p:cNvPr id="13" name="Text 11"/>
+          <p:cNvSpPr txBox="1"/>
+          <p:nvPr/>
+        </p:nvSpPr>
+        <p:spPr>
+          <a:xfrm>
+            <a:off x="4846320" y="2487168"/>
+            <a:ext cx="3657600" cy="365760"/>
+          </a:xfrm>
+          <a:prstGeom prst="rect">
+            <a:avLst/>
+          </a:prstGeom>
+          <a:noFill/>
+          <a:ln/>
+        </p:spPr>
+        <p:txBody>
+          <a:bodyPr wrap="square" lIns="0" tIns="0" rIns="0" bIns="0" rtlCol="0" anchor="ctr"/>
+          <a:lstStyle/>
+          <a:p>
+            <a:pPr indent="0" marL="0">
+              <a:buNone/>
+            </a:pPr>
+            <a:r>
+              <a:rPr lang="en-US" sz="1600" b="1" dirty="0">
+                <a:solidFill>
+                  <a:srgbClr val="2F6DB5"/>
+                </a:solidFill>
+                <a:latin typeface="Arial" pitchFamily="34" charset="0"/>
+                <a:ea typeface="Arial" pitchFamily="34" charset="-122"/>
+                <a:cs typeface="Arial" pitchFamily="34" charset="-120"/>
+              </a:rPr>
+              <a:t>Foveation · Temporal fusion</a:t>
+            </a:r>
+            <a:endParaRPr lang="en-US" sz="1600" dirty="0"/>
+          </a:p>
+        </p:txBody>
+      </p:sp>
+      <p:sp>
+        <p:nvSpPr>
           <p:cNvPr id="14" name="Text 12"/>
           <p:cNvSpPr txBox="1"/>
           <p:nvPr/>
         </p:nvSpPr>
         <p:spPr>
           <a:xfrm>
-            <a:off x="4846320" y="2487168"/>
-            <a:ext cx="3657600" cy="365760"/>
+            <a:off x="4846320" y="2852928"/>
+            <a:ext cx="3657600" cy="640080"/>
           </a:xfrm>
           <a:prstGeom prst="rect">
             <a:avLst/>
@@ -6266,52 +6071,13 @@
           <a:ln/>
         </p:spPr>
         <p:txBody>
-          <a:bodyPr wrap="square" lIns="0" tIns="0" rIns="0" bIns="0" rtlCol="0" anchor="ctr"/>
+          <a:bodyPr wrap="square" lIns="0" tIns="0" rIns="0" bIns="0" rtlCol="0" anchor="t"/>
           <a:lstStyle/>
           <a:p>
             <a:pPr indent="0" marL="0">
               <a:buNone/>
             </a:pPr>
             <a:r>
-              <a:rPr lang="en-US" sz="1600" b="1" dirty="0">
-                <a:solidFill>
-                  <a:srgbClr val="2F6DB5"/>
-                </a:solidFill>
-                <a:latin typeface="Arial" pitchFamily="34" charset="0"/>
-                <a:ea typeface="Arial" pitchFamily="34" charset="-122"/>
-                <a:cs typeface="Arial" pitchFamily="34" charset="-120"/>
-              </a:rPr>
-              <a:t>Foveation · Temporal fusion</a:t>
-            </a:r>
-            <a:endParaRPr lang="en-US" sz="1600" dirty="0"/>
-          </a:p>
-        </p:txBody>
-      </p:sp>
-      <p:sp>
-        <p:nvSpPr>
-          <p:cNvPr id="15" name="Text 13"/>
-          <p:cNvSpPr txBox="1"/>
-          <p:nvPr/>
-        </p:nvSpPr>
-        <p:spPr>
-          <a:xfrm>
-            <a:off x="4846320" y="2852928"/>
-            <a:ext cx="3657600" cy="640080"/>
-          </a:xfrm>
-          <a:prstGeom prst="rect">
-            <a:avLst/>
-          </a:prstGeom>
-          <a:noFill/>
-          <a:ln/>
-        </p:spPr>
-        <p:txBody>
-          <a:bodyPr wrap="square" lIns="0" tIns="0" rIns="0" bIns="0" rtlCol="0" anchor="t"/>
-          <a:lstStyle/>
-          <a:p>
-            <a:pPr indent="0" marL="0">
-              <a:buNone/>
-            </a:pPr>
-            <a:r>
               <a:rPr lang="en-US" sz="1250" dirty="0">
                 <a:solidFill>
                   <a:srgbClr val="1F2933"/>
@@ -6328,7 +6094,7 @@
       </p:sp>
       <p:sp>
         <p:nvSpPr>
-          <p:cNvPr id="16" name="Shape 14"/>
+          <p:cNvPr id="15" name="Shape 13"/>
           <p:cNvSpPr/>
           <p:nvPr/>
         </p:nvSpPr>
@@ -6355,7 +6121,7 @@
       </p:sp>
       <p:sp>
         <p:nvSpPr>
-          <p:cNvPr id="17" name="Text 15"/>
+          <p:cNvPr id="16" name="Text 14"/>
           <p:cNvSpPr txBox="1"/>
           <p:nvPr/>
         </p:nvSpPr>
@@ -6432,8 +6198,8 @@
         </p:nvSpPr>
         <p:spPr>
           <a:xfrm>
-            <a:off x="7680960" y="73152"/>
-            <a:ext cx="1280160" cy="228600"/>
+            <a:off x="457200" y="292608"/>
+            <a:ext cx="8229600" cy="640080"/>
           </a:xfrm>
           <a:prstGeom prst="rect">
             <a:avLst/>
@@ -6445,45 +6211,6 @@
           <a:bodyPr wrap="square" lIns="0" tIns="0" rIns="0" bIns="0" rtlCol="0" anchor="ctr"/>
           <a:lstStyle/>
           <a:p>
-            <a:pPr algn="r" indent="0" marL="0">
-              <a:buNone/>
-            </a:pPr>
-            <a:r>
-              <a:rPr lang="en-US" sz="900" dirty="0">
-                <a:solidFill>
-                  <a:srgbClr val="5F6B7A"/>
-                </a:solidFill>
-                <a:latin typeface="Arial" pitchFamily="34" charset="0"/>
-                <a:ea typeface="Arial" pitchFamily="34" charset="-122"/>
-                <a:cs typeface="Arial" pitchFamily="34" charset="-120"/>
-              </a:rPr>
-              <a:t>2  ·  11s</a:t>
-            </a:r>
-            <a:endParaRPr lang="en-US" sz="900" dirty="0"/>
-          </a:p>
-        </p:txBody>
-      </p:sp>
-      <p:sp>
-        <p:nvSpPr>
-          <p:cNvPr id="3" name="Text 1"/>
-          <p:cNvSpPr txBox="1"/>
-          <p:nvPr/>
-        </p:nvSpPr>
-        <p:spPr>
-          <a:xfrm>
-            <a:off x="457200" y="292608"/>
-            <a:ext cx="8229600" cy="640080"/>
-          </a:xfrm>
-          <a:prstGeom prst="rect">
-            <a:avLst/>
-          </a:prstGeom>
-          <a:noFill/>
-          <a:ln/>
-        </p:spPr>
-        <p:txBody>
-          <a:bodyPr wrap="square" lIns="0" tIns="0" rIns="0" bIns="0" rtlCol="0" anchor="ctr"/>
-          <a:lstStyle/>
-          <a:p>
             <a:pPr indent="0" marL="0">
               <a:buNone/>
             </a:pPr>
@@ -6504,7 +6231,7 @@
       </p:sp>
       <p:sp>
         <p:nvSpPr>
-          <p:cNvPr id="4" name="Shape 2"/>
+          <p:cNvPr id="3" name="Shape 1"/>
           <p:cNvSpPr/>
           <p:nvPr/>
         </p:nvSpPr>
@@ -6531,7 +6258,7 @@
       </p:sp>
       <p:sp>
         <p:nvSpPr>
-          <p:cNvPr id="5" name="Text 3"/>
+          <p:cNvPr id="4" name="Text 2"/>
           <p:cNvSpPr txBox="1"/>
           <p:nvPr/>
         </p:nvSpPr>
@@ -6570,7 +6297,7 @@
       </p:sp>
       <p:pic>
         <p:nvPicPr>
-          <p:cNvPr id="6" name="Image 0" descr="/tmp/claude-0/-home-user-BiVLA/4327cefa-ba5d-5e2e-9d87-c73dd3a8ccbb/scratchpad/video_ppt/assets/m_fov.png">    </p:cNvPr>
+          <p:cNvPr id="5" name="Image 0" descr="/tmp/claude-0/-home-user-BiVLA/4327cefa-ba5d-5e2e-9d87-c73dd3a8ccbb/scratchpad/video_ppt/assets/m_fov.png">    </p:cNvPr>
           <p:cNvPicPr>
             <a:picLocks noChangeAspect="1"/>
           </p:cNvPicPr>
@@ -6594,7 +6321,7 @@
       </p:pic>
       <p:sp>
         <p:nvSpPr>
-          <p:cNvPr id="7" name="Text 4"/>
+          <p:cNvPr id="6" name="Text 3"/>
           <p:cNvSpPr txBox="1"/>
           <p:nvPr/>
         </p:nvSpPr>
@@ -6679,7 +6406,7 @@
       </p:sp>
       <p:sp>
         <p:nvSpPr>
-          <p:cNvPr id="8" name="Shape 5"/>
+          <p:cNvPr id="7" name="Shape 4"/>
           <p:cNvSpPr/>
           <p:nvPr/>
         </p:nvSpPr>
@@ -6706,7 +6433,7 @@
       </p:sp>
       <p:sp>
         <p:nvSpPr>
-          <p:cNvPr id="9" name="Shape 6"/>
+          <p:cNvPr id="8" name="Shape 5"/>
           <p:cNvSpPr/>
           <p:nvPr/>
         </p:nvSpPr>
@@ -6731,7 +6458,7 @@
       </p:sp>
       <p:sp>
         <p:nvSpPr>
-          <p:cNvPr id="10" name="Shape 7"/>
+          <p:cNvPr id="9" name="Shape 6"/>
           <p:cNvSpPr/>
           <p:nvPr/>
         </p:nvSpPr>
@@ -6756,14 +6483,53 @@
       </p:sp>
       <p:sp>
         <p:nvSpPr>
+          <p:cNvPr id="10" name="Text 7"/>
+          <p:cNvSpPr txBox="1"/>
+          <p:nvPr/>
+        </p:nvSpPr>
+        <p:spPr>
+          <a:xfrm>
+            <a:off x="4846320" y="2583180"/>
+            <a:ext cx="3749040" cy="274320"/>
+          </a:xfrm>
+          <a:prstGeom prst="rect">
+            <a:avLst/>
+          </a:prstGeom>
+          <a:noFill/>
+          <a:ln/>
+        </p:spPr>
+        <p:txBody>
+          <a:bodyPr wrap="square" lIns="0" tIns="0" rIns="0" bIns="0" rtlCol="0" anchor="ctr"/>
+          <a:lstStyle/>
+          <a:p>
+            <a:pPr algn="ctr" indent="0" marL="0">
+              <a:buNone/>
+            </a:pPr>
+            <a:r>
+              <a:rPr lang="en-US" sz="1200" b="1" dirty="0">
+                <a:solidFill>
+                  <a:srgbClr val="FFFFFF"/>
+                </a:solidFill>
+                <a:latin typeface="Arial" pitchFamily="34" charset="0"/>
+                <a:ea typeface="Arial" pitchFamily="34" charset="-122"/>
+                <a:cs typeface="Arial" pitchFamily="34" charset="-120"/>
+              </a:rPr>
+              <a:t>CLIP: original vs foveation</a:t>
+            </a:r>
+            <a:endParaRPr lang="en-US" sz="1200" dirty="0"/>
+          </a:p>
+        </p:txBody>
+      </p:sp>
+      <p:sp>
+        <p:nvSpPr>
           <p:cNvPr id="11" name="Text 8"/>
           <p:cNvSpPr txBox="1"/>
           <p:nvPr/>
         </p:nvSpPr>
         <p:spPr>
           <a:xfrm>
-            <a:off x="4846320" y="2583180"/>
-            <a:ext cx="3749040" cy="274320"/>
+            <a:off x="4846320" y="2830068"/>
+            <a:ext cx="3749040" cy="365760"/>
           </a:xfrm>
           <a:prstGeom prst="rect">
             <a:avLst/>
@@ -6772,69 +6538,30 @@
           <a:ln/>
         </p:spPr>
         <p:txBody>
-          <a:bodyPr wrap="square" lIns="0" tIns="0" rIns="0" bIns="0" rtlCol="0" anchor="ctr"/>
+          <a:bodyPr wrap="square" lIns="0" tIns="0" rIns="0" bIns="0" rtlCol="0" anchor="t"/>
           <a:lstStyle/>
           <a:p>
             <a:pPr algn="ctr" indent="0" marL="0">
               <a:buNone/>
             </a:pPr>
             <a:r>
-              <a:rPr lang="en-US" sz="1200" b="1" dirty="0">
-                <a:solidFill>
-                  <a:srgbClr val="FFFFFF"/>
-                </a:solidFill>
-                <a:latin typeface="Arial" pitchFamily="34" charset="0"/>
-                <a:ea typeface="Arial" pitchFamily="34" charset="-122"/>
-                <a:cs typeface="Arial" pitchFamily="34" charset="-120"/>
-              </a:rPr>
-              <a:t>CLIP: original vs foveation</a:t>
-            </a:r>
-            <a:endParaRPr lang="en-US" sz="1200" dirty="0"/>
+              <a:rPr lang="en-US" sz="950" dirty="0">
+                <a:solidFill>
+                  <a:srgbClr val="C9D1DC"/>
+                </a:solidFill>
+                <a:latin typeface="Arial" pitchFamily="34" charset="0"/>
+                <a:ea typeface="Arial" pitchFamily="34" charset="-122"/>
+                <a:cs typeface="Arial" pitchFamily="34" charset="-120"/>
+              </a:rPr>
+              <a:t>same episode, same initial state</a:t>
+            </a:r>
+            <a:endParaRPr lang="en-US" sz="950" dirty="0"/>
           </a:p>
         </p:txBody>
       </p:sp>
       <p:sp>
         <p:nvSpPr>
           <p:cNvPr id="12" name="Text 9"/>
-          <p:cNvSpPr txBox="1"/>
-          <p:nvPr/>
-        </p:nvSpPr>
-        <p:spPr>
-          <a:xfrm>
-            <a:off x="4846320" y="2830068"/>
-            <a:ext cx="3749040" cy="365760"/>
-          </a:xfrm>
-          <a:prstGeom prst="rect">
-            <a:avLst/>
-          </a:prstGeom>
-          <a:noFill/>
-          <a:ln/>
-        </p:spPr>
-        <p:txBody>
-          <a:bodyPr wrap="square" lIns="0" tIns="0" rIns="0" bIns="0" rtlCol="0" anchor="t"/>
-          <a:lstStyle/>
-          <a:p>
-            <a:pPr algn="ctr" indent="0" marL="0">
-              <a:buNone/>
-            </a:pPr>
-            <a:r>
-              <a:rPr lang="en-US" sz="950" dirty="0">
-                <a:solidFill>
-                  <a:srgbClr val="C9D1DC"/>
-                </a:solidFill>
-                <a:latin typeface="Arial" pitchFamily="34" charset="0"/>
-                <a:ea typeface="Arial" pitchFamily="34" charset="-122"/>
-                <a:cs typeface="Arial" pitchFamily="34" charset="-120"/>
-              </a:rPr>
-              <a:t>same episode, same initial state</a:t>
-            </a:r>
-            <a:endParaRPr lang="en-US" sz="950" dirty="0"/>
-          </a:p>
-        </p:txBody>
-      </p:sp>
-      <p:sp>
-        <p:nvSpPr>
-          <p:cNvPr id="13" name="Text 10"/>
           <p:cNvSpPr txBox="1"/>
           <p:nvPr/>
         </p:nvSpPr>
@@ -6911,8 +6638,8 @@
         </p:nvSpPr>
         <p:spPr>
           <a:xfrm>
-            <a:off x="7680960" y="73152"/>
-            <a:ext cx="1280160" cy="228600"/>
+            <a:off x="457200" y="292608"/>
+            <a:ext cx="8229600" cy="640080"/>
           </a:xfrm>
           <a:prstGeom prst="rect">
             <a:avLst/>
@@ -6924,45 +6651,6 @@
           <a:bodyPr wrap="square" lIns="0" tIns="0" rIns="0" bIns="0" rtlCol="0" anchor="ctr"/>
           <a:lstStyle/>
           <a:p>
-            <a:pPr algn="r" indent="0" marL="0">
-              <a:buNone/>
-            </a:pPr>
-            <a:r>
-              <a:rPr lang="en-US" sz="900" dirty="0">
-                <a:solidFill>
-                  <a:srgbClr val="5F6B7A"/>
-                </a:solidFill>
-                <a:latin typeface="Arial" pitchFamily="34" charset="0"/>
-                <a:ea typeface="Arial" pitchFamily="34" charset="-122"/>
-                <a:cs typeface="Arial" pitchFamily="34" charset="-120"/>
-              </a:rPr>
-              <a:t>3  ·  11s</a:t>
-            </a:r>
-            <a:endParaRPr lang="en-US" sz="900" dirty="0"/>
-          </a:p>
-        </p:txBody>
-      </p:sp>
-      <p:sp>
-        <p:nvSpPr>
-          <p:cNvPr id="3" name="Text 1"/>
-          <p:cNvSpPr txBox="1"/>
-          <p:nvPr/>
-        </p:nvSpPr>
-        <p:spPr>
-          <a:xfrm>
-            <a:off x="457200" y="292608"/>
-            <a:ext cx="8229600" cy="640080"/>
-          </a:xfrm>
-          <a:prstGeom prst="rect">
-            <a:avLst/>
-          </a:prstGeom>
-          <a:noFill/>
-          <a:ln/>
-        </p:spPr>
-        <p:txBody>
-          <a:bodyPr wrap="square" lIns="0" tIns="0" rIns="0" bIns="0" rtlCol="0" anchor="ctr"/>
-          <a:lstStyle/>
-          <a:p>
             <a:pPr indent="0" marL="0">
               <a:buNone/>
             </a:pPr>
@@ -6983,7 +6671,7 @@
       </p:sp>
       <p:sp>
         <p:nvSpPr>
-          <p:cNvPr id="4" name="Shape 2"/>
+          <p:cNvPr id="3" name="Shape 1"/>
           <p:cNvSpPr/>
           <p:nvPr/>
         </p:nvSpPr>
@@ -7010,7 +6698,7 @@
       </p:sp>
       <p:sp>
         <p:nvSpPr>
-          <p:cNvPr id="5" name="Text 3"/>
+          <p:cNvPr id="4" name="Text 2"/>
           <p:cNvSpPr txBox="1"/>
           <p:nvPr/>
         </p:nvSpPr>
@@ -7049,7 +6737,7 @@
       </p:sp>
       <p:pic>
         <p:nvPicPr>
-          <p:cNvPr id="6" name="Image 0" descr="/tmp/claude-0/-home-user-BiVLA/4327cefa-ba5d-5e2e-9d87-c73dd3a8ccbb/scratchpad/video_ppt/assets/m_repeat.png">    </p:cNvPr>
+          <p:cNvPr id="5" name="Image 0" descr="/tmp/claude-0/-home-user-BiVLA/4327cefa-ba5d-5e2e-9d87-c73dd3a8ccbb/scratchpad/video_ppt/assets/m_repeat.png">    </p:cNvPr>
           <p:cNvPicPr>
             <a:picLocks noChangeAspect="1"/>
           </p:cNvPicPr>
@@ -7073,7 +6761,7 @@
       </p:pic>
       <p:sp>
         <p:nvSpPr>
-          <p:cNvPr id="7" name="Text 4"/>
+          <p:cNvPr id="6" name="Text 3"/>
           <p:cNvSpPr txBox="1"/>
           <p:nvPr/>
         </p:nvSpPr>
@@ -7158,7 +6846,7 @@
       </p:sp>
       <p:sp>
         <p:nvSpPr>
-          <p:cNvPr id="8" name="Shape 5"/>
+          <p:cNvPr id="7" name="Shape 4"/>
           <p:cNvSpPr/>
           <p:nvPr/>
         </p:nvSpPr>
@@ -7185,7 +6873,7 @@
       </p:sp>
       <p:sp>
         <p:nvSpPr>
-          <p:cNvPr id="9" name="Shape 6"/>
+          <p:cNvPr id="8" name="Shape 5"/>
           <p:cNvSpPr/>
           <p:nvPr/>
         </p:nvSpPr>
@@ -7210,7 +6898,7 @@
       </p:sp>
       <p:sp>
         <p:nvSpPr>
-          <p:cNvPr id="10" name="Shape 7"/>
+          <p:cNvPr id="9" name="Shape 6"/>
           <p:cNvSpPr/>
           <p:nvPr/>
         </p:nvSpPr>
@@ -7235,14 +6923,53 @@
       </p:sp>
       <p:sp>
         <p:nvSpPr>
+          <p:cNvPr id="10" name="Text 7"/>
+          <p:cNvSpPr txBox="1"/>
+          <p:nvPr/>
+        </p:nvSpPr>
+        <p:spPr>
+          <a:xfrm>
+            <a:off x="4846320" y="2583180"/>
+            <a:ext cx="3749040" cy="274320"/>
+          </a:xfrm>
+          <a:prstGeom prst="rect">
+            <a:avLst/>
+          </a:prstGeom>
+          <a:noFill/>
+          <a:ln/>
+        </p:spPr>
+        <p:txBody>
+          <a:bodyPr wrap="square" lIns="0" tIns="0" rIns="0" bIns="0" rtlCol="0" anchor="ctr"/>
+          <a:lstStyle/>
+          <a:p>
+            <a:pPr algn="ctr" indent="0" marL="0">
+              <a:buNone/>
+            </a:pPr>
+            <a:r>
+              <a:rPr lang="en-US" sz="1200" b="1" dirty="0">
+                <a:solidFill>
+                  <a:srgbClr val="FFFFFF"/>
+                </a:solidFill>
+                <a:latin typeface="Arial" pitchFamily="34" charset="0"/>
+                <a:ea typeface="Arial" pitchFamily="34" charset="-122"/>
+                <a:cs typeface="Arial" pitchFamily="34" charset="-120"/>
+              </a:rPr>
+              <a:t>CLIP: original vs action repeat k = 4</a:t>
+            </a:r>
+            <a:endParaRPr lang="en-US" sz="1200" dirty="0"/>
+          </a:p>
+        </p:txBody>
+      </p:sp>
+      <p:sp>
+        <p:nvSpPr>
           <p:cNvPr id="11" name="Text 8"/>
           <p:cNvSpPr txBox="1"/>
           <p:nvPr/>
         </p:nvSpPr>
         <p:spPr>
           <a:xfrm>
-            <a:off x="4846320" y="2583180"/>
-            <a:ext cx="3749040" cy="274320"/>
+            <a:off x="4846320" y="2830068"/>
+            <a:ext cx="3749040" cy="365760"/>
           </a:xfrm>
           <a:prstGeom prst="rect">
             <a:avLst/>
@@ -7251,69 +6978,30 @@
           <a:ln/>
         </p:spPr>
         <p:txBody>
-          <a:bodyPr wrap="square" lIns="0" tIns="0" rIns="0" bIns="0" rtlCol="0" anchor="ctr"/>
+          <a:bodyPr wrap="square" lIns="0" tIns="0" rIns="0" bIns="0" rtlCol="0" anchor="t"/>
           <a:lstStyle/>
           <a:p>
             <a:pPr algn="ctr" indent="0" marL="0">
               <a:buNone/>
             </a:pPr>
             <a:r>
-              <a:rPr lang="en-US" sz="1200" b="1" dirty="0">
-                <a:solidFill>
-                  <a:srgbClr val="FFFFFF"/>
-                </a:solidFill>
-                <a:latin typeface="Arial" pitchFamily="34" charset="0"/>
-                <a:ea typeface="Arial" pitchFamily="34" charset="-122"/>
-                <a:cs typeface="Arial" pitchFamily="34" charset="-120"/>
-              </a:rPr>
-              <a:t>CLIP: original vs action repeat k = 4</a:t>
-            </a:r>
-            <a:endParaRPr lang="en-US" sz="1200" dirty="0"/>
+              <a:rPr lang="en-US" sz="950" dirty="0">
+                <a:solidFill>
+                  <a:srgbClr val="C9D1DC"/>
+                </a:solidFill>
+                <a:latin typeface="Arial" pitchFamily="34" charset="0"/>
+                <a:ea typeface="Arial" pitchFamily="34" charset="-122"/>
+                <a:cs typeface="Arial" pitchFamily="34" charset="-120"/>
+              </a:rPr>
+              <a:t>same episode, same initial state</a:t>
+            </a:r>
+            <a:endParaRPr lang="en-US" sz="950" dirty="0"/>
           </a:p>
         </p:txBody>
       </p:sp>
       <p:sp>
         <p:nvSpPr>
           <p:cNvPr id="12" name="Text 9"/>
-          <p:cNvSpPr txBox="1"/>
-          <p:nvPr/>
-        </p:nvSpPr>
-        <p:spPr>
-          <a:xfrm>
-            <a:off x="4846320" y="2830068"/>
-            <a:ext cx="3749040" cy="365760"/>
-          </a:xfrm>
-          <a:prstGeom prst="rect">
-            <a:avLst/>
-          </a:prstGeom>
-          <a:noFill/>
-          <a:ln/>
-        </p:spPr>
-        <p:txBody>
-          <a:bodyPr wrap="square" lIns="0" tIns="0" rIns="0" bIns="0" rtlCol="0" anchor="t"/>
-          <a:lstStyle/>
-          <a:p>
-            <a:pPr algn="ctr" indent="0" marL="0">
-              <a:buNone/>
-            </a:pPr>
-            <a:r>
-              <a:rPr lang="en-US" sz="950" dirty="0">
-                <a:solidFill>
-                  <a:srgbClr val="C9D1DC"/>
-                </a:solidFill>
-                <a:latin typeface="Arial" pitchFamily="34" charset="0"/>
-                <a:ea typeface="Arial" pitchFamily="34" charset="-122"/>
-                <a:cs typeface="Arial" pitchFamily="34" charset="-120"/>
-              </a:rPr>
-              <a:t>same episode, same initial state</a:t>
-            </a:r>
-            <a:endParaRPr lang="en-US" sz="950" dirty="0"/>
-          </a:p>
-        </p:txBody>
-      </p:sp>
-      <p:sp>
-        <p:nvSpPr>
-          <p:cNvPr id="13" name="Text 10"/>
           <p:cNvSpPr txBox="1"/>
           <p:nvPr/>
         </p:nvSpPr>
@@ -7390,8 +7078,8 @@
         </p:nvSpPr>
         <p:spPr>
           <a:xfrm>
-            <a:off x="7680960" y="73152"/>
-            <a:ext cx="1280160" cy="228600"/>
+            <a:off x="457200" y="292608"/>
+            <a:ext cx="8229600" cy="640080"/>
           </a:xfrm>
           <a:prstGeom prst="rect">
             <a:avLst/>
@@ -7403,45 +7091,6 @@
           <a:bodyPr wrap="square" lIns="0" tIns="0" rIns="0" bIns="0" rtlCol="0" anchor="ctr"/>
           <a:lstStyle/>
           <a:p>
-            <a:pPr algn="r" indent="0" marL="0">
-              <a:buNone/>
-            </a:pPr>
-            <a:r>
-              <a:rPr lang="en-US" sz="900" dirty="0">
-                <a:solidFill>
-                  <a:srgbClr val="5F6B7A"/>
-                </a:solidFill>
-                <a:latin typeface="Arial" pitchFamily="34" charset="0"/>
-                <a:ea typeface="Arial" pitchFamily="34" charset="-122"/>
-                <a:cs typeface="Arial" pitchFamily="34" charset="-120"/>
-              </a:rPr>
-              <a:t>4  ·  11s</a:t>
-            </a:r>
-            <a:endParaRPr lang="en-US" sz="900" dirty="0"/>
-          </a:p>
-        </p:txBody>
-      </p:sp>
-      <p:sp>
-        <p:nvSpPr>
-          <p:cNvPr id="3" name="Text 1"/>
-          <p:cNvSpPr txBox="1"/>
-          <p:nvPr/>
-        </p:nvSpPr>
-        <p:spPr>
-          <a:xfrm>
-            <a:off x="457200" y="292608"/>
-            <a:ext cx="8229600" cy="640080"/>
-          </a:xfrm>
-          <a:prstGeom prst="rect">
-            <a:avLst/>
-          </a:prstGeom>
-          <a:noFill/>
-          <a:ln/>
-        </p:spPr>
-        <p:txBody>
-          <a:bodyPr wrap="square" lIns="0" tIns="0" rIns="0" bIns="0" rtlCol="0" anchor="ctr"/>
-          <a:lstStyle/>
-          <a:p>
             <a:pPr indent="0" marL="0">
               <a:buNone/>
             </a:pPr>
@@ -7462,7 +7111,7 @@
       </p:sp>
       <p:sp>
         <p:nvSpPr>
-          <p:cNvPr id="4" name="Shape 2"/>
+          <p:cNvPr id="3" name="Shape 1"/>
           <p:cNvSpPr/>
           <p:nvPr/>
         </p:nvSpPr>
@@ -7489,7 +7138,7 @@
       </p:sp>
       <p:sp>
         <p:nvSpPr>
-          <p:cNvPr id="5" name="Text 3"/>
+          <p:cNvPr id="4" name="Text 2"/>
           <p:cNvSpPr txBox="1"/>
           <p:nvPr/>
         </p:nvSpPr>
@@ -7528,7 +7177,7 @@
       </p:sp>
       <p:pic>
         <p:nvPicPr>
-          <p:cNvPr id="6" name="Image 0" descr="/tmp/claude-0/-home-user-BiVLA/4327cefa-ba5d-5e2e-9d87-c73dd3a8ccbb/scratchpad/video_ppt/assets/m_prune.png">    </p:cNvPr>
+          <p:cNvPr id="5" name="Image 0" descr="/tmp/claude-0/-home-user-BiVLA/4327cefa-ba5d-5e2e-9d87-c73dd3a8ccbb/scratchpad/video_ppt/assets/m_prune.png">    </p:cNvPr>
           <p:cNvPicPr>
             <a:picLocks noChangeAspect="1"/>
           </p:cNvPicPr>
@@ -7552,7 +7201,7 @@
       </p:pic>
       <p:sp>
         <p:nvSpPr>
-          <p:cNvPr id="7" name="Text 4"/>
+          <p:cNvPr id="6" name="Text 3"/>
           <p:cNvSpPr txBox="1"/>
           <p:nvPr/>
         </p:nvSpPr>
@@ -7573,13 +7222,13 @@
           <a:p>
             <a:pPr marL="177800" indent="-177800">
               <a:spcAft>
-                <a:spcPts val="500"/>
+                <a:spcPts val="600"/>
               </a:spcAft>
               <a:buSzPct val="100000"/>
               <a:buChar char="•"/>
             </a:pPr>
             <a:r>
-              <a:rPr lang="en-US" sz="1050" dirty="0">
+              <a:rPr lang="en-US" sz="1100" dirty="0">
                 <a:solidFill>
                   <a:srgbClr val="1F2933"/>
                 </a:solidFill>
@@ -7587,20 +7236,20 @@
                 <a:ea typeface="Arial" pitchFamily="34" charset="-122"/>
                 <a:cs typeface="Arial" pitchFamily="34" charset="-120"/>
               </a:rPr>
-              <a:t>Block Influence: how little a decoder block changes its hidden states on calibration data</a:t>
-            </a:r>
-            <a:endParaRPr lang="en-US" sz="1050" dirty="0"/>
+              <a:t>Score each decoder block by Block Influence</a:t>
+            </a:r>
+            <a:endParaRPr lang="en-US" sz="1100" dirty="0"/>
           </a:p>
           <a:p>
             <a:pPr marL="177800" indent="-177800">
               <a:spcAft>
-                <a:spcPts val="500"/>
+                <a:spcPts val="600"/>
               </a:spcAft>
               <a:buSzPct val="100000"/>
               <a:buChar char="•"/>
             </a:pPr>
             <a:r>
-              <a:rPr lang="en-US" sz="1050" dirty="0">
+              <a:rPr lang="en-US" sz="1100" dirty="0">
                 <a:solidFill>
                   <a:srgbClr val="1F2933"/>
                 </a:solidFill>
@@ -7608,20 +7257,20 @@
                 <a:ea typeface="Arial" pitchFamily="34" charset="-122"/>
                 <a:cs typeface="Arial" pitchFamily="34" charset="-120"/>
               </a:rPr>
-              <a:t>Remove the 1, 2, or 4 lowest-influence blocks; none adjacent, first and last kept</a:t>
-            </a:r>
-            <a:endParaRPr lang="en-US" sz="1050" dirty="0"/>
+              <a:t>Remove the 1, 2, or 4 lowest; none adjacent, first and last kept</a:t>
+            </a:r>
+            <a:endParaRPr lang="en-US" sz="1100" dirty="0"/>
           </a:p>
           <a:p>
             <a:pPr marL="177800" indent="-177800">
               <a:spcAft>
-                <a:spcPts val="500"/>
+                <a:spcPts val="600"/>
               </a:spcAft>
               <a:buSzPct val="100000"/>
               <a:buChar char="•"/>
             </a:pPr>
             <a:r>
-              <a:rPr lang="en-US" sz="1050" dirty="0">
+              <a:rPr lang="en-US" sz="1100" dirty="0">
                 <a:solidFill>
                   <a:srgbClr val="1F2933"/>
                 </a:solidFill>
@@ -7629,36 +7278,15 @@
                 <a:ea typeface="Arial" pitchFamily="34" charset="-122"/>
                 <a:cs typeface="Arial" pitchFamily="34" charset="-120"/>
               </a:rPr>
-              <a:t>Selected once from calibration data, fixed before evaluation</a:t>
-            </a:r>
-            <a:endParaRPr lang="en-US" sz="1050" dirty="0"/>
-          </a:p>
-          <a:p>
-            <a:pPr marL="177800" indent="-177800">
-              <a:spcAft>
-                <a:spcPts val="500"/>
-              </a:spcAft>
-              <a:buSzPct val="100000"/>
-              <a:buChar char="•"/>
-            </a:pPr>
-            <a:r>
-              <a:rPr lang="en-US" sz="1050" dirty="0">
-                <a:solidFill>
-                  <a:srgbClr val="1F2933"/>
-                </a:solidFill>
-                <a:latin typeface="Arial" pitchFamily="34" charset="0"/>
-                <a:ea typeface="Arial" pitchFamily="34" charset="-122"/>
-                <a:cs typeface="Arial" pitchFamily="34" charset="-120"/>
-              </a:rPr>
-              <a:t>Acts inside the action decoder, after the visual encoder</a:t>
-            </a:r>
-            <a:endParaRPr lang="en-US" sz="1050" dirty="0"/>
-          </a:p>
-        </p:txBody>
-      </p:sp>
-      <p:sp>
-        <p:nvSpPr>
-          <p:cNvPr id="8" name="Shape 5"/>
+              <a:t>Fixed once from calibration data, not adapted at test time</a:t>
+            </a:r>
+            <a:endParaRPr lang="en-US" sz="1100" dirty="0"/>
+          </a:p>
+        </p:txBody>
+      </p:sp>
+      <p:sp>
+        <p:nvSpPr>
+          <p:cNvPr id="7" name="Shape 4"/>
           <p:cNvSpPr/>
           <p:nvPr/>
         </p:nvSpPr>
@@ -7685,7 +7313,7 @@
       </p:sp>
       <p:sp>
         <p:nvSpPr>
-          <p:cNvPr id="9" name="Shape 6"/>
+          <p:cNvPr id="8" name="Shape 5"/>
           <p:cNvSpPr/>
           <p:nvPr/>
         </p:nvSpPr>
@@ -7710,7 +7338,7 @@
       </p:sp>
       <p:sp>
         <p:nvSpPr>
-          <p:cNvPr id="10" name="Shape 7"/>
+          <p:cNvPr id="9" name="Shape 6"/>
           <p:cNvSpPr/>
           <p:nvPr/>
         </p:nvSpPr>
@@ -7735,14 +7363,53 @@
       </p:sp>
       <p:sp>
         <p:nvSpPr>
+          <p:cNvPr id="10" name="Text 7"/>
+          <p:cNvSpPr txBox="1"/>
+          <p:nvPr/>
+        </p:nvSpPr>
+        <p:spPr>
+          <a:xfrm>
+            <a:off x="4846320" y="2583180"/>
+            <a:ext cx="3749040" cy="274320"/>
+          </a:xfrm>
+          <a:prstGeom prst="rect">
+            <a:avLst/>
+          </a:prstGeom>
+          <a:noFill/>
+          <a:ln/>
+        </p:spPr>
+        <p:txBody>
+          <a:bodyPr wrap="square" lIns="0" tIns="0" rIns="0" bIns="0" rtlCol="0" anchor="ctr"/>
+          <a:lstStyle/>
+          <a:p>
+            <a:pPr algn="ctr" indent="0" marL="0">
+              <a:buNone/>
+            </a:pPr>
+            <a:r>
+              <a:rPr lang="en-US" sz="1200" b="1" dirty="0">
+                <a:solidFill>
+                  <a:srgbClr val="FFFFFF"/>
+                </a:solidFill>
+                <a:latin typeface="Arial" pitchFamily="34" charset="0"/>
+                <a:ea typeface="Arial" pitchFamily="34" charset="-122"/>
+                <a:cs typeface="Arial" pitchFamily="34" charset="-120"/>
+              </a:rPr>
+              <a:t>CLIP: original vs depth pruning</a:t>
+            </a:r>
+            <a:endParaRPr lang="en-US" sz="1200" dirty="0"/>
+          </a:p>
+        </p:txBody>
+      </p:sp>
+      <p:sp>
+        <p:nvSpPr>
           <p:cNvPr id="11" name="Text 8"/>
           <p:cNvSpPr txBox="1"/>
           <p:nvPr/>
         </p:nvSpPr>
         <p:spPr>
           <a:xfrm>
-            <a:off x="4846320" y="2583180"/>
-            <a:ext cx="3749040" cy="274320"/>
+            <a:off x="4846320" y="2830068"/>
+            <a:ext cx="3749040" cy="365760"/>
           </a:xfrm>
           <a:prstGeom prst="rect">
             <a:avLst/>
@@ -7751,69 +7418,30 @@
           <a:ln/>
         </p:spPr>
         <p:txBody>
-          <a:bodyPr wrap="square" lIns="0" tIns="0" rIns="0" bIns="0" rtlCol="0" anchor="ctr"/>
+          <a:bodyPr wrap="square" lIns="0" tIns="0" rIns="0" bIns="0" rtlCol="0" anchor="t"/>
           <a:lstStyle/>
           <a:p>
             <a:pPr algn="ctr" indent="0" marL="0">
               <a:buNone/>
             </a:pPr>
             <a:r>
-              <a:rPr lang="en-US" sz="1200" b="1" dirty="0">
-                <a:solidFill>
-                  <a:srgbClr val="FFFFFF"/>
-                </a:solidFill>
-                <a:latin typeface="Arial" pitchFamily="34" charset="0"/>
-                <a:ea typeface="Arial" pitchFamily="34" charset="-122"/>
-                <a:cs typeface="Arial" pitchFamily="34" charset="-120"/>
-              </a:rPr>
-              <a:t>CLIP: original vs depth pruning</a:t>
-            </a:r>
-            <a:endParaRPr lang="en-US" sz="1200" dirty="0"/>
+              <a:rPr lang="en-US" sz="950" dirty="0">
+                <a:solidFill>
+                  <a:srgbClr val="C9D1DC"/>
+                </a:solidFill>
+                <a:latin typeface="Arial" pitchFamily="34" charset="0"/>
+                <a:ea typeface="Arial" pitchFamily="34" charset="-122"/>
+                <a:cs typeface="Arial" pitchFamily="34" charset="-120"/>
+              </a:rPr>
+              <a:t>same episode, same initial state</a:t>
+            </a:r>
+            <a:endParaRPr lang="en-US" sz="950" dirty="0"/>
           </a:p>
         </p:txBody>
       </p:sp>
       <p:sp>
         <p:nvSpPr>
           <p:cNvPr id="12" name="Text 9"/>
-          <p:cNvSpPr txBox="1"/>
-          <p:nvPr/>
-        </p:nvSpPr>
-        <p:spPr>
-          <a:xfrm>
-            <a:off x="4846320" y="2830068"/>
-            <a:ext cx="3749040" cy="365760"/>
-          </a:xfrm>
-          <a:prstGeom prst="rect">
-            <a:avLst/>
-          </a:prstGeom>
-          <a:noFill/>
-          <a:ln/>
-        </p:spPr>
-        <p:txBody>
-          <a:bodyPr wrap="square" lIns="0" tIns="0" rIns="0" bIns="0" rtlCol="0" anchor="t"/>
-          <a:lstStyle/>
-          <a:p>
-            <a:pPr algn="ctr" indent="0" marL="0">
-              <a:buNone/>
-            </a:pPr>
-            <a:r>
-              <a:rPr lang="en-US" sz="950" dirty="0">
-                <a:solidFill>
-                  <a:srgbClr val="C9D1DC"/>
-                </a:solidFill>
-                <a:latin typeface="Arial" pitchFamily="34" charset="0"/>
-                <a:ea typeface="Arial" pitchFamily="34" charset="-122"/>
-                <a:cs typeface="Arial" pitchFamily="34" charset="-120"/>
-              </a:rPr>
-              <a:t>same episode, same initial state</a:t>
-            </a:r>
-            <a:endParaRPr lang="en-US" sz="950" dirty="0"/>
-          </a:p>
-        </p:txBody>
-      </p:sp>
-      <p:sp>
-        <p:nvSpPr>
-          <p:cNvPr id="13" name="Text 10"/>
           <p:cNvSpPr txBox="1"/>
           <p:nvPr/>
         </p:nvSpPr>
@@ -7890,8 +7518,8 @@
         </p:nvSpPr>
         <p:spPr>
           <a:xfrm>
-            <a:off x="7680960" y="73152"/>
-            <a:ext cx="1280160" cy="228600"/>
+            <a:off x="457200" y="292608"/>
+            <a:ext cx="8229600" cy="640080"/>
           </a:xfrm>
           <a:prstGeom prst="rect">
             <a:avLst/>
@@ -7903,45 +7531,6 @@
           <a:bodyPr wrap="square" lIns="0" tIns="0" rIns="0" bIns="0" rtlCol="0" anchor="ctr"/>
           <a:lstStyle/>
           <a:p>
-            <a:pPr algn="r" indent="0" marL="0">
-              <a:buNone/>
-            </a:pPr>
-            <a:r>
-              <a:rPr lang="en-US" sz="900" dirty="0">
-                <a:solidFill>
-                  <a:srgbClr val="5F6B7A"/>
-                </a:solidFill>
-                <a:latin typeface="Arial" pitchFamily="34" charset="0"/>
-                <a:ea typeface="Arial" pitchFamily="34" charset="-122"/>
-                <a:cs typeface="Arial" pitchFamily="34" charset="-120"/>
-              </a:rPr>
-              <a:t>5  ·  11s</a:t>
-            </a:r>
-            <a:endParaRPr lang="en-US" sz="900" dirty="0"/>
-          </a:p>
-        </p:txBody>
-      </p:sp>
-      <p:sp>
-        <p:nvSpPr>
-          <p:cNvPr id="3" name="Text 1"/>
-          <p:cNvSpPr txBox="1"/>
-          <p:nvPr/>
-        </p:nvSpPr>
-        <p:spPr>
-          <a:xfrm>
-            <a:off x="457200" y="292608"/>
-            <a:ext cx="8229600" cy="640080"/>
-          </a:xfrm>
-          <a:prstGeom prst="rect">
-            <a:avLst/>
-          </a:prstGeom>
-          <a:noFill/>
-          <a:ln/>
-        </p:spPr>
-        <p:txBody>
-          <a:bodyPr wrap="square" lIns="0" tIns="0" rIns="0" bIns="0" rtlCol="0" anchor="ctr"/>
-          <a:lstStyle/>
-          <a:p>
             <a:pPr indent="0" marL="0">
               <a:buNone/>
             </a:pPr>
@@ -7962,7 +7551,7 @@
       </p:sp>
       <p:sp>
         <p:nvSpPr>
-          <p:cNvPr id="4" name="Shape 2"/>
+          <p:cNvPr id="3" name="Shape 1"/>
           <p:cNvSpPr/>
           <p:nvPr/>
         </p:nvSpPr>
@@ -7989,7 +7578,7 @@
       </p:sp>
       <p:sp>
         <p:nvSpPr>
-          <p:cNvPr id="5" name="Text 3"/>
+          <p:cNvPr id="4" name="Text 2"/>
           <p:cNvSpPr txBox="1"/>
           <p:nvPr/>
         </p:nvSpPr>
@@ -8028,7 +7617,7 @@
       </p:sp>
       <p:pic>
         <p:nvPicPr>
-          <p:cNvPr id="6" name="Image 0" descr="/tmp/claude-0/-home-user-BiVLA/4327cefa-ba5d-5e2e-9d87-c73dd3a8ccbb/scratchpad/video_ppt/assets/m_guarded.png">    </p:cNvPr>
+          <p:cNvPr id="5" name="Image 0" descr="/tmp/claude-0/-home-user-BiVLA/4327cefa-ba5d-5e2e-9d87-c73dd3a8ccbb/scratchpad/video_ppt/assets/m_guarded.png">    </p:cNvPr>
           <p:cNvPicPr>
             <a:picLocks noChangeAspect="1"/>
           </p:cNvPicPr>
@@ -8052,7 +7641,7 @@
       </p:pic>
       <p:sp>
         <p:nvSpPr>
-          <p:cNvPr id="7" name="Text 4"/>
+          <p:cNvPr id="6" name="Text 3"/>
           <p:cNvSpPr txBox="1"/>
           <p:nvPr/>
         </p:nvSpPr>
@@ -8116,7 +7705,7 @@
       </p:sp>
       <p:sp>
         <p:nvSpPr>
-          <p:cNvPr id="8" name="Shape 5"/>
+          <p:cNvPr id="7" name="Shape 4"/>
           <p:cNvSpPr/>
           <p:nvPr/>
         </p:nvSpPr>
@@ -8143,7 +7732,7 @@
       </p:sp>
       <p:sp>
         <p:nvSpPr>
-          <p:cNvPr id="9" name="Shape 6"/>
+          <p:cNvPr id="8" name="Shape 5"/>
           <p:cNvSpPr/>
           <p:nvPr/>
         </p:nvSpPr>
@@ -8168,7 +7757,7 @@
       </p:sp>
       <p:sp>
         <p:nvSpPr>
-          <p:cNvPr id="10" name="Shape 7"/>
+          <p:cNvPr id="9" name="Shape 6"/>
           <p:cNvSpPr/>
           <p:nvPr/>
         </p:nvSpPr>
@@ -8193,14 +7782,53 @@
       </p:sp>
       <p:sp>
         <p:nvSpPr>
+          <p:cNvPr id="10" name="Text 7"/>
+          <p:cNvSpPr txBox="1"/>
+          <p:nvPr/>
+        </p:nvSpPr>
+        <p:spPr>
+          <a:xfrm>
+            <a:off x="4846320" y="2583180"/>
+            <a:ext cx="3749040" cy="274320"/>
+          </a:xfrm>
+          <a:prstGeom prst="rect">
+            <a:avLst/>
+          </a:prstGeom>
+          <a:noFill/>
+          <a:ln/>
+        </p:spPr>
+        <p:txBody>
+          <a:bodyPr wrap="square" lIns="0" tIns="0" rIns="0" bIns="0" rtlCol="0" anchor="ctr"/>
+          <a:lstStyle/>
+          <a:p>
+            <a:pPr algn="ctr" indent="0" marL="0">
+              <a:buNone/>
+            </a:pPr>
+            <a:r>
+              <a:rPr lang="en-US" sz="1200" b="1" dirty="0">
+                <a:solidFill>
+                  <a:srgbClr val="FFFFFF"/>
+                </a:solidFill>
+                <a:latin typeface="Arial" pitchFamily="34" charset="0"/>
+                <a:ea typeface="Arial" pitchFamily="34" charset="-122"/>
+                <a:cs typeface="Arial" pitchFamily="34" charset="-120"/>
+              </a:rPr>
+              <a:t>CLIP: original vs guarded reuse</a:t>
+            </a:r>
+            <a:endParaRPr lang="en-US" sz="1200" dirty="0"/>
+          </a:p>
+        </p:txBody>
+      </p:sp>
+      <p:sp>
+        <p:nvSpPr>
           <p:cNvPr id="11" name="Text 8"/>
           <p:cNvSpPr txBox="1"/>
           <p:nvPr/>
         </p:nvSpPr>
         <p:spPr>
           <a:xfrm>
-            <a:off x="4846320" y="2583180"/>
-            <a:ext cx="3749040" cy="274320"/>
+            <a:off x="4846320" y="2830068"/>
+            <a:ext cx="3749040" cy="365760"/>
           </a:xfrm>
           <a:prstGeom prst="rect">
             <a:avLst/>
@@ -8209,69 +7837,30 @@
           <a:ln/>
         </p:spPr>
         <p:txBody>
-          <a:bodyPr wrap="square" lIns="0" tIns="0" rIns="0" bIns="0" rtlCol="0" anchor="ctr"/>
+          <a:bodyPr wrap="square" lIns="0" tIns="0" rIns="0" bIns="0" rtlCol="0" anchor="t"/>
           <a:lstStyle/>
           <a:p>
             <a:pPr algn="ctr" indent="0" marL="0">
               <a:buNone/>
             </a:pPr>
             <a:r>
-              <a:rPr lang="en-US" sz="1200" b="1" dirty="0">
-                <a:solidFill>
-                  <a:srgbClr val="FFFFFF"/>
-                </a:solidFill>
-                <a:latin typeface="Arial" pitchFamily="34" charset="0"/>
-                <a:ea typeface="Arial" pitchFamily="34" charset="-122"/>
-                <a:cs typeface="Arial" pitchFamily="34" charset="-120"/>
-              </a:rPr>
-              <a:t>CLIP: original vs guarded reuse</a:t>
-            </a:r>
-            <a:endParaRPr lang="en-US" sz="1200" dirty="0"/>
+              <a:rPr lang="en-US" sz="950" dirty="0">
+                <a:solidFill>
+                  <a:srgbClr val="C9D1DC"/>
+                </a:solidFill>
+                <a:latin typeface="Arial" pitchFamily="34" charset="0"/>
+                <a:ea typeface="Arial" pitchFamily="34" charset="-122"/>
+                <a:cs typeface="Arial" pitchFamily="34" charset="-120"/>
+              </a:rPr>
+              <a:t>same episode, same initial state</a:t>
+            </a:r>
+            <a:endParaRPr lang="en-US" sz="950" dirty="0"/>
           </a:p>
         </p:txBody>
       </p:sp>
       <p:sp>
         <p:nvSpPr>
           <p:cNvPr id="12" name="Text 9"/>
-          <p:cNvSpPr txBox="1"/>
-          <p:nvPr/>
-        </p:nvSpPr>
-        <p:spPr>
-          <a:xfrm>
-            <a:off x="4846320" y="2830068"/>
-            <a:ext cx="3749040" cy="365760"/>
-          </a:xfrm>
-          <a:prstGeom prst="rect">
-            <a:avLst/>
-          </a:prstGeom>
-          <a:noFill/>
-          <a:ln/>
-        </p:spPr>
-        <p:txBody>
-          <a:bodyPr wrap="square" lIns="0" tIns="0" rIns="0" bIns="0" rtlCol="0" anchor="t"/>
-          <a:lstStyle/>
-          <a:p>
-            <a:pPr algn="ctr" indent="0" marL="0">
-              <a:buNone/>
-            </a:pPr>
-            <a:r>
-              <a:rPr lang="en-US" sz="950" dirty="0">
-                <a:solidFill>
-                  <a:srgbClr val="C9D1DC"/>
-                </a:solidFill>
-                <a:latin typeface="Arial" pitchFamily="34" charset="0"/>
-                <a:ea typeface="Arial" pitchFamily="34" charset="-122"/>
-                <a:cs typeface="Arial" pitchFamily="34" charset="-120"/>
-              </a:rPr>
-              <a:t>same episode, same initial state</a:t>
-            </a:r>
-            <a:endParaRPr lang="en-US" sz="950" dirty="0"/>
-          </a:p>
-        </p:txBody>
-      </p:sp>
-      <p:sp>
-        <p:nvSpPr>
-          <p:cNvPr id="13" name="Text 10"/>
           <p:cNvSpPr txBox="1"/>
           <p:nvPr/>
         </p:nvSpPr>
@@ -8348,8 +7937,8 @@
         </p:nvSpPr>
         <p:spPr>
           <a:xfrm>
-            <a:off x="7680960" y="73152"/>
-            <a:ext cx="1280160" cy="228600"/>
+            <a:off x="457200" y="292608"/>
+            <a:ext cx="8229600" cy="640080"/>
           </a:xfrm>
           <a:prstGeom prst="rect">
             <a:avLst/>
@@ -8361,45 +7950,6 @@
           <a:bodyPr wrap="square" lIns="0" tIns="0" rIns="0" bIns="0" rtlCol="0" anchor="ctr"/>
           <a:lstStyle/>
           <a:p>
-            <a:pPr algn="r" indent="0" marL="0">
-              <a:buNone/>
-            </a:pPr>
-            <a:r>
-              <a:rPr lang="en-US" sz="900" dirty="0">
-                <a:solidFill>
-                  <a:srgbClr val="5F6B7A"/>
-                </a:solidFill>
-                <a:latin typeface="Arial" pitchFamily="34" charset="0"/>
-                <a:ea typeface="Arial" pitchFamily="34" charset="-122"/>
-                <a:cs typeface="Arial" pitchFamily="34" charset="-120"/>
-              </a:rPr>
-              <a:t>6  ·  12s</a:t>
-            </a:r>
-            <a:endParaRPr lang="en-US" sz="900" dirty="0"/>
-          </a:p>
-        </p:txBody>
-      </p:sp>
-      <p:sp>
-        <p:nvSpPr>
-          <p:cNvPr id="3" name="Text 1"/>
-          <p:cNvSpPr txBox="1"/>
-          <p:nvPr/>
-        </p:nvSpPr>
-        <p:spPr>
-          <a:xfrm>
-            <a:off x="457200" y="292608"/>
-            <a:ext cx="8229600" cy="640080"/>
-          </a:xfrm>
-          <a:prstGeom prst="rect">
-            <a:avLst/>
-          </a:prstGeom>
-          <a:noFill/>
-          <a:ln/>
-        </p:spPr>
-        <p:txBody>
-          <a:bodyPr wrap="square" lIns="0" tIns="0" rIns="0" bIns="0" rtlCol="0" anchor="ctr"/>
-          <a:lstStyle/>
-          <a:p>
             <a:pPr indent="0" marL="0">
               <a:buNone/>
             </a:pPr>
@@ -8420,7 +7970,7 @@
       </p:sp>
       <p:sp>
         <p:nvSpPr>
-          <p:cNvPr id="4" name="Shape 2"/>
+          <p:cNvPr id="3" name="Shape 1"/>
           <p:cNvSpPr/>
           <p:nvPr/>
         </p:nvSpPr>
@@ -8447,7 +7997,7 @@
       </p:sp>
       <p:sp>
         <p:nvSpPr>
-          <p:cNvPr id="5" name="Text 3"/>
+          <p:cNvPr id="4" name="Text 2"/>
           <p:cNvSpPr txBox="1"/>
           <p:nvPr/>
         </p:nvSpPr>
@@ -8486,7 +8036,7 @@
       </p:sp>
       <p:pic>
         <p:nvPicPr>
-          <p:cNvPr id="6" name="Image 0" descr="/tmp/claude-0/-home-user-BiVLA/4327cefa-ba5d-5e2e-9d87-c73dd3a8ccbb/scratchpad/video_ppt/assets/m_fusion.png">    </p:cNvPr>
+          <p:cNvPr id="5" name="Image 0" descr="/tmp/claude-0/-home-user-BiVLA/4327cefa-ba5d-5e2e-9d87-c73dd3a8ccbb/scratchpad/video_ppt/assets/m_fusion.png">    </p:cNvPr>
           <p:cNvPicPr>
             <a:picLocks noChangeAspect="1"/>
           </p:cNvPicPr>
@@ -8510,7 +8060,7 @@
       </p:pic>
       <p:sp>
         <p:nvSpPr>
-          <p:cNvPr id="7" name="Text 4"/>
+          <p:cNvPr id="6" name="Text 3"/>
           <p:cNvSpPr txBox="1"/>
           <p:nvPr/>
         </p:nvSpPr>
@@ -8531,13 +8081,13 @@
           <a:p>
             <a:pPr marL="177800" indent="-177800">
               <a:spcAft>
-                <a:spcPts val="300"/>
+                <a:spcPts val="600"/>
               </a:spcAft>
               <a:buSzPct val="100000"/>
               <a:buChar char="•"/>
             </a:pPr>
             <a:r>
-              <a:rPr lang="en-US" sz="1050" dirty="0">
+              <a:rPr lang="en-US" sz="1100" dirty="0">
                 <a:solidFill>
                   <a:srgbClr val="1F2933"/>
                 </a:solidFill>
@@ -8545,20 +8095,20 @@
                 <a:ea typeface="Arial" pitchFamily="34" charset="-122"/>
                 <a:cs typeface="Arial" pitchFamily="34" charset="-120"/>
               </a:rPr>
-              <a:t>Reuse projected visual tokens of temporally stable patches from the previous call</a:t>
-            </a:r>
-            <a:endParaRPr lang="en-US" sz="1050" dirty="0"/>
+              <a:t>Reuse visual tokens of stable patches from the previous call</a:t>
+            </a:r>
+            <a:endParaRPr lang="en-US" sz="1100" dirty="0"/>
           </a:p>
           <a:p>
             <a:pPr marL="177800" indent="-177800">
               <a:spcAft>
-                <a:spcPts val="300"/>
+                <a:spcPts val="600"/>
               </a:spcAft>
               <a:buSzPct val="100000"/>
               <a:buChar char="•"/>
             </a:pPr>
             <a:r>
-              <a:rPr lang="en-US" sz="1050" dirty="0">
+              <a:rPr lang="en-US" sz="1100" dirty="0">
                 <a:solidFill>
                   <a:srgbClr val="1F2933"/>
                 </a:solidFill>
@@ -8566,20 +8116,20 @@
                 <a:ea typeface="Arial" pitchFamily="34" charset="-122"/>
                 <a:cs typeface="Arial" pitchFamily="34" charset="-120"/>
               </a:rPr>
-              <a:t>Protect patches with motion, high entropy, high language attention, or interaction regions; recompute those</a:t>
-            </a:r>
-            <a:endParaRPr lang="en-US" sz="1050" dirty="0"/>
+              <a:t>Recompute patches with motion, entropy, or language attention</a:t>
+            </a:r>
+            <a:endParaRPr lang="en-US" sz="1100" dirty="0"/>
           </a:p>
           <a:p>
             <a:pPr marL="177800" indent="-177800">
               <a:spcAft>
-                <a:spcPts val="300"/>
+                <a:spcPts val="600"/>
               </a:spcAft>
               <a:buSzPct val="100000"/>
               <a:buChar char="•"/>
             </a:pPr>
             <a:r>
-              <a:rPr lang="en-US" sz="1050" dirty="0">
+              <a:rPr lang="en-US" sz="1100" dirty="0">
                 <a:solidFill>
                   <a:srgbClr val="1F2933"/>
                 </a:solidFill>
@@ -8587,36 +8137,15 @@
                 <a:ea typeface="Arial" pitchFamily="34" charset="-122"/>
                 <a:cs typeface="Arial" pitchFamily="34" charset="-120"/>
               </a:rPr>
-              <a:t>The same reuse mask is shared with the generation cache</a:t>
-            </a:r>
-            <a:endParaRPr lang="en-US" sz="1050" dirty="0"/>
-          </a:p>
-          <a:p>
-            <a:pPr marL="177800" indent="-177800">
-              <a:spcAft>
-                <a:spcPts val="300"/>
-              </a:spcAft>
-              <a:buSzPct val="100000"/>
-              <a:buChar char="•"/>
-            </a:pPr>
-            <a:r>
-              <a:rPr lang="en-US" sz="1050" dirty="0">
-                <a:solidFill>
-                  <a:srgbClr val="1F2933"/>
-                </a:solidFill>
-                <a:latin typeface="Arial" pitchFamily="34" charset="0"/>
-                <a:ea typeface="Arial" pitchFamily="34" charset="-122"/>
-                <a:cs typeface="Arial" pitchFamily="34" charset="-120"/>
-              </a:rPr>
               <a:t>Presets: motion-entropy, task-aware, conservative-adaptive</a:t>
             </a:r>
-            <a:endParaRPr lang="en-US" sz="1050" dirty="0"/>
+            <a:endParaRPr lang="en-US" sz="1100" dirty="0"/>
           </a:p>
         </p:txBody>
       </p:sp>
       <p:pic>
         <p:nvPicPr>
-          <p:cNvPr id="8" name="Image 1" descr="/tmp/claude-0/-home-user-BiVLA/4327cefa-ba5d-5e2e-9d87-c73dd3a8ccbb/scratchpad/video_ppt/assets/m_cache.png">    </p:cNvPr>
+          <p:cNvPr id="7" name="Image 1" descr="/tmp/claude-0/-home-user-BiVLA/4327cefa-ba5d-5e2e-9d87-c73dd3a8ccbb/scratchpad/video_ppt/assets/m_cache.png">    </p:cNvPr>
           <p:cNvPicPr>
             <a:picLocks noChangeAspect="1"/>
           </p:cNvPicPr>
@@ -8640,14 +8169,14 @@
       </p:pic>
       <p:sp>
         <p:nvSpPr>
-          <p:cNvPr id="9" name="Text 5"/>
+          <p:cNvPr id="8" name="Text 4"/>
           <p:cNvSpPr txBox="1"/>
           <p:nvPr/>
         </p:nvSpPr>
         <p:spPr>
           <a:xfrm>
             <a:off x="457200" y="4480560"/>
-            <a:ext cx="2377440" cy="365760"/>
+            <a:ext cx="2377440" cy="274320"/>
           </a:xfrm>
           <a:prstGeom prst="rect">
             <a:avLst/>
@@ -8671,7 +8200,7 @@
                 <a:ea typeface="Arial" pitchFamily="34" charset="-122"/>
                 <a:cs typeface="Arial" pitchFamily="34" charset="-120"/>
               </a:rPr>
-              <a:t>Top: fusion mask. Bottom: VLA-Cache criterion (stable, task-irrelevant patches reused).</a:t>
+              <a:t>Top: fusion mask. Bottom: VLA-Cache criterion.</a:t>
             </a:r>
             <a:endParaRPr lang="en-US" sz="950" dirty="0"/>
           </a:p>
@@ -8679,7 +8208,7 @@
       </p:sp>
       <p:sp>
         <p:nvSpPr>
-          <p:cNvPr id="10" name="Shape 6"/>
+          <p:cNvPr id="9" name="Shape 5"/>
           <p:cNvSpPr/>
           <p:nvPr/>
         </p:nvSpPr>
@@ -8706,7 +8235,7 @@
       </p:sp>
       <p:sp>
         <p:nvSpPr>
-          <p:cNvPr id="11" name="Shape 7"/>
+          <p:cNvPr id="10" name="Shape 6"/>
           <p:cNvSpPr/>
           <p:nvPr/>
         </p:nvSpPr>
@@ -8731,7 +8260,7 @@
       </p:sp>
       <p:sp>
         <p:nvSpPr>
-          <p:cNvPr id="12" name="Shape 8"/>
+          <p:cNvPr id="11" name="Shape 7"/>
           <p:cNvSpPr/>
           <p:nvPr/>
         </p:nvSpPr>
@@ -8756,14 +8285,53 @@
       </p:sp>
       <p:sp>
         <p:nvSpPr>
+          <p:cNvPr id="12" name="Text 8"/>
+          <p:cNvSpPr txBox="1"/>
+          <p:nvPr/>
+        </p:nvSpPr>
+        <p:spPr>
+          <a:xfrm>
+            <a:off x="4846320" y="2583180"/>
+            <a:ext cx="3749040" cy="274320"/>
+          </a:xfrm>
+          <a:prstGeom prst="rect">
+            <a:avLst/>
+          </a:prstGeom>
+          <a:noFill/>
+          <a:ln/>
+        </p:spPr>
+        <p:txBody>
+          <a:bodyPr wrap="square" lIns="0" tIns="0" rIns="0" bIns="0" rtlCol="0" anchor="ctr"/>
+          <a:lstStyle/>
+          <a:p>
+            <a:pPr algn="ctr" indent="0" marL="0">
+              <a:buNone/>
+            </a:pPr>
+            <a:r>
+              <a:rPr lang="en-US" sz="1200" b="1" dirty="0">
+                <a:solidFill>
+                  <a:srgbClr val="FFFFFF"/>
+                </a:solidFill>
+                <a:latin typeface="Arial" pitchFamily="34" charset="0"/>
+                <a:ea typeface="Arial" pitchFamily="34" charset="-122"/>
+                <a:cs typeface="Arial" pitchFamily="34" charset="-120"/>
+              </a:rPr>
+              <a:t>CLIP: original vs temporal fusion</a:t>
+            </a:r>
+            <a:endParaRPr lang="en-US" sz="1200" dirty="0"/>
+          </a:p>
+        </p:txBody>
+      </p:sp>
+      <p:sp>
+        <p:nvSpPr>
           <p:cNvPr id="13" name="Text 9"/>
           <p:cNvSpPr txBox="1"/>
           <p:nvPr/>
         </p:nvSpPr>
         <p:spPr>
           <a:xfrm>
-            <a:off x="4846320" y="2583180"/>
-            <a:ext cx="3749040" cy="274320"/>
+            <a:off x="4846320" y="2830068"/>
+            <a:ext cx="3749040" cy="365760"/>
           </a:xfrm>
           <a:prstGeom prst="rect">
             <a:avLst/>
@@ -8772,69 +8340,30 @@
           <a:ln/>
         </p:spPr>
         <p:txBody>
-          <a:bodyPr wrap="square" lIns="0" tIns="0" rIns="0" bIns="0" rtlCol="0" anchor="ctr"/>
+          <a:bodyPr wrap="square" lIns="0" tIns="0" rIns="0" bIns="0" rtlCol="0" anchor="t"/>
           <a:lstStyle/>
           <a:p>
             <a:pPr algn="ctr" indent="0" marL="0">
               <a:buNone/>
             </a:pPr>
             <a:r>
-              <a:rPr lang="en-US" sz="1200" b="1" dirty="0">
-                <a:solidFill>
-                  <a:srgbClr val="FFFFFF"/>
-                </a:solidFill>
-                <a:latin typeface="Arial" pitchFamily="34" charset="0"/>
-                <a:ea typeface="Arial" pitchFamily="34" charset="-122"/>
-                <a:cs typeface="Arial" pitchFamily="34" charset="-120"/>
-              </a:rPr>
-              <a:t>CLIP: original vs temporal fusion</a:t>
-            </a:r>
-            <a:endParaRPr lang="en-US" sz="1200" dirty="0"/>
+              <a:rPr lang="en-US" sz="950" dirty="0">
+                <a:solidFill>
+                  <a:srgbClr val="C9D1DC"/>
+                </a:solidFill>
+                <a:latin typeface="Arial" pitchFamily="34" charset="0"/>
+                <a:ea typeface="Arial" pitchFamily="34" charset="-122"/>
+                <a:cs typeface="Arial" pitchFamily="34" charset="-120"/>
+              </a:rPr>
+              <a:t>same episode, same initial state</a:t>
+            </a:r>
+            <a:endParaRPr lang="en-US" sz="950" dirty="0"/>
           </a:p>
         </p:txBody>
       </p:sp>
       <p:sp>
         <p:nvSpPr>
           <p:cNvPr id="14" name="Text 10"/>
-          <p:cNvSpPr txBox="1"/>
-          <p:nvPr/>
-        </p:nvSpPr>
-        <p:spPr>
-          <a:xfrm>
-            <a:off x="4846320" y="2830068"/>
-            <a:ext cx="3749040" cy="365760"/>
-          </a:xfrm>
-          <a:prstGeom prst="rect">
-            <a:avLst/>
-          </a:prstGeom>
-          <a:noFill/>
-          <a:ln/>
-        </p:spPr>
-        <p:txBody>
-          <a:bodyPr wrap="square" lIns="0" tIns="0" rIns="0" bIns="0" rtlCol="0" anchor="t"/>
-          <a:lstStyle/>
-          <a:p>
-            <a:pPr algn="ctr" indent="0" marL="0">
-              <a:buNone/>
-            </a:pPr>
-            <a:r>
-              <a:rPr lang="en-US" sz="950" dirty="0">
-                <a:solidFill>
-                  <a:srgbClr val="C9D1DC"/>
-                </a:solidFill>
-                <a:latin typeface="Arial" pitchFamily="34" charset="0"/>
-                <a:ea typeface="Arial" pitchFamily="34" charset="-122"/>
-                <a:cs typeface="Arial" pitchFamily="34" charset="-120"/>
-              </a:rPr>
-              <a:t>same episode, same initial state</a:t>
-            </a:r>
-            <a:endParaRPr lang="en-US" sz="950" dirty="0"/>
-          </a:p>
-        </p:txBody>
-      </p:sp>
-      <p:sp>
-        <p:nvSpPr>
-          <p:cNvPr id="15" name="Text 11"/>
           <p:cNvSpPr txBox="1"/>
           <p:nvPr/>
         </p:nvSpPr>
@@ -8906,45 +8435,6 @@
       <p:sp>
         <p:nvSpPr>
           <p:cNvPr id="2" name="Text 0"/>
-          <p:cNvSpPr txBox="1"/>
-          <p:nvPr/>
-        </p:nvSpPr>
-        <p:spPr>
-          <a:xfrm>
-            <a:off x="7680960" y="73152"/>
-            <a:ext cx="1280160" cy="228600"/>
-          </a:xfrm>
-          <a:prstGeom prst="rect">
-            <a:avLst/>
-          </a:prstGeom>
-          <a:noFill/>
-          <a:ln/>
-        </p:spPr>
-        <p:txBody>
-          <a:bodyPr wrap="square" lIns="0" tIns="0" rIns="0" bIns="0" rtlCol="0" anchor="ctr"/>
-          <a:lstStyle/>
-          <a:p>
-            <a:pPr algn="r" indent="0" marL="0">
-              <a:buNone/>
-            </a:pPr>
-            <a:r>
-              <a:rPr lang="en-US" sz="900" dirty="0">
-                <a:solidFill>
-                  <a:srgbClr val="5F6B7A"/>
-                </a:solidFill>
-                <a:latin typeface="Arial" pitchFamily="34" charset="0"/>
-                <a:ea typeface="Arial" pitchFamily="34" charset="-122"/>
-                <a:cs typeface="Arial" pitchFamily="34" charset="-120"/>
-              </a:rPr>
-              <a:t>7  ·  12s</a:t>
-            </a:r>
-            <a:endParaRPr lang="en-US" sz="900" dirty="0"/>
-          </a:p>
-        </p:txBody>
-      </p:sp>
-      <p:sp>
-        <p:nvSpPr>
-          <p:cNvPr id="3" name="Text 1"/>
           <p:cNvSpPr txBox="1"/>
           <p:nvPr/>
         </p:nvSpPr>
@@ -11119,14 +10609,53 @@
       </p:graphicFrame>
       <p:sp>
         <p:nvSpPr>
+          <p:cNvPr id="4" name="Text 1"/>
+          <p:cNvSpPr txBox="1"/>
+          <p:nvPr/>
+        </p:nvSpPr>
+        <p:spPr>
+          <a:xfrm>
+            <a:off x="457200" y="3794760"/>
+            <a:ext cx="4572000" cy="594360"/>
+          </a:xfrm>
+          <a:prstGeom prst="rect">
+            <a:avLst/>
+          </a:prstGeom>
+          <a:noFill/>
+          <a:ln/>
+        </p:spPr>
+        <p:txBody>
+          <a:bodyPr wrap="square" lIns="0" tIns="0" rIns="0" bIns="0" rtlCol="0" anchor="t"/>
+          <a:lstStyle/>
+          <a:p>
+            <a:pPr algn="l" indent="0" marL="0">
+              <a:buNone/>
+            </a:pPr>
+            <a:r>
+              <a:rPr lang="en-US" sz="1050" dirty="0">
+                <a:solidFill>
+                  <a:srgbClr val="5F6B7A"/>
+                </a:solidFill>
+                <a:latin typeface="Arial" pitchFamily="34" charset="0"/>
+                <a:ea typeface="Arial" pitchFamily="34" charset="-122"/>
+                <a:cs typeface="Arial" pitchFamily="34" charset="-120"/>
+              </a:rPr>
+              <a:t>SimplerEnv WidowX: 4 tasks × 50 episodes.  Google Robot/Fractal: 5 tasks × 50.  LIBERO: Long, Goal, Object, Spatial, each suite a separate pair (3 × 4 = 12), giving 22 pairs in total.</a:t>
+            </a:r>
+            <a:endParaRPr lang="en-US" sz="1050" dirty="0"/>
+          </a:p>
+        </p:txBody>
+      </p:sp>
+      <p:sp>
+        <p:nvSpPr>
           <p:cNvPr id="5" name="Text 2"/>
           <p:cNvSpPr txBox="1"/>
           <p:nvPr/>
         </p:nvSpPr>
         <p:spPr>
           <a:xfrm>
-            <a:off x="457200" y="3794760"/>
-            <a:ext cx="4572000" cy="594360"/>
+            <a:off x="5212080" y="1005840"/>
+            <a:ext cx="1143000" cy="685800"/>
           </a:xfrm>
           <a:prstGeom prst="rect">
             <a:avLst/>
@@ -11135,24 +10664,24 @@
           <a:ln/>
         </p:spPr>
         <p:txBody>
-          <a:bodyPr wrap="square" lIns="0" tIns="0" rIns="0" bIns="0" rtlCol="0" anchor="t"/>
-          <a:lstStyle/>
-          <a:p>
-            <a:pPr algn="l" indent="0" marL="0">
+          <a:bodyPr wrap="square" lIns="0" tIns="0" rIns="0" bIns="0" rtlCol="0" anchor="ctr"/>
+          <a:lstStyle/>
+          <a:p>
+            <a:pPr algn="ctr" indent="0" marL="0">
               <a:buNone/>
             </a:pPr>
             <a:r>
-              <a:rPr lang="en-US" sz="1050" dirty="0">
-                <a:solidFill>
-                  <a:srgbClr val="5F6B7A"/>
-                </a:solidFill>
-                <a:latin typeface="Arial" pitchFamily="34" charset="0"/>
-                <a:ea typeface="Arial" pitchFamily="34" charset="-122"/>
-                <a:cs typeface="Arial" pitchFamily="34" charset="-120"/>
-              </a:rPr>
-              <a:t>SimplerEnv WidowX: 4 tasks × 50 episodes.  Google Robot/Fractal: 5 tasks × 50.  LIBERO: Long, Goal, Object, Spatial, each suite a separate pair (3 × 4 = 12), giving 22 pairs in total.</a:t>
-            </a:r>
-            <a:endParaRPr lang="en-US" sz="1050" dirty="0"/>
+              <a:rPr lang="en-US" sz="3000" b="1" dirty="0">
+                <a:solidFill>
+                  <a:srgbClr val="1B7F79"/>
+                </a:solidFill>
+                <a:latin typeface="Arial" pitchFamily="34" charset="0"/>
+                <a:ea typeface="Arial" pitchFamily="34" charset="-122"/>
+                <a:cs typeface="Arial" pitchFamily="34" charset="-120"/>
+              </a:rPr>
+              <a:t>22</a:t>
+            </a:r>
+            <a:endParaRPr lang="en-US" sz="3000" dirty="0"/>
           </a:p>
         </p:txBody>
       </p:sp>
@@ -11164,8 +10693,8 @@
         </p:nvSpPr>
         <p:spPr>
           <a:xfrm>
-            <a:off x="5212080" y="1005840"/>
-            <a:ext cx="1143000" cy="685800"/>
+            <a:off x="5212080" y="1691640"/>
+            <a:ext cx="1143000" cy="457200"/>
           </a:xfrm>
           <a:prstGeom prst="rect">
             <a:avLst/>
@@ -11174,24 +10703,24 @@
           <a:ln/>
         </p:spPr>
         <p:txBody>
-          <a:bodyPr wrap="square" lIns="0" tIns="0" rIns="0" bIns="0" rtlCol="0" anchor="ctr"/>
+          <a:bodyPr wrap="square" lIns="0" tIns="0" rIns="0" bIns="0" rtlCol="0" anchor="t"/>
           <a:lstStyle/>
           <a:p>
             <a:pPr algn="ctr" indent="0" marL="0">
               <a:buNone/>
             </a:pPr>
             <a:r>
-              <a:rPr lang="en-US" sz="3000" b="1" dirty="0">
-                <a:solidFill>
-                  <a:srgbClr val="1B7F79"/>
-                </a:solidFill>
-                <a:latin typeface="Arial" pitchFamily="34" charset="0"/>
-                <a:ea typeface="Arial" pitchFamily="34" charset="-122"/>
-                <a:cs typeface="Arial" pitchFamily="34" charset="-120"/>
-              </a:rPr>
-              <a:t>22</a:t>
-            </a:r>
-            <a:endParaRPr lang="en-US" sz="3000" dirty="0"/>
+              <a:rPr lang="en-US" sz="1050" dirty="0">
+                <a:solidFill>
+                  <a:srgbClr val="5F6B7A"/>
+                </a:solidFill>
+                <a:latin typeface="Arial" pitchFamily="34" charset="0"/>
+                <a:ea typeface="Arial" pitchFamily="34" charset="-122"/>
+                <a:cs typeface="Arial" pitchFamily="34" charset="-120"/>
+              </a:rPr>
+              <a:t>backbone × environment pairs</a:t>
+            </a:r>
+            <a:endParaRPr lang="en-US" sz="1050" dirty="0"/>
           </a:p>
         </p:txBody>
       </p:sp>
@@ -11203,8 +10732,8 @@
         </p:nvSpPr>
         <p:spPr>
           <a:xfrm>
-            <a:off x="5212080" y="1691640"/>
-            <a:ext cx="1143000" cy="457200"/>
+            <a:off x="6400800" y="1005840"/>
+            <a:ext cx="1143000" cy="685800"/>
           </a:xfrm>
           <a:prstGeom prst="rect">
             <a:avLst/>
@@ -11213,24 +10742,24 @@
           <a:ln/>
         </p:spPr>
         <p:txBody>
-          <a:bodyPr wrap="square" lIns="0" tIns="0" rIns="0" bIns="0" rtlCol="0" anchor="t"/>
+          <a:bodyPr wrap="square" lIns="0" tIns="0" rIns="0" bIns="0" rtlCol="0" anchor="ctr"/>
           <a:lstStyle/>
           <a:p>
             <a:pPr algn="ctr" indent="0" marL="0">
               <a:buNone/>
             </a:pPr>
             <a:r>
-              <a:rPr lang="en-US" sz="1050" dirty="0">
-                <a:solidFill>
-                  <a:srgbClr val="5F6B7A"/>
-                </a:solidFill>
-                <a:latin typeface="Arial" pitchFamily="34" charset="0"/>
-                <a:ea typeface="Arial" pitchFamily="34" charset="-122"/>
-                <a:cs typeface="Arial" pitchFamily="34" charset="-120"/>
-              </a:rPr>
-              <a:t>backbone × environment pairs</a:t>
-            </a:r>
-            <a:endParaRPr lang="en-US" sz="1050" dirty="0"/>
+              <a:rPr lang="en-US" sz="3000" b="1" dirty="0">
+                <a:solidFill>
+                  <a:srgbClr val="1B7F79"/>
+                </a:solidFill>
+                <a:latin typeface="Arial" pitchFamily="34" charset="0"/>
+                <a:ea typeface="Arial" pitchFamily="34" charset="-122"/>
+                <a:cs typeface="Arial" pitchFamily="34" charset="-120"/>
+              </a:rPr>
+              <a:t>13 + 1</a:t>
+            </a:r>
+            <a:endParaRPr lang="en-US" sz="3000" dirty="0"/>
           </a:p>
         </p:txBody>
       </p:sp>
@@ -11242,8 +10771,8 @@
         </p:nvSpPr>
         <p:spPr>
           <a:xfrm>
-            <a:off x="6400800" y="1005840"/>
-            <a:ext cx="1143000" cy="685800"/>
+            <a:off x="6400800" y="1691640"/>
+            <a:ext cx="1143000" cy="457200"/>
           </a:xfrm>
           <a:prstGeom prst="rect">
             <a:avLst/>
@@ -11252,24 +10781,24 @@
           <a:ln/>
         </p:spPr>
         <p:txBody>
-          <a:bodyPr wrap="square" lIns="0" tIns="0" rIns="0" bIns="0" rtlCol="0" anchor="ctr"/>
+          <a:bodyPr wrap="square" lIns="0" tIns="0" rIns="0" bIns="0" rtlCol="0" anchor="t"/>
           <a:lstStyle/>
           <a:p>
             <a:pPr algn="ctr" indent="0" marL="0">
               <a:buNone/>
             </a:pPr>
             <a:r>
-              <a:rPr lang="en-US" sz="3000" b="1" dirty="0">
-                <a:solidFill>
-                  <a:srgbClr val="1B7F79"/>
-                </a:solidFill>
-                <a:latin typeface="Arial" pitchFamily="34" charset="0"/>
-                <a:ea typeface="Arial" pitchFamily="34" charset="-122"/>
-                <a:cs typeface="Arial" pitchFamily="34" charset="-120"/>
-              </a:rPr>
-              <a:t>13 + 1</a:t>
-            </a:r>
-            <a:endParaRPr lang="en-US" sz="3000" dirty="0"/>
+              <a:rPr lang="en-US" sz="1050" dirty="0">
+                <a:solidFill>
+                  <a:srgbClr val="5F6B7A"/>
+                </a:solidFill>
+                <a:latin typeface="Arial" pitchFamily="34" charset="0"/>
+                <a:ea typeface="Arial" pitchFamily="34" charset="-122"/>
+                <a:cs typeface="Arial" pitchFamily="34" charset="-120"/>
+              </a:rPr>
+              <a:t>trick settings + original, per pair</a:t>
+            </a:r>
+            <a:endParaRPr lang="en-US" sz="1050" dirty="0"/>
           </a:p>
         </p:txBody>
       </p:sp>
@@ -11281,8 +10810,8 @@
         </p:nvSpPr>
         <p:spPr>
           <a:xfrm>
-            <a:off x="6400800" y="1691640"/>
-            <a:ext cx="1143000" cy="457200"/>
+            <a:off x="7589520" y="1005840"/>
+            <a:ext cx="1143000" cy="685800"/>
           </a:xfrm>
           <a:prstGeom prst="rect">
             <a:avLst/>
@@ -11291,24 +10820,24 @@
           <a:ln/>
         </p:spPr>
         <p:txBody>
-          <a:bodyPr wrap="square" lIns="0" tIns="0" rIns="0" bIns="0" rtlCol="0" anchor="t"/>
+          <a:bodyPr wrap="square" lIns="0" tIns="0" rIns="0" bIns="0" rtlCol="0" anchor="ctr"/>
           <a:lstStyle/>
           <a:p>
             <a:pPr algn="ctr" indent="0" marL="0">
               <a:buNone/>
             </a:pPr>
             <a:r>
-              <a:rPr lang="en-US" sz="1050" dirty="0">
-                <a:solidFill>
-                  <a:srgbClr val="5F6B7A"/>
-                </a:solidFill>
-                <a:latin typeface="Arial" pitchFamily="34" charset="0"/>
-                <a:ea typeface="Arial" pitchFamily="34" charset="-122"/>
-                <a:cs typeface="Arial" pitchFamily="34" charset="-120"/>
-              </a:rPr>
-              <a:t>trick settings + original, per pair</a:t>
-            </a:r>
-            <a:endParaRPr lang="en-US" sz="1050" dirty="0"/>
+              <a:rPr lang="en-US" sz="3000" b="1" dirty="0">
+                <a:solidFill>
+                  <a:srgbClr val="1B7F79"/>
+                </a:solidFill>
+                <a:latin typeface="Arial" pitchFamily="34" charset="0"/>
+                <a:ea typeface="Arial" pitchFamily="34" charset="-122"/>
+                <a:cs typeface="Arial" pitchFamily="34" charset="-120"/>
+              </a:rPr>
+              <a:t>286</a:t>
+            </a:r>
+            <a:endParaRPr lang="en-US" sz="3000" dirty="0"/>
           </a:p>
         </p:txBody>
       </p:sp>
@@ -11320,8 +10849,8 @@
         </p:nvSpPr>
         <p:spPr>
           <a:xfrm>
-            <a:off x="7589520" y="1005840"/>
-            <a:ext cx="1143000" cy="685800"/>
+            <a:off x="7589520" y="1691640"/>
+            <a:ext cx="1143000" cy="457200"/>
           </a:xfrm>
           <a:prstGeom prst="rect">
             <a:avLst/>
@@ -11330,69 +10859,30 @@
           <a:ln/>
         </p:spPr>
         <p:txBody>
-          <a:bodyPr wrap="square" lIns="0" tIns="0" rIns="0" bIns="0" rtlCol="0" anchor="ctr"/>
+          <a:bodyPr wrap="square" lIns="0" tIns="0" rIns="0" bIns="0" rtlCol="0" anchor="t"/>
           <a:lstStyle/>
           <a:p>
             <a:pPr algn="ctr" indent="0" marL="0">
               <a:buNone/>
             </a:pPr>
             <a:r>
-              <a:rPr lang="en-US" sz="3000" b="1" dirty="0">
-                <a:solidFill>
-                  <a:srgbClr val="1B7F79"/>
-                </a:solidFill>
-                <a:latin typeface="Arial" pitchFamily="34" charset="0"/>
-                <a:ea typeface="Arial" pitchFamily="34" charset="-122"/>
-                <a:cs typeface="Arial" pitchFamily="34" charset="-120"/>
-              </a:rPr>
-              <a:t>286</a:t>
-            </a:r>
-            <a:endParaRPr lang="en-US" sz="3000" dirty="0"/>
+              <a:rPr lang="en-US" sz="1050" dirty="0">
+                <a:solidFill>
+                  <a:srgbClr val="5F6B7A"/>
+                </a:solidFill>
+                <a:latin typeface="Arial" pitchFamily="34" charset="0"/>
+                <a:ea typeface="Arial" pitchFamily="34" charset="-122"/>
+                <a:cs typeface="Arial" pitchFamily="34" charset="-120"/>
+              </a:rPr>
+              <a:t>trick settings, all paired with the original</a:t>
+            </a:r>
+            <a:endParaRPr lang="en-US" sz="1050" dirty="0"/>
           </a:p>
         </p:txBody>
       </p:sp>
       <p:sp>
         <p:nvSpPr>
           <p:cNvPr id="11" name="Text 8"/>
-          <p:cNvSpPr txBox="1"/>
-          <p:nvPr/>
-        </p:nvSpPr>
-        <p:spPr>
-          <a:xfrm>
-            <a:off x="7589520" y="1691640"/>
-            <a:ext cx="1143000" cy="457200"/>
-          </a:xfrm>
-          <a:prstGeom prst="rect">
-            <a:avLst/>
-          </a:prstGeom>
-          <a:noFill/>
-          <a:ln/>
-        </p:spPr>
-        <p:txBody>
-          <a:bodyPr wrap="square" lIns="0" tIns="0" rIns="0" bIns="0" rtlCol="0" anchor="t"/>
-          <a:lstStyle/>
-          <a:p>
-            <a:pPr algn="ctr" indent="0" marL="0">
-              <a:buNone/>
-            </a:pPr>
-            <a:r>
-              <a:rPr lang="en-US" sz="1050" dirty="0">
-                <a:solidFill>
-                  <a:srgbClr val="5F6B7A"/>
-                </a:solidFill>
-                <a:latin typeface="Arial" pitchFamily="34" charset="0"/>
-                <a:ea typeface="Arial" pitchFamily="34" charset="-122"/>
-                <a:cs typeface="Arial" pitchFamily="34" charset="-120"/>
-              </a:rPr>
-              <a:t>trick settings, all paired with the original</a:t>
-            </a:r>
-            <a:endParaRPr lang="en-US" sz="1050" dirty="0"/>
-          </a:p>
-        </p:txBody>
-      </p:sp>
-      <p:sp>
-        <p:nvSpPr>
-          <p:cNvPr id="12" name="Text 9"/>
           <p:cNvSpPr txBox="1"/>
           <p:nvPr/>
         </p:nvSpPr>
@@ -11557,8 +11047,8 @@
         </p:nvSpPr>
         <p:spPr>
           <a:xfrm>
-            <a:off x="7680960" y="73152"/>
-            <a:ext cx="1280160" cy="228600"/>
+            <a:off x="457200" y="292608"/>
+            <a:ext cx="8229600" cy="640080"/>
           </a:xfrm>
           <a:prstGeom prst="rect">
             <a:avLst/>
@@ -11570,45 +11060,6 @@
           <a:bodyPr wrap="square" lIns="0" tIns="0" rIns="0" bIns="0" rtlCol="0" anchor="ctr"/>
           <a:lstStyle/>
           <a:p>
-            <a:pPr algn="r" indent="0" marL="0">
-              <a:buNone/>
-            </a:pPr>
-            <a:r>
-              <a:rPr lang="en-US" sz="900" dirty="0">
-                <a:solidFill>
-                  <a:srgbClr val="5F6B7A"/>
-                </a:solidFill>
-                <a:latin typeface="Arial" pitchFamily="34" charset="0"/>
-                <a:ea typeface="Arial" pitchFamily="34" charset="-122"/>
-                <a:cs typeface="Arial" pitchFamily="34" charset="-120"/>
-              </a:rPr>
-              <a:t>8  ·  12s</a:t>
-            </a:r>
-            <a:endParaRPr lang="en-US" sz="900" dirty="0"/>
-          </a:p>
-        </p:txBody>
-      </p:sp>
-      <p:sp>
-        <p:nvSpPr>
-          <p:cNvPr id="3" name="Text 1"/>
-          <p:cNvSpPr txBox="1"/>
-          <p:nvPr/>
-        </p:nvSpPr>
-        <p:spPr>
-          <a:xfrm>
-            <a:off x="457200" y="292608"/>
-            <a:ext cx="8229600" cy="640080"/>
-          </a:xfrm>
-          <a:prstGeom prst="rect">
-            <a:avLst/>
-          </a:prstGeom>
-          <a:noFill/>
-          <a:ln/>
-        </p:spPr>
-        <p:txBody>
-          <a:bodyPr wrap="square" lIns="0" tIns="0" rIns="0" bIns="0" rtlCol="0" anchor="ctr"/>
-          <a:lstStyle/>
-          <a:p>
             <a:pPr indent="0" marL="0">
               <a:buNone/>
             </a:pPr>
@@ -11629,7 +11080,7 @@
       </p:sp>
       <p:pic>
         <p:nvPicPr>
-          <p:cNvPr id="4" name="Image 0" descr="/tmp/claude-0/-home-user-BiVLA/4327cefa-ba5d-5e2e-9d87-c73dd3a8ccbb/scratchpad/video_ppt/assets/fig1_teaser_nolegend.png">    </p:cNvPr>
+          <p:cNvPr id="3" name="Image 0" descr="/tmp/claude-0/-home-user-BiVLA/4327cefa-ba5d-5e2e-9d87-c73dd3a8ccbb/scratchpad/video_ppt/assets/fig1_teaser_nolegend.png">    </p:cNvPr>
           <p:cNvPicPr>
             <a:picLocks noChangeAspect="1"/>
           </p:cNvPicPr>
@@ -11653,7 +11104,7 @@
       </p:pic>
       <p:sp>
         <p:nvSpPr>
-          <p:cNvPr id="5" name="Shape 2"/>
+          <p:cNvPr id="4" name="Shape 1"/>
           <p:cNvSpPr/>
           <p:nvPr/>
         </p:nvSpPr>
@@ -11678,7 +11129,7 @@
       </p:sp>
       <p:sp>
         <p:nvSpPr>
-          <p:cNvPr id="6" name="Text 3"/>
+          <p:cNvPr id="5" name="Text 2"/>
           <p:cNvSpPr txBox="1"/>
           <p:nvPr/>
         </p:nvSpPr>
@@ -11717,7 +11168,7 @@
       </p:sp>
       <p:sp>
         <p:nvSpPr>
-          <p:cNvPr id="7" name="Shape 4"/>
+          <p:cNvPr id="6" name="Shape 3"/>
           <p:cNvSpPr/>
           <p:nvPr/>
         </p:nvSpPr>
@@ -11742,7 +11193,7 @@
       </p:sp>
       <p:sp>
         <p:nvSpPr>
-          <p:cNvPr id="8" name="Text 5"/>
+          <p:cNvPr id="7" name="Text 4"/>
           <p:cNvSpPr txBox="1"/>
           <p:nvPr/>
         </p:nvSpPr>
@@ -11781,7 +11232,7 @@
       </p:sp>
       <p:sp>
         <p:nvSpPr>
-          <p:cNvPr id="9" name="Shape 6"/>
+          <p:cNvPr id="8" name="Shape 5"/>
           <p:cNvSpPr/>
           <p:nvPr/>
         </p:nvSpPr>
@@ -11806,7 +11257,7 @@
       </p:sp>
       <p:sp>
         <p:nvSpPr>
-          <p:cNvPr id="10" name="Text 7"/>
+          <p:cNvPr id="9" name="Text 6"/>
           <p:cNvSpPr txBox="1"/>
           <p:nvPr/>
         </p:nvSpPr>
@@ -11845,7 +11296,7 @@
       </p:sp>
       <p:sp>
         <p:nvSpPr>
-          <p:cNvPr id="11" name="Shape 8"/>
+          <p:cNvPr id="10" name="Shape 7"/>
           <p:cNvSpPr/>
           <p:nvPr/>
         </p:nvSpPr>
@@ -11870,7 +11321,7 @@
       </p:sp>
       <p:sp>
         <p:nvSpPr>
-          <p:cNvPr id="12" name="Text 9"/>
+          <p:cNvPr id="11" name="Text 8"/>
           <p:cNvSpPr txBox="1"/>
           <p:nvPr/>
         </p:nvSpPr>
@@ -11909,7 +11360,7 @@
       </p:sp>
       <p:sp>
         <p:nvSpPr>
-          <p:cNvPr id="13" name="Shape 10"/>
+          <p:cNvPr id="12" name="Shape 9"/>
           <p:cNvSpPr/>
           <p:nvPr/>
         </p:nvSpPr>
@@ -11934,7 +11385,7 @@
       </p:sp>
       <p:sp>
         <p:nvSpPr>
-          <p:cNvPr id="14" name="Text 11"/>
+          <p:cNvPr id="13" name="Text 10"/>
           <p:cNvSpPr txBox="1"/>
           <p:nvPr/>
         </p:nvSpPr>
@@ -11973,7 +11424,7 @@
       </p:sp>
       <p:sp>
         <p:nvSpPr>
-          <p:cNvPr id="15" name="Shape 12"/>
+          <p:cNvPr id="14" name="Shape 11"/>
           <p:cNvSpPr/>
           <p:nvPr/>
         </p:nvSpPr>
@@ -11998,7 +11449,7 @@
       </p:sp>
       <p:sp>
         <p:nvSpPr>
-          <p:cNvPr id="16" name="Text 13"/>
+          <p:cNvPr id="15" name="Text 12"/>
           <p:cNvSpPr txBox="1"/>
           <p:nvPr/>
         </p:nvSpPr>
@@ -12037,7 +11488,7 @@
       </p:sp>
       <p:sp>
         <p:nvSpPr>
-          <p:cNvPr id="17" name="Shape 14"/>
+          <p:cNvPr id="16" name="Shape 13"/>
           <p:cNvSpPr/>
           <p:nvPr/>
         </p:nvSpPr>
@@ -12064,14 +11515,53 @@
       </p:sp>
       <p:sp>
         <p:nvSpPr>
+          <p:cNvPr id="17" name="Text 14"/>
+          <p:cNvSpPr txBox="1"/>
+          <p:nvPr/>
+        </p:nvSpPr>
+        <p:spPr>
+          <a:xfrm>
+            <a:off x="4480560" y="1005840"/>
+            <a:ext cx="1234440" cy="365760"/>
+          </a:xfrm>
+          <a:prstGeom prst="rect">
+            <a:avLst/>
+          </a:prstGeom>
+          <a:noFill/>
+          <a:ln/>
+        </p:spPr>
+        <p:txBody>
+          <a:bodyPr wrap="square" lIns="0" tIns="0" rIns="0" bIns="0" rtlCol="0" anchor="ctr"/>
+          <a:lstStyle/>
+          <a:p>
+            <a:pPr algn="ctr" indent="0" marL="0">
+              <a:buNone/>
+            </a:pPr>
+            <a:r>
+              <a:rPr lang="en-US" sz="1100" b="1" dirty="0">
+                <a:solidFill>
+                  <a:srgbClr val="F5F7FA"/>
+                </a:solidFill>
+                <a:latin typeface="Arial" pitchFamily="34" charset="0"/>
+                <a:ea typeface="Arial" pitchFamily="34" charset="-122"/>
+                <a:cs typeface="Arial" pitchFamily="34" charset="-120"/>
+              </a:rPr>
+              <a:t>Q1  Success</a:t>
+            </a:r>
+            <a:endParaRPr lang="en-US" sz="1100" dirty="0"/>
+          </a:p>
+        </p:txBody>
+      </p:sp>
+      <p:sp>
+        <p:nvSpPr>
           <p:cNvPr id="18" name="Text 15"/>
           <p:cNvSpPr txBox="1"/>
           <p:nvPr/>
         </p:nvSpPr>
         <p:spPr>
           <a:xfrm>
-            <a:off x="4480560" y="1005840"/>
-            <a:ext cx="1234440" cy="365760"/>
+            <a:off x="5806440" y="914400"/>
+            <a:ext cx="2880360" cy="594360"/>
           </a:xfrm>
           <a:prstGeom prst="rect">
             <a:avLst/>
@@ -12083,21 +11573,21 @@
           <a:bodyPr wrap="square" lIns="0" tIns="0" rIns="0" bIns="0" rtlCol="0" anchor="ctr"/>
           <a:lstStyle/>
           <a:p>
-            <a:pPr algn="ctr" indent="0" marL="0">
+            <a:pPr indent="0" marL="0">
               <a:buNone/>
             </a:pPr>
             <a:r>
-              <a:rPr lang="en-US" sz="1100" b="1" dirty="0">
-                <a:solidFill>
-                  <a:srgbClr val="F5F7FA"/>
-                </a:solidFill>
-                <a:latin typeface="Arial" pitchFamily="34" charset="0"/>
-                <a:ea typeface="Arial" pitchFamily="34" charset="-122"/>
-                <a:cs typeface="Arial" pitchFamily="34" charset="-120"/>
-              </a:rPr>
-              <a:t>Q1  Success</a:t>
-            </a:r>
-            <a:endParaRPr lang="en-US" sz="1100" dirty="0"/>
+              <a:rPr lang="en-US" sz="1350" b="1" dirty="0">
+                <a:solidFill>
+                  <a:srgbClr val="1F2933"/>
+                </a:solidFill>
+                <a:latin typeface="Arial" pitchFamily="34" charset="0"/>
+                <a:ea typeface="Arial" pitchFamily="34" charset="-122"/>
+                <a:cs typeface="Arial" pitchFamily="34" charset="-120"/>
+              </a:rPr>
+              <a:t>Guarded reuse and temporal fusion are the safest for preserving success.</a:t>
+            </a:r>
+            <a:endParaRPr lang="en-US" sz="1350" dirty="0"/>
           </a:p>
         </p:txBody>
       </p:sp>
@@ -12109,8 +11599,8 @@
         </p:nvSpPr>
         <p:spPr>
           <a:xfrm>
-            <a:off x="5806440" y="914400"/>
-            <a:ext cx="2880360" cy="594360"/>
+            <a:off x="4480560" y="1691640"/>
+            <a:ext cx="4206240" cy="274320"/>
           </a:xfrm>
           <a:prstGeom prst="rect">
             <a:avLst/>
@@ -12119,45 +11609,6 @@
           <a:ln/>
         </p:spPr>
         <p:txBody>
-          <a:bodyPr wrap="square" lIns="0" tIns="0" rIns="0" bIns="0" rtlCol="0" anchor="ctr"/>
-          <a:lstStyle/>
-          <a:p>
-            <a:pPr indent="0" marL="0">
-              <a:buNone/>
-            </a:pPr>
-            <a:r>
-              <a:rPr lang="en-US" sz="1350" b="1" dirty="0">
-                <a:solidFill>
-                  <a:srgbClr val="1F2933"/>
-                </a:solidFill>
-                <a:latin typeface="Arial" pitchFamily="34" charset="0"/>
-                <a:ea typeface="Arial" pitchFamily="34" charset="-122"/>
-                <a:cs typeface="Arial" pitchFamily="34" charset="-120"/>
-              </a:rPr>
-              <a:t>Guarded reuse and temporal fusion are the safest for preserving success.</a:t>
-            </a:r>
-            <a:endParaRPr lang="en-US" sz="1350" dirty="0"/>
-          </a:p>
-        </p:txBody>
-      </p:sp>
-      <p:sp>
-        <p:nvSpPr>
-          <p:cNvPr id="20" name="Text 17"/>
-          <p:cNvSpPr txBox="1"/>
-          <p:nvPr/>
-        </p:nvSpPr>
-        <p:spPr>
-          <a:xfrm>
-            <a:off x="4480560" y="1691640"/>
-            <a:ext cx="4206240" cy="274320"/>
-          </a:xfrm>
-          <a:prstGeom prst="rect">
-            <a:avLst/>
-          </a:prstGeom>
-          <a:noFill/>
-          <a:ln/>
-        </p:spPr>
-        <p:txBody>
           <a:bodyPr wrap="square" lIns="0" tIns="0" rIns="0" bIns="0" rtlCol="0" anchor="t"/>
           <a:lstStyle/>
           <a:p>
@@ -12181,7 +11632,7 @@
       </p:sp>
       <p:sp>
         <p:nvSpPr>
-          <p:cNvPr id="21" name="Shape 18"/>
+          <p:cNvPr id="20" name="Shape 17"/>
           <p:cNvSpPr/>
           <p:nvPr/>
         </p:nvSpPr>
@@ -12208,7 +11659,7 @@
       </p:sp>
       <p:sp>
         <p:nvSpPr>
-          <p:cNvPr id="22" name="Text 19"/>
+          <p:cNvPr id="21" name="Text 18"/>
           <p:cNvSpPr txBox="1"/>
           <p:nvPr/>
         </p:nvSpPr>
@@ -12247,7 +11698,7 @@
       </p:sp>
       <p:sp>
         <p:nvSpPr>
-          <p:cNvPr id="23" name="Shape 20"/>
+          <p:cNvPr id="22" name="Shape 19"/>
           <p:cNvSpPr/>
           <p:nvPr/>
         </p:nvSpPr>
@@ -12274,14 +11725,53 @@
       </p:sp>
       <p:sp>
         <p:nvSpPr>
+          <p:cNvPr id="23" name="Text 20"/>
+          <p:cNvSpPr txBox="1"/>
+          <p:nvPr/>
+        </p:nvSpPr>
+        <p:spPr>
+          <a:xfrm>
+            <a:off x="4480560" y="2423160"/>
+            <a:ext cx="4206240" cy="384048"/>
+          </a:xfrm>
+          <a:prstGeom prst="rect">
+            <a:avLst/>
+          </a:prstGeom>
+          <a:noFill/>
+          <a:ln/>
+        </p:spPr>
+        <p:txBody>
+          <a:bodyPr wrap="square" lIns="0" tIns="0" rIns="0" bIns="0" rtlCol="0" anchor="ctr"/>
+          <a:lstStyle/>
+          <a:p>
+            <a:pPr algn="ctr" indent="0" marL="0">
+              <a:buNone/>
+            </a:pPr>
+            <a:r>
+              <a:rPr lang="en-US" sz="1100" b="1" dirty="0">
+                <a:solidFill>
+                  <a:srgbClr val="2E8B57"/>
+                </a:solidFill>
+                <a:latin typeface="Arial" pitchFamily="34" charset="0"/>
+                <a:ea typeface="Arial" pitchFamily="34" charset="-122"/>
+                <a:cs typeface="Arial" pitchFamily="34" charset="-120"/>
+              </a:rPr>
+              <a:t>Depth pruning, WidowX: CogACT +9.5</a:t>
+            </a:r>
+            <a:endParaRPr lang="en-US" sz="1100" dirty="0"/>
+          </a:p>
+        </p:txBody>
+      </p:sp>
+      <p:sp>
+        <p:nvSpPr>
           <p:cNvPr id="24" name="Text 21"/>
           <p:cNvSpPr txBox="1"/>
           <p:nvPr/>
         </p:nvSpPr>
         <p:spPr>
           <a:xfrm>
-            <a:off x="4480560" y="2423160"/>
-            <a:ext cx="4206240" cy="384048"/>
+            <a:off x="4480560" y="2926080"/>
+            <a:ext cx="4206240" cy="274320"/>
           </a:xfrm>
           <a:prstGeom prst="rect">
             <a:avLst/>
@@ -12290,45 +11780,6 @@
           <a:ln/>
         </p:spPr>
         <p:txBody>
-          <a:bodyPr wrap="square" lIns="0" tIns="0" rIns="0" bIns="0" rtlCol="0" anchor="ctr"/>
-          <a:lstStyle/>
-          <a:p>
-            <a:pPr algn="ctr" indent="0" marL="0">
-              <a:buNone/>
-            </a:pPr>
-            <a:r>
-              <a:rPr lang="en-US" sz="1100" b="1" dirty="0">
-                <a:solidFill>
-                  <a:srgbClr val="2E8B57"/>
-                </a:solidFill>
-                <a:latin typeface="Arial" pitchFamily="34" charset="0"/>
-                <a:ea typeface="Arial" pitchFamily="34" charset="-122"/>
-                <a:cs typeface="Arial" pitchFamily="34" charset="-120"/>
-              </a:rPr>
-              <a:t>Depth pruning, WidowX: CogACT +9.5</a:t>
-            </a:r>
-            <a:endParaRPr lang="en-US" sz="1100" dirty="0"/>
-          </a:p>
-        </p:txBody>
-      </p:sp>
-      <p:sp>
-        <p:nvSpPr>
-          <p:cNvPr id="25" name="Text 22"/>
-          <p:cNvSpPr txBox="1"/>
-          <p:nvPr/>
-        </p:nvSpPr>
-        <p:spPr>
-          <a:xfrm>
-            <a:off x="4480560" y="2926080"/>
-            <a:ext cx="4206240" cy="274320"/>
-          </a:xfrm>
-          <a:prstGeom prst="rect">
-            <a:avLst/>
-          </a:prstGeom>
-          <a:noFill/>
-          <a:ln/>
-        </p:spPr>
-        <p:txBody>
           <a:bodyPr wrap="square" lIns="0" tIns="0" rIns="0" bIns="0" rtlCol="0" anchor="t"/>
           <a:lstStyle/>
           <a:p>
@@ -12352,7 +11803,7 @@
       </p:sp>
       <p:sp>
         <p:nvSpPr>
-          <p:cNvPr id="26" name="Shape 23"/>
+          <p:cNvPr id="25" name="Shape 22"/>
           <p:cNvSpPr/>
           <p:nvPr/>
         </p:nvSpPr>
@@ -12379,7 +11830,7 @@
       </p:sp>
       <p:sp>
         <p:nvSpPr>
-          <p:cNvPr id="27" name="Text 24"/>
+          <p:cNvPr id="26" name="Text 23"/>
           <p:cNvSpPr txBox="1"/>
           <p:nvPr/>
         </p:nvSpPr>
@@ -12418,7 +11869,7 @@
       </p:sp>
       <p:sp>
         <p:nvSpPr>
-          <p:cNvPr id="28" name="Shape 25"/>
+          <p:cNvPr id="27" name="Shape 24"/>
           <p:cNvSpPr/>
           <p:nvPr/>
         </p:nvSpPr>
@@ -12445,7 +11896,7 @@
       </p:sp>
       <p:sp>
         <p:nvSpPr>
-          <p:cNvPr id="29" name="Text 26"/>
+          <p:cNvPr id="28" name="Text 25"/>
           <p:cNvSpPr txBox="1"/>
           <p:nvPr/>
         </p:nvSpPr>
@@ -12484,7 +11935,7 @@
       </p:sp>
       <p:sp>
         <p:nvSpPr>
-          <p:cNvPr id="30" name="Text 27"/>
+          <p:cNvPr id="29" name="Text 26"/>
           <p:cNvSpPr txBox="1"/>
           <p:nvPr/>
         </p:nvSpPr>
@@ -12561,8 +12012,8 @@
         </p:nvSpPr>
         <p:spPr>
           <a:xfrm>
-            <a:off x="7680960" y="73152"/>
-            <a:ext cx="1280160" cy="228600"/>
+            <a:off x="457200" y="292608"/>
+            <a:ext cx="8229600" cy="640080"/>
           </a:xfrm>
           <a:prstGeom prst="rect">
             <a:avLst/>
@@ -12574,45 +12025,6 @@
           <a:bodyPr wrap="square" lIns="0" tIns="0" rIns="0" bIns="0" rtlCol="0" anchor="ctr"/>
           <a:lstStyle/>
           <a:p>
-            <a:pPr algn="r" indent="0" marL="0">
-              <a:buNone/>
-            </a:pPr>
-            <a:r>
-              <a:rPr lang="en-US" sz="900" dirty="0">
-                <a:solidFill>
-                  <a:srgbClr val="5F6B7A"/>
-                </a:solidFill>
-                <a:latin typeface="Arial" pitchFamily="34" charset="0"/>
-                <a:ea typeface="Arial" pitchFamily="34" charset="-122"/>
-                <a:cs typeface="Arial" pitchFamily="34" charset="-120"/>
-              </a:rPr>
-              <a:t>9  ·  12s</a:t>
-            </a:r>
-            <a:endParaRPr lang="en-US" sz="900" dirty="0"/>
-          </a:p>
-        </p:txBody>
-      </p:sp>
-      <p:sp>
-        <p:nvSpPr>
-          <p:cNvPr id="3" name="Text 1"/>
-          <p:cNvSpPr txBox="1"/>
-          <p:nvPr/>
-        </p:nvSpPr>
-        <p:spPr>
-          <a:xfrm>
-            <a:off x="457200" y="292608"/>
-            <a:ext cx="8229600" cy="640080"/>
-          </a:xfrm>
-          <a:prstGeom prst="rect">
-            <a:avLst/>
-          </a:prstGeom>
-          <a:noFill/>
-          <a:ln/>
-        </p:spPr>
-        <p:txBody>
-          <a:bodyPr wrap="square" lIns="0" tIns="0" rIns="0" bIns="0" rtlCol="0" anchor="ctr"/>
-          <a:lstStyle/>
-          <a:p>
             <a:pPr indent="0" marL="0">
               <a:buNone/>
             </a:pPr>
@@ -12633,7 +12045,7 @@
       </p:sp>
       <p:pic>
         <p:nvPicPr>
-          <p:cNvPr id="4" name="Image 0" descr="/tmp/claude-0/-home-user-BiVLA/4327cefa-ba5d-5e2e-9d87-c73dd3a8ccbb/scratchpad/video_ppt/assets/fig3a_cogact.png">    </p:cNvPr>
+          <p:cNvPr id="3" name="Image 0" descr="/tmp/claude-0/-home-user-BiVLA/4327cefa-ba5d-5e2e-9d87-c73dd3a8ccbb/scratchpad/video_ppt/assets/fig3a_cogact.png">    </p:cNvPr>
           <p:cNvPicPr>
             <a:picLocks noChangeAspect="1"/>
           </p:cNvPicPr>
@@ -12657,7 +12069,7 @@
       </p:pic>
       <p:sp>
         <p:nvSpPr>
-          <p:cNvPr id="5" name="Shape 2"/>
+          <p:cNvPr id="4" name="Shape 1"/>
           <p:cNvSpPr/>
           <p:nvPr/>
         </p:nvSpPr>
@@ -12684,7 +12096,7 @@
       </p:sp>
       <p:sp>
         <p:nvSpPr>
-          <p:cNvPr id="6" name="Text 3"/>
+          <p:cNvPr id="5" name="Text 2"/>
           <p:cNvSpPr txBox="1"/>
           <p:nvPr/>
         </p:nvSpPr>
@@ -12723,7 +12135,7 @@
       </p:sp>
       <p:sp>
         <p:nvSpPr>
-          <p:cNvPr id="7" name="Shape 4"/>
+          <p:cNvPr id="6" name="Shape 3"/>
           <p:cNvSpPr/>
           <p:nvPr/>
         </p:nvSpPr>
@@ -12750,7 +12162,7 @@
       </p:sp>
       <p:sp>
         <p:nvSpPr>
-          <p:cNvPr id="8" name="Text 5"/>
+          <p:cNvPr id="7" name="Text 4"/>
           <p:cNvSpPr txBox="1"/>
           <p:nvPr/>
         </p:nvSpPr>
@@ -12789,7 +12201,7 @@
       </p:sp>
       <p:sp>
         <p:nvSpPr>
-          <p:cNvPr id="9" name="Shape 6"/>
+          <p:cNvPr id="8" name="Shape 5"/>
           <p:cNvSpPr/>
           <p:nvPr/>
         </p:nvSpPr>
@@ -12816,7 +12228,7 @@
       </p:sp>
       <p:sp>
         <p:nvSpPr>
-          <p:cNvPr id="10" name="Text 7"/>
+          <p:cNvPr id="9" name="Text 6"/>
           <p:cNvSpPr txBox="1"/>
           <p:nvPr/>
         </p:nvSpPr>
@@ -12855,7 +12267,7 @@
       </p:sp>
       <p:sp>
         <p:nvSpPr>
-          <p:cNvPr id="11" name="Text 8"/>
+          <p:cNvPr id="10" name="Text 7"/>
           <p:cNvSpPr txBox="1"/>
           <p:nvPr/>
         </p:nvSpPr>

</xml_diff>

<commit_message>
Video deck: fixes from the final-paper audit (wording, Fig. 4 panel version, action-repeat k label, crop artifacts)
Co-Authored-By: Claude Fable 5.1 <noreply@anthropic.com>
Claude-Session: https://claude.ai/code/session_011USoCwMtkSq1wKhwTPjNT9
</commit_message>
<xml_diff>
--- a/experiments/paper/video/ICRA27_video_v2.pptx
+++ b/experiments/paper/video/ICRA27_video_v2.pptx
@@ -517,7 +517,7 @@
               <a:rPr lang="en-US" dirty="0"/>
               <a:t>SLIDE 1  |  15 s  |  36 words (2.4 w/s)
 NARRATION:
-Vision-language-action models are capable but slow. Every control step runs a vision encoder and a language backbone. Training-free tricks promise cheaper inference, but each is reported on one model and one benchmark. Do the gains transfer?
+Vision-language-action models are capable but slow. Every policy call runs a vision encoder and a language backbone. Training-free tricks promise cheaper inference, but gains are typically reported for one backbone and one benchmark. Do they transfer?
 VISUAL / PRODUCTION NOTE:
 Static. Optional: play a short original-policy rollout behind the loop diagram. Pipeline row cropped from Fig. 2(a).</a:t>
             </a:r>
@@ -703,7 +703,7 @@
 NARRATION:
 Second, speed. Action repeat gives the largest speedup. SpatialVLA on WidowX drops from about 424 to 235 milliseconds per step. Depth pruning gives smaller decoder-level savings, and guarded reuse the safest trade-off.
 VISUAL / PRODUCTION NOTE:
-Fig. 4. If the Speechma clip runs longer than 13 s, extend the slide rather than speeding the voice.</a:t>
+Paper Fig. 4 with a native colour legend. If the Speechma clip runs longer than 13 s, extend the slide rather than speeding the voice.</a:t>
             </a:r>
             <a:endParaRPr lang="en-US" dirty="0"/>
           </a:p>
@@ -795,7 +795,7 @@
 NARRATION:
 Action repeat runs open loop: on WidowX, CogACT loses 38 points and UniVLA 75. Guarded reuse skips calls only when the gates agree. On SmolVLA in LIBERO Long, success stays at 42.0 with lower latency.
 VISUAL / PRODUCTION NOTE:
-Three-panel recording of one CogACT WidowX episode. Before rendering, fill the three "policy calls used" counters from that episode: original = number of steps, k = 4 = about steps / 4, guarded = steps minus skipped calls.</a:t>
+Three-panel recording of one CogACT WidowX episode; use k = 2 for the action-repeat panel so the clip matches the quoted deltas (k = 4 is worse, about -46 and -85 points, Fig. 5). Before rendering, fill the three "policy calls used" counters from that episode: original = number of steps, repeat = about steps / k, guarded = steps minus skipped calls, or delete the counter lines.</a:t>
             </a:r>
             <a:endParaRPr lang="en-US" dirty="0"/>
           </a:p>
@@ -887,7 +887,7 @@
 NARRATION:
 Third, consistency. Across backbone and environment pairs the same trick improves one model, leaves another unchanged, and hurts a third. No trick is plug-and-play.
 VISUAL / PRODUCTION NOTE:
-Consistency chart (Project Page figure, counts from the per-setting records with LIBERO episodes pooled). Do not read the counts aloud.</a:t>
+Consistency chart (supplementary figure, counts from the per-setting records with LIBERO episodes pooled). Do not read the counts aloud.</a:t>
             </a:r>
             <a:endParaRPr lang="en-US" dirty="0"/>
           </a:p>
@@ -1251,9 +1251,9 @@
           <a:p>
             <a:r>
               <a:rPr lang="en-US" dirty="0"/>
-              <a:t>SLIDE 4  |  11 s  |  26 words (2.4 w/s)
+              <a:t>SLIDE 4  |  12 s  |  32 words (2.7 w/s)
 NARRATION:
-Trick three, depth pruning. Decoder blocks that barely change their hidden states are removed, one, two, or four of them. The selection is fixed before evaluation.
+Trick three, depth pruning. Decoder blocks that barely change their hidden states are removed, one, two, or four of them, keeping the early and final blocks. The selection is fixed before evaluation.
 VISUAL / PRODUCTION NOTE:
 Left: Fig. 2(a) panel. Right: side-by-side rollout clip.</a:t>
             </a:r>
@@ -2237,7 +2237,7 @@
                 <a:ea typeface="Arial" pitchFamily="34" charset="-122"/>
                 <a:cs typeface="Arial" pitchFamily="34" charset="-120"/>
               </a:rPr>
-              <a:t>The control loop of a frozen VLA policy (Fig. 2 of the paper). Coloured boxes are where the five tricks enter; the visual encoder and the action decoder run at every step.</a:t>
+              <a:t>The control loop of a frozen VLA policy (Fig. 2 of the paper). Green, orange, purple, and blue boxes mark where the five tricks enter; Redundancy Control is action repeat.</a:t>
             </a:r>
             <a:endParaRPr lang="en-US" sz="1100" dirty="0"/>
           </a:p>
@@ -2304,7 +2304,7 @@
                 <a:ea typeface="Arial" pitchFamily="34" charset="-122"/>
                 <a:cs typeface="Arial" pitchFamily="34" charset="-120"/>
               </a:rPr>
-              <a:t>Hundreds of milliseconds per step, which limits how often the policy can observe, decide, and correct.</a:t>
+              <a:t>Tens to hundreds of milliseconds per step (60 to 450 ms in our runs), which limits how often the policy can observe, decide, and correct.</a:t>
             </a:r>
             <a:endParaRPr lang="en-US" sz="1400" dirty="0"/>
           </a:p>
@@ -2357,7 +2357,7 @@
                 <a:ea typeface="Arial" pitchFamily="34" charset="-122"/>
                 <a:cs typeface="Arial" pitchFamily="34" charset="-120"/>
               </a:rPr>
-              <a:t>Training-free tricks are reported one at a time. </a:t>
+              <a:t>Gains are reported in isolation. </a:t>
             </a:r>
             <a:pPr indent="0" marL="0">
               <a:buNone/>
@@ -2371,7 +2371,7 @@
                 <a:ea typeface="Arial" pitchFamily="34" charset="-122"/>
                 <a:cs typeface="Arial" pitchFamily="34" charset="-120"/>
               </a:rPr>
-              <a:t>Foveation, action repeat, depth pruning, guarded reuse, temporal fusion: each on one backbone, one benchmark, one implementation.</a:t>
+              <a:t>Training-free tricks are typically evaluated for a specific trick, backbone, benchmark, and implementation, so transfer across models is unknown.</a:t>
             </a:r>
             <a:endParaRPr lang="en-US" sz="1400" dirty="0"/>
           </a:p>
@@ -3280,7 +3280,7 @@
       </p:sp>
       <p:pic>
         <p:nvPicPr>
-          <p:cNvPr id="3" name="Image 0" descr="/tmp/claude-0/-home-user-BiVLA/4327cefa-ba5d-5e2e-9d87-c73dd3a8ccbb/scratchpad/video_ppt/assets/fig4_tradeoff_row.png">    </p:cNvPr>
+          <p:cNvPr id="3" name="Image 0" descr="/tmp/claude-0/-home-user-BiVLA/4327cefa-ba5d-5e2e-9d87-c73dd3a8ccbb/scratchpad/video_ppt/assets/fig4_paper_nolegend.png">    </p:cNvPr>
           <p:cNvPicPr>
             <a:picLocks noChangeAspect="1"/>
           </p:cNvPicPr>
@@ -3294,8 +3294,8 @@
         </p:blipFill>
         <p:spPr>
           <a:xfrm>
-            <a:off x="822960" y="868680"/>
-            <a:ext cx="7498080" cy="2551176"/>
+            <a:off x="365760" y="868680"/>
+            <a:ext cx="4297680" cy="3520440"/>
           </a:xfrm>
           <a:prstGeom prst="rect">
             <a:avLst/>
@@ -3304,14 +3304,39 @@
       </p:pic>
       <p:sp>
         <p:nvSpPr>
-          <p:cNvPr id="4" name="Text 1"/>
+          <p:cNvPr id="4" name="Shape 1"/>
+          <p:cNvSpPr/>
+          <p:nvPr/>
+        </p:nvSpPr>
+        <p:spPr>
+          <a:xfrm>
+            <a:off x="457200" y="4480560"/>
+            <a:ext cx="146304" cy="146304"/>
+          </a:xfrm>
+          <a:prstGeom prst="rect">
+            <a:avLst/>
+          </a:prstGeom>
+          <a:solidFill>
+            <a:srgbClr val="222222"/>
+          </a:solidFill>
+          <a:ln w="12700">
+            <a:solidFill>
+              <a:srgbClr val="222222"/>
+            </a:solidFill>
+            <a:prstDash val="solid"/>
+          </a:ln>
+        </p:spPr>
+      </p:sp>
+      <p:sp>
+        <p:nvSpPr>
+          <p:cNvPr id="5" name="Text 2"/>
           <p:cNvSpPr txBox="1"/>
           <p:nvPr/>
         </p:nvSpPr>
         <p:spPr>
           <a:xfrm>
-            <a:off x="457200" y="3456432"/>
-            <a:ext cx="8229600" cy="320040"/>
+            <a:off x="658368" y="4434840"/>
+            <a:ext cx="1188720" cy="237744"/>
           </a:xfrm>
           <a:prstGeom prst="rect">
             <a:avLst/>
@@ -3320,6 +3345,365 @@
           <a:ln/>
         </p:spPr>
         <p:txBody>
+          <a:bodyPr wrap="square" lIns="0" tIns="0" rIns="0" bIns="0" rtlCol="0" anchor="ctr"/>
+          <a:lstStyle/>
+          <a:p>
+            <a:pPr indent="0" marL="0">
+              <a:buNone/>
+            </a:pPr>
+            <a:r>
+              <a:rPr lang="en-US" sz="950" dirty="0">
+                <a:solidFill>
+                  <a:srgbClr val="1F2933"/>
+                </a:solidFill>
+                <a:latin typeface="Arial" pitchFamily="34" charset="0"/>
+                <a:ea typeface="Arial" pitchFamily="34" charset="-122"/>
+                <a:cs typeface="Arial" pitchFamily="34" charset="-120"/>
+              </a:rPr>
+              <a:t>Original</a:t>
+            </a:r>
+            <a:endParaRPr lang="en-US" sz="950" dirty="0"/>
+          </a:p>
+        </p:txBody>
+      </p:sp>
+      <p:sp>
+        <p:nvSpPr>
+          <p:cNvPr id="6" name="Shape 3"/>
+          <p:cNvSpPr/>
+          <p:nvPr/>
+        </p:nvSpPr>
+        <p:spPr>
+          <a:xfrm>
+            <a:off x="1874520" y="4480560"/>
+            <a:ext cx="146304" cy="146304"/>
+          </a:xfrm>
+          <a:prstGeom prst="rect">
+            <a:avLst/>
+          </a:prstGeom>
+          <a:solidFill>
+            <a:srgbClr val="0072B2"/>
+          </a:solidFill>
+          <a:ln w="12700">
+            <a:solidFill>
+              <a:srgbClr val="0072B2"/>
+            </a:solidFill>
+            <a:prstDash val="solid"/>
+          </a:ln>
+        </p:spPr>
+      </p:sp>
+      <p:sp>
+        <p:nvSpPr>
+          <p:cNvPr id="7" name="Text 4"/>
+          <p:cNvSpPr txBox="1"/>
+          <p:nvPr/>
+        </p:nvSpPr>
+        <p:spPr>
+          <a:xfrm>
+            <a:off x="2075688" y="4434840"/>
+            <a:ext cx="1188720" cy="237744"/>
+          </a:xfrm>
+          <a:prstGeom prst="rect">
+            <a:avLst/>
+          </a:prstGeom>
+          <a:noFill/>
+          <a:ln/>
+        </p:spPr>
+        <p:txBody>
+          <a:bodyPr wrap="square" lIns="0" tIns="0" rIns="0" bIns="0" rtlCol="0" anchor="ctr"/>
+          <a:lstStyle/>
+          <a:p>
+            <a:pPr indent="0" marL="0">
+              <a:buNone/>
+            </a:pPr>
+            <a:r>
+              <a:rPr lang="en-US" sz="950" dirty="0">
+                <a:solidFill>
+                  <a:srgbClr val="1F2933"/>
+                </a:solidFill>
+                <a:latin typeface="Arial" pitchFamily="34" charset="0"/>
+                <a:ea typeface="Arial" pitchFamily="34" charset="-122"/>
+                <a:cs typeface="Arial" pitchFamily="34" charset="-120"/>
+              </a:rPr>
+              <a:t>Foveation</a:t>
+            </a:r>
+            <a:endParaRPr lang="en-US" sz="950" dirty="0"/>
+          </a:p>
+        </p:txBody>
+      </p:sp>
+      <p:sp>
+        <p:nvSpPr>
+          <p:cNvPr id="8" name="Shape 5"/>
+          <p:cNvSpPr/>
+          <p:nvPr/>
+        </p:nvSpPr>
+        <p:spPr>
+          <a:xfrm>
+            <a:off x="3291840" y="4480560"/>
+            <a:ext cx="146304" cy="146304"/>
+          </a:xfrm>
+          <a:prstGeom prst="rect">
+            <a:avLst/>
+          </a:prstGeom>
+          <a:solidFill>
+            <a:srgbClr val="D55E00"/>
+          </a:solidFill>
+          <a:ln w="12700">
+            <a:solidFill>
+              <a:srgbClr val="D55E00"/>
+            </a:solidFill>
+            <a:prstDash val="solid"/>
+          </a:ln>
+        </p:spPr>
+      </p:sp>
+      <p:sp>
+        <p:nvSpPr>
+          <p:cNvPr id="9" name="Text 6"/>
+          <p:cNvSpPr txBox="1"/>
+          <p:nvPr/>
+        </p:nvSpPr>
+        <p:spPr>
+          <a:xfrm>
+            <a:off x="3493008" y="4434840"/>
+            <a:ext cx="1188720" cy="237744"/>
+          </a:xfrm>
+          <a:prstGeom prst="rect">
+            <a:avLst/>
+          </a:prstGeom>
+          <a:noFill/>
+          <a:ln/>
+        </p:spPr>
+        <p:txBody>
+          <a:bodyPr wrap="square" lIns="0" tIns="0" rIns="0" bIns="0" rtlCol="0" anchor="ctr"/>
+          <a:lstStyle/>
+          <a:p>
+            <a:pPr indent="0" marL="0">
+              <a:buNone/>
+            </a:pPr>
+            <a:r>
+              <a:rPr lang="en-US" sz="950" dirty="0">
+                <a:solidFill>
+                  <a:srgbClr val="1F2933"/>
+                </a:solidFill>
+                <a:latin typeface="Arial" pitchFamily="34" charset="0"/>
+                <a:ea typeface="Arial" pitchFamily="34" charset="-122"/>
+                <a:cs typeface="Arial" pitchFamily="34" charset="-120"/>
+              </a:rPr>
+              <a:t>Action repeat</a:t>
+            </a:r>
+            <a:endParaRPr lang="en-US" sz="950" dirty="0"/>
+          </a:p>
+        </p:txBody>
+      </p:sp>
+      <p:sp>
+        <p:nvSpPr>
+          <p:cNvPr id="10" name="Shape 7"/>
+          <p:cNvSpPr/>
+          <p:nvPr/>
+        </p:nvSpPr>
+        <p:spPr>
+          <a:xfrm>
+            <a:off x="457200" y="4709160"/>
+            <a:ext cx="146304" cy="146304"/>
+          </a:xfrm>
+          <a:prstGeom prst="rect">
+            <a:avLst/>
+          </a:prstGeom>
+          <a:solidFill>
+            <a:srgbClr val="009E73"/>
+          </a:solidFill>
+          <a:ln w="12700">
+            <a:solidFill>
+              <a:srgbClr val="009E73"/>
+            </a:solidFill>
+            <a:prstDash val="solid"/>
+          </a:ln>
+        </p:spPr>
+      </p:sp>
+      <p:sp>
+        <p:nvSpPr>
+          <p:cNvPr id="11" name="Text 8"/>
+          <p:cNvSpPr txBox="1"/>
+          <p:nvPr/>
+        </p:nvSpPr>
+        <p:spPr>
+          <a:xfrm>
+            <a:off x="658368" y="4663440"/>
+            <a:ext cx="1188720" cy="237744"/>
+          </a:xfrm>
+          <a:prstGeom prst="rect">
+            <a:avLst/>
+          </a:prstGeom>
+          <a:noFill/>
+          <a:ln/>
+        </p:spPr>
+        <p:txBody>
+          <a:bodyPr wrap="square" lIns="0" tIns="0" rIns="0" bIns="0" rtlCol="0" anchor="ctr"/>
+          <a:lstStyle/>
+          <a:p>
+            <a:pPr indent="0" marL="0">
+              <a:buNone/>
+            </a:pPr>
+            <a:r>
+              <a:rPr lang="en-US" sz="950" dirty="0">
+                <a:solidFill>
+                  <a:srgbClr val="1F2933"/>
+                </a:solidFill>
+                <a:latin typeface="Arial" pitchFamily="34" charset="0"/>
+                <a:ea typeface="Arial" pitchFamily="34" charset="-122"/>
+                <a:cs typeface="Arial" pitchFamily="34" charset="-120"/>
+              </a:rPr>
+              <a:t>Depth pruning</a:t>
+            </a:r>
+            <a:endParaRPr lang="en-US" sz="950" dirty="0"/>
+          </a:p>
+        </p:txBody>
+      </p:sp>
+      <p:sp>
+        <p:nvSpPr>
+          <p:cNvPr id="12" name="Shape 9"/>
+          <p:cNvSpPr/>
+          <p:nvPr/>
+        </p:nvSpPr>
+        <p:spPr>
+          <a:xfrm>
+            <a:off x="1874520" y="4709160"/>
+            <a:ext cx="146304" cy="146304"/>
+          </a:xfrm>
+          <a:prstGeom prst="rect">
+            <a:avLst/>
+          </a:prstGeom>
+          <a:solidFill>
+            <a:srgbClr val="CC79A7"/>
+          </a:solidFill>
+          <a:ln w="12700">
+            <a:solidFill>
+              <a:srgbClr val="CC79A7"/>
+            </a:solidFill>
+            <a:prstDash val="solid"/>
+          </a:ln>
+        </p:spPr>
+      </p:sp>
+      <p:sp>
+        <p:nvSpPr>
+          <p:cNvPr id="13" name="Text 10"/>
+          <p:cNvSpPr txBox="1"/>
+          <p:nvPr/>
+        </p:nvSpPr>
+        <p:spPr>
+          <a:xfrm>
+            <a:off x="2075688" y="4663440"/>
+            <a:ext cx="1188720" cy="237744"/>
+          </a:xfrm>
+          <a:prstGeom prst="rect">
+            <a:avLst/>
+          </a:prstGeom>
+          <a:noFill/>
+          <a:ln/>
+        </p:spPr>
+        <p:txBody>
+          <a:bodyPr wrap="square" lIns="0" tIns="0" rIns="0" bIns="0" rtlCol="0" anchor="ctr"/>
+          <a:lstStyle/>
+          <a:p>
+            <a:pPr indent="0" marL="0">
+              <a:buNone/>
+            </a:pPr>
+            <a:r>
+              <a:rPr lang="en-US" sz="950" dirty="0">
+                <a:solidFill>
+                  <a:srgbClr val="1F2933"/>
+                </a:solidFill>
+                <a:latin typeface="Arial" pitchFamily="34" charset="0"/>
+                <a:ea typeface="Arial" pitchFamily="34" charset="-122"/>
+                <a:cs typeface="Arial" pitchFamily="34" charset="-120"/>
+              </a:rPr>
+              <a:t>Guarded reuse</a:t>
+            </a:r>
+            <a:endParaRPr lang="en-US" sz="950" dirty="0"/>
+          </a:p>
+        </p:txBody>
+      </p:sp>
+      <p:sp>
+        <p:nvSpPr>
+          <p:cNvPr id="14" name="Shape 11"/>
+          <p:cNvSpPr/>
+          <p:nvPr/>
+        </p:nvSpPr>
+        <p:spPr>
+          <a:xfrm>
+            <a:off x="3291840" y="4709160"/>
+            <a:ext cx="146304" cy="146304"/>
+          </a:xfrm>
+          <a:prstGeom prst="rect">
+            <a:avLst/>
+          </a:prstGeom>
+          <a:solidFill>
+            <a:srgbClr val="8C650F"/>
+          </a:solidFill>
+          <a:ln w="12700">
+            <a:solidFill>
+              <a:srgbClr val="8C650F"/>
+            </a:solidFill>
+            <a:prstDash val="solid"/>
+          </a:ln>
+        </p:spPr>
+      </p:sp>
+      <p:sp>
+        <p:nvSpPr>
+          <p:cNvPr id="15" name="Text 12"/>
+          <p:cNvSpPr txBox="1"/>
+          <p:nvPr/>
+        </p:nvSpPr>
+        <p:spPr>
+          <a:xfrm>
+            <a:off x="3493008" y="4663440"/>
+            <a:ext cx="1188720" cy="237744"/>
+          </a:xfrm>
+          <a:prstGeom prst="rect">
+            <a:avLst/>
+          </a:prstGeom>
+          <a:noFill/>
+          <a:ln/>
+        </p:spPr>
+        <p:txBody>
+          <a:bodyPr wrap="square" lIns="0" tIns="0" rIns="0" bIns="0" rtlCol="0" anchor="ctr"/>
+          <a:lstStyle/>
+          <a:p>
+            <a:pPr indent="0" marL="0">
+              <a:buNone/>
+            </a:pPr>
+            <a:r>
+              <a:rPr lang="en-US" sz="950" dirty="0">
+                <a:solidFill>
+                  <a:srgbClr val="1F2933"/>
+                </a:solidFill>
+                <a:latin typeface="Arial" pitchFamily="34" charset="0"/>
+                <a:ea typeface="Arial" pitchFamily="34" charset="-122"/>
+                <a:cs typeface="Arial" pitchFamily="34" charset="-120"/>
+              </a:rPr>
+              <a:t>Temporal fusion</a:t>
+            </a:r>
+            <a:endParaRPr lang="en-US" sz="950" dirty="0"/>
+          </a:p>
+        </p:txBody>
+      </p:sp>
+      <p:sp>
+        <p:nvSpPr>
+          <p:cNvPr id="16" name="Text 13"/>
+          <p:cNvSpPr txBox="1"/>
+          <p:nvPr/>
+        </p:nvSpPr>
+        <p:spPr>
+          <a:xfrm>
+            <a:off x="4937760" y="868680"/>
+            <a:ext cx="3749040" cy="640080"/>
+          </a:xfrm>
+          <a:prstGeom prst="rect">
+            <a:avLst/>
+          </a:prstGeom>
+          <a:noFill/>
+          <a:ln/>
+        </p:spPr>
+        <p:txBody>
           <a:bodyPr wrap="square" lIns="0" tIns="0" rIns="0" bIns="0" rtlCol="0" anchor="t"/>
           <a:lstStyle/>
           <a:p>
@@ -3335,7 +3719,7 @@
                 <a:ea typeface="Arial" pitchFamily="34" charset="-122"/>
                 <a:cs typeface="Arial" pitchFamily="34" charset="-120"/>
               </a:rPr>
-              <a:t>Six WidowX backbones, left to right: CogACT, CronusVLA, MiniVLA, OpenVLA, SpatialVLA, UniVLA.  Star = original, shaded = faster and no worse, colour = trick, symbol = setting.</a:t>
+              <a:t>Fig. 4, SimplerEnv WidowX. Star = original, shaded = faster and no worse. Colour = trick; circle, square, triangle = first, second, third setting of that trick.</a:t>
             </a:r>
             <a:endParaRPr lang="en-US" sz="1000" dirty="0"/>
           </a:p>
@@ -3343,13 +3727,13 @@
       </p:sp>
       <p:sp>
         <p:nvSpPr>
-          <p:cNvPr id="5" name="Shape 2"/>
+          <p:cNvPr id="17" name="Shape 14"/>
           <p:cNvSpPr/>
           <p:nvPr/>
         </p:nvSpPr>
         <p:spPr>
           <a:xfrm>
-            <a:off x="457200" y="3840480"/>
+            <a:off x="4937760" y="1600200"/>
             <a:ext cx="1234440" cy="365760"/>
           </a:xfrm>
           <a:prstGeom prst="roundRect">
@@ -3370,13 +3754,13 @@
       </p:sp>
       <p:sp>
         <p:nvSpPr>
-          <p:cNvPr id="6" name="Text 3"/>
+          <p:cNvPr id="18" name="Text 15"/>
           <p:cNvSpPr txBox="1"/>
           <p:nvPr/>
         </p:nvSpPr>
         <p:spPr>
           <a:xfrm>
-            <a:off x="457200" y="3840480"/>
+            <a:off x="4937760" y="1600200"/>
             <a:ext cx="1234440" cy="365760"/>
           </a:xfrm>
           <a:prstGeom prst="rect">
@@ -3409,14 +3793,14 @@
       </p:sp>
       <p:sp>
         <p:nvSpPr>
-          <p:cNvPr id="7" name="Text 4"/>
+          <p:cNvPr id="19" name="Text 16"/>
           <p:cNvSpPr txBox="1"/>
           <p:nvPr/>
         </p:nvSpPr>
         <p:spPr>
           <a:xfrm>
-            <a:off x="1783080" y="3794760"/>
-            <a:ext cx="3108960" cy="960120"/>
+            <a:off x="4937760" y="2057400"/>
+            <a:ext cx="3749040" cy="822960"/>
           </a:xfrm>
           <a:prstGeom prst="rect">
             <a:avLst/>
@@ -3425,14 +3809,14 @@
           <a:ln/>
         </p:spPr>
         <p:txBody>
-          <a:bodyPr wrap="square" lIns="0" tIns="0" rIns="0" bIns="0" rtlCol="0" anchor="ctr"/>
+          <a:bodyPr wrap="square" lIns="0" tIns="0" rIns="0" bIns="0" rtlCol="0" anchor="t"/>
           <a:lstStyle/>
           <a:p>
             <a:pPr indent="0" marL="0">
               <a:buNone/>
             </a:pPr>
             <a:r>
-              <a:rPr lang="en-US" sz="1150" b="1" dirty="0">
+              <a:rPr lang="en-US" sz="1200" b="1" dirty="0">
                 <a:solidFill>
                   <a:srgbClr val="1F2933"/>
                 </a:solidFill>
@@ -3442,7 +3826,7 @@
               </a:rPr>
               <a:t>Action repeat gives the largest speedup, depth pruning gives decoder-level savings, guarded reuse gives the safest trade-off.</a:t>
             </a:r>
-            <a:endParaRPr lang="en-US" sz="1150" dirty="0"/>
+            <a:endParaRPr lang="en-US" sz="1200" dirty="0"/>
           </a:p>
         </p:txBody>
       </p:sp>
@@ -3461,18 +3845,18 @@
           </p:nvPr>
         </p:nvGraphicFramePr>
         <p:xfrm>
-          <a:off x="5029200" y="3794760"/>
-          <a:ext cx="3657600" cy="914400"/>
+          <a:off x="4937760" y="3063240"/>
+          <a:ext cx="3749040" cy="914400"/>
         </p:xfrm>
         <a:graphic>
           <a:graphicData uri="http://schemas.openxmlformats.org/drawingml/2006/table">
             <a:tbl>
               <a:tblPr/>
               <a:tblGrid>
-                <a:gridCol w="2286000"/>
-                <a:gridCol w="1371600"/>
+                <a:gridCol w="2331720"/>
+                <a:gridCol w="1417320"/>
               </a:tblGrid>
-              <a:tr h="219456">
+              <a:tr h="274320">
                 <a:tc>
                   <a:txBody>
                     <a:bodyPr/>
@@ -3482,7 +3866,7 @@
                         <a:buNone/>
                       </a:pPr>
                       <a:r>
-                        <a:rPr lang="en-US" sz="950" b="1" dirty="0">
+                        <a:rPr lang="en-US" sz="1000" b="1" dirty="0">
                           <a:solidFill>
                             <a:srgbClr val="FFFFFF"/>
                           </a:solidFill>
@@ -3492,7 +3876,7 @@
                         </a:rPr>
                         <a:t>Latency, ms per step</a:t>
                       </a:r>
-                      <a:endParaRPr lang="en-US" sz="950" dirty="0">
+                      <a:endParaRPr lang="en-US" sz="1000" dirty="0">
                         <a:latin typeface="Arial" charset="0"/>
                         <a:ea typeface="Arial" charset="0"/>
                         <a:cs typeface="Arial" charset="0"/>
@@ -3550,7 +3934,7 @@
                         <a:buNone/>
                       </a:pPr>
                       <a:r>
-                        <a:rPr lang="en-US" sz="950" b="1" dirty="0">
+                        <a:rPr lang="en-US" sz="1000" b="1" dirty="0">
                           <a:solidFill>
                             <a:srgbClr val="FFFFFF"/>
                           </a:solidFill>
@@ -3560,7 +3944,7 @@
                         </a:rPr>
                         <a:t>Original → trick</a:t>
                       </a:r>
-                      <a:endParaRPr lang="en-US" sz="950" dirty="0">
+                      <a:endParaRPr lang="en-US" sz="1000" dirty="0">
                         <a:latin typeface="Arial" charset="0"/>
                         <a:ea typeface="Arial" charset="0"/>
                         <a:cs typeface="Arial" charset="0"/>
@@ -3610,7 +3994,7 @@
                   </a:tcPr>
                 </a:tc>
               </a:tr>
-              <a:tr h="219456">
+              <a:tr h="274320">
                 <a:tc>
                   <a:txBody>
                     <a:bodyPr/>
@@ -3620,7 +4004,7 @@
                         <a:buNone/>
                       </a:pPr>
                       <a:r>
-                        <a:rPr lang="en-US" sz="950" dirty="0">
+                        <a:rPr lang="en-US" sz="1000" dirty="0">
                           <a:solidFill>
                             <a:srgbClr val="1F2933"/>
                           </a:solidFill>
@@ -3630,7 +4014,7 @@
                         </a:rPr>
                         <a:t>Repeat · SpatialVLA WidowX</a:t>
                       </a:r>
-                      <a:endParaRPr lang="en-US" sz="950" dirty="0">
+                      <a:endParaRPr lang="en-US" sz="1000" dirty="0">
                         <a:latin typeface="Arial" charset="0"/>
                         <a:ea typeface="Arial" charset="0"/>
                         <a:cs typeface="Arial" charset="0"/>
@@ -3685,7 +4069,7 @@
                         <a:buNone/>
                       </a:pPr>
                       <a:r>
-                        <a:rPr lang="en-US" sz="950" b="1" dirty="0">
+                        <a:rPr lang="en-US" sz="1000" b="1" dirty="0">
                           <a:solidFill>
                             <a:srgbClr val="C8641E"/>
                           </a:solidFill>
@@ -3695,7 +4079,7 @@
                         </a:rPr>
                         <a:t>423.5 → 235.1</a:t>
                       </a:r>
-                      <a:endParaRPr lang="en-US" sz="950" dirty="0">
+                      <a:endParaRPr lang="en-US" sz="1000" dirty="0">
                         <a:latin typeface="Arial" charset="0"/>
                         <a:ea typeface="Arial" charset="0"/>
                         <a:cs typeface="Arial" charset="0"/>
@@ -3742,7 +4126,7 @@
                   </a:tcPr>
                 </a:tc>
               </a:tr>
-              <a:tr h="219456">
+              <a:tr h="274320">
                 <a:tc>
                   <a:txBody>
                     <a:bodyPr/>
@@ -3752,7 +4136,7 @@
                         <a:buNone/>
                       </a:pPr>
                       <a:r>
-                        <a:rPr lang="en-US" sz="950" dirty="0">
+                        <a:rPr lang="en-US" sz="1000" dirty="0">
                           <a:solidFill>
                             <a:srgbClr val="1F2933"/>
                           </a:solidFill>
@@ -3762,7 +4146,7 @@
                         </a:rPr>
                         <a:t>Repeat · OpenVLA LIBERO Long</a:t>
                       </a:r>
-                      <a:endParaRPr lang="en-US" sz="950" dirty="0">
+                      <a:endParaRPr lang="en-US" sz="1000" dirty="0">
                         <a:latin typeface="Arial" charset="0"/>
                         <a:ea typeface="Arial" charset="0"/>
                         <a:cs typeface="Arial" charset="0"/>
@@ -3817,7 +4201,7 @@
                         <a:buNone/>
                       </a:pPr>
                       <a:r>
-                        <a:rPr lang="en-US" sz="950" b="1" dirty="0">
+                        <a:rPr lang="en-US" sz="1000" b="1" dirty="0">
                           <a:solidFill>
                             <a:srgbClr val="C8641E"/>
                           </a:solidFill>
@@ -3827,7 +4211,7 @@
                         </a:rPr>
                         <a:t>171.6 → 93.2</a:t>
                       </a:r>
-                      <a:endParaRPr lang="en-US" sz="950" dirty="0">
+                      <a:endParaRPr lang="en-US" sz="1000" dirty="0">
                         <a:latin typeface="Arial" charset="0"/>
                         <a:ea typeface="Arial" charset="0"/>
                         <a:cs typeface="Arial" charset="0"/>
@@ -3874,7 +4258,7 @@
                   </a:tcPr>
                 </a:tc>
               </a:tr>
-              <a:tr h="219456">
+              <a:tr h="274320">
                 <a:tc>
                   <a:txBody>
                     <a:bodyPr/>
@@ -3884,7 +4268,7 @@
                         <a:buNone/>
                       </a:pPr>
                       <a:r>
-                        <a:rPr lang="en-US" sz="950" dirty="0">
+                        <a:rPr lang="en-US" sz="1000" dirty="0">
                           <a:solidFill>
                             <a:srgbClr val="1F2933"/>
                           </a:solidFill>
@@ -3894,7 +4278,7 @@
                         </a:rPr>
                         <a:t>Pruning · OpenVLA WidowX</a:t>
                       </a:r>
-                      <a:endParaRPr lang="en-US" sz="950" dirty="0">
+                      <a:endParaRPr lang="en-US" sz="1000" dirty="0">
                         <a:latin typeface="Arial" charset="0"/>
                         <a:ea typeface="Arial" charset="0"/>
                         <a:cs typeface="Arial" charset="0"/>
@@ -3949,7 +4333,7 @@
                         <a:buNone/>
                       </a:pPr>
                       <a:r>
-                        <a:rPr lang="en-US" sz="950" b="1" dirty="0">
+                        <a:rPr lang="en-US" sz="1000" b="1" dirty="0">
                           <a:solidFill>
                             <a:srgbClr val="1B7F79"/>
                           </a:solidFill>
@@ -3959,7 +4343,7 @@
                         </a:rPr>
                         <a:t>210.2 → 199.4</a:t>
                       </a:r>
-                      <a:endParaRPr lang="en-US" sz="950" dirty="0">
+                      <a:endParaRPr lang="en-US" sz="1000" dirty="0">
                         <a:latin typeface="Arial" charset="0"/>
                         <a:ea typeface="Arial" charset="0"/>
                         <a:cs typeface="Arial" charset="0"/>
@@ -4006,7 +4390,7 @@
                   </a:tcPr>
                 </a:tc>
               </a:tr>
-              <a:tr h="219456">
+              <a:tr h="274320">
                 <a:tc>
                   <a:txBody>
                     <a:bodyPr/>
@@ -4016,7 +4400,7 @@
                         <a:buNone/>
                       </a:pPr>
                       <a:r>
-                        <a:rPr lang="en-US" sz="950" dirty="0">
+                        <a:rPr lang="en-US" sz="1000" dirty="0">
                           <a:solidFill>
                             <a:srgbClr val="1F2933"/>
                           </a:solidFill>
@@ -4026,7 +4410,7 @@
                         </a:rPr>
                         <a:t>Reuse · SmolVLA LIBERO Long</a:t>
                       </a:r>
-                      <a:endParaRPr lang="en-US" sz="950" dirty="0">
+                      <a:endParaRPr lang="en-US" sz="1000" dirty="0">
                         <a:latin typeface="Arial" charset="0"/>
                         <a:ea typeface="Arial" charset="0"/>
                         <a:cs typeface="Arial" charset="0"/>
@@ -4081,7 +4465,7 @@
                         <a:buNone/>
                       </a:pPr>
                       <a:r>
-                        <a:rPr lang="en-US" sz="950" b="1" dirty="0">
+                        <a:rPr lang="en-US" sz="1000" b="1" dirty="0">
                           <a:solidFill>
                             <a:srgbClr val="1B7F79"/>
                           </a:solidFill>
@@ -4091,7 +4475,7 @@
                         </a:rPr>
                         <a:t>289.5 → 268.9</a:t>
                       </a:r>
-                      <a:endParaRPr lang="en-US" sz="950" dirty="0">
+                      <a:endParaRPr lang="en-US" sz="1000" dirty="0">
                         <a:latin typeface="Arial" charset="0"/>
                         <a:ea typeface="Arial" charset="0"/>
                         <a:cs typeface="Arial" charset="0"/>
@@ -4207,7 +4591,7 @@
                 <a:ea typeface="Arial" pitchFamily="34" charset="-122"/>
                 <a:cs typeface="Arial" pitchFamily="34" charset="-120"/>
               </a:rPr>
-              <a:t>Open loop has a cost, gating keeps it safe</a:t>
+              <a:t>Open loop has a cost, gating keeps it safer</a:t>
             </a:r>
             <a:endParaRPr lang="en-US" sz="2600" dirty="0"/>
           </a:p>
@@ -4517,7 +4901,7 @@
                 <a:ea typeface="Arial" pitchFamily="34" charset="-122"/>
                 <a:cs typeface="Arial" pitchFamily="34" charset="-120"/>
               </a:rPr>
-              <a:t>CLIP: Action repeat k = 4</a:t>
+              <a:t>CLIP: Action repeat</a:t>
             </a:r>
             <a:endParaRPr lang="en-US" sz="1200" dirty="0"/>
           </a:p>
@@ -4847,7 +5231,7 @@
               <a:buNone/>
             </a:pPr>
             <a:r>
-              <a:rPr lang="en-US" sz="1100" b="1" dirty="0">
+              <a:rPr lang="en-US" sz="1050" b="1" dirty="0">
                 <a:solidFill>
                   <a:srgbClr val="B03A2E"/>
                 </a:solidFill>
@@ -4855,9 +5239,9 @@
                 <a:ea typeface="Arial" pitchFamily="34" charset="-122"/>
                 <a:cs typeface="Arial" pitchFamily="34" charset="-120"/>
               </a:rPr>
-              <a:t>Action repeat, WidowX: CogACT −38.0 · UniVLA −75.0</a:t>
-            </a:r>
-            <a:endParaRPr lang="en-US" sz="1100" dirty="0"/>
+              <a:t>Action repeat (k = 2, best setting), WidowX: CogACT −38.0 · UniVLA −75.0</a:t>
+            </a:r>
+            <a:endParaRPr lang="en-US" sz="1050" dirty="0"/>
           </a:p>
         </p:txBody>
       </p:sp>
@@ -5529,7 +5913,7 @@
                 <a:ea typeface="Arial" pitchFamily="34" charset="-122"/>
                 <a:cs typeface="Arial" pitchFamily="34" charset="-120"/>
               </a:rPr>
-              <a:t>Action repeat: harmful on WidowX, milder on Fractal for some backbones</a:t>
+              <a:t>Action repeat: often harmful on WidowX, milder on Fractal for some backbones</a:t>
             </a:r>
             <a:endParaRPr lang="en-US" sz="1050" dirty="0"/>
           </a:p>
@@ -6796,7 +7180,7 @@
                 <a:ea typeface="Arial" pitchFamily="34" charset="-122"/>
                 <a:cs typeface="Arial" pitchFamily="34" charset="-120"/>
               </a:rPr>
-              <a:t>Hold each predicted action for k = 2 or 4 steps, one call per k steps</a:t>
+              <a:t>Hold each predicted action for k = 2 or 4 steps, about one call per k steps</a:t>
             </a:r>
             <a:endParaRPr lang="en-US" sz="1150" dirty="0"/>
           </a:p>
@@ -6954,7 +7338,7 @@
                 <a:ea typeface="Arial" pitchFamily="34" charset="-122"/>
                 <a:cs typeface="Arial" pitchFamily="34" charset="-120"/>
               </a:rPr>
-              <a:t>CLIP: original vs action repeat k = 4</a:t>
+              <a:t>CLIP: original vs action repeat</a:t>
             </a:r>
             <a:endParaRPr lang="en-US" sz="1200" dirty="0"/>
           </a:p>
@@ -7257,7 +7641,7 @@
                 <a:ea typeface="Arial" pitchFamily="34" charset="-122"/>
                 <a:cs typeface="Arial" pitchFamily="34" charset="-120"/>
               </a:rPr>
-              <a:t>Remove the 1, 2, or 4 lowest; none adjacent, first and last kept</a:t>
+              <a:t>Remove 1, 2, or 4 low-influence blocks; none adjacent, early blocks and the final block kept</a:t>
             </a:r>
             <a:endParaRPr lang="en-US" sz="1100" dirty="0"/>
           </a:p>
@@ -8116,7 +8500,7 @@
                 <a:ea typeface="Arial" pitchFamily="34" charset="-122"/>
                 <a:cs typeface="Arial" pitchFamily="34" charset="-120"/>
               </a:rPr>
-              <a:t>Recompute patches with motion, entropy, or language attention</a:t>
+              <a:t>Recompute patches with motion, local structure, language attention, or in the interaction region</a:t>
             </a:r>
             <a:endParaRPr lang="en-US" sz="1100" dirty="0"/>
           </a:p>
@@ -10874,7 +11258,7 @@
                 <a:ea typeface="Arial" pitchFamily="34" charset="-122"/>
                 <a:cs typeface="Arial" pitchFamily="34" charset="-120"/>
               </a:rPr>
-              <a:t>trick settings, all paired with the original</a:t>
+              <a:t>trick settings (13 × 22), all paired with the original</a:t>
             </a:r>
             <a:endParaRPr lang="en-US" sz="1050" dirty="0"/>
           </a:p>
@@ -11966,7 +12350,7 @@
                 <a:ea typeface="Arial" pitchFamily="34" charset="-122"/>
                 <a:cs typeface="Arial" pitchFamily="34" charset="-120"/>
               </a:rPr>
-              <a:t>Fig. 1: success per configuration, six WidowX backbones (14 bars each, darker to lighter within a trick). Dotted line = original policy. Deltas from Tables I and II, best setting per trick.</a:t>
+              <a:t>Fig. 1: success per configuration, six WidowX backbones (14 bars each, darker to lighter within a trick). Dotted line = original policy, 0 = no successful episodes. Deltas from Tables I and II, best setting per trick.</a:t>
             </a:r>
             <a:endParaRPr lang="en-US" sz="950" dirty="0"/>
           </a:p>

</xml_diff>

<commit_message>
Video deck: add a subtitle-band variant (narration as on-slide captions)
Co-Authored-By: Claude Fable 5.1 <noreply@anthropic.com>
Claude-Session: https://claude.ai/code/session_011USoCwMtkSq1wKhwTPjNT9
</commit_message>
<xml_diff>
--- a/experiments/paper/video/ICRA27_video_v2.pptx
+++ b/experiments/paper/video/ICRA27_video_v2.pptx
@@ -5452,7 +5452,7 @@
         <p:spPr>
           <a:xfrm>
             <a:off x="457200" y="4434840"/>
-            <a:ext cx="8229600" cy="274320"/>
+            <a:ext cx="8229600" cy="237744"/>
           </a:xfrm>
           <a:prstGeom prst="rect">
             <a:avLst/>
@@ -8543,7 +8543,7 @@
         </p:blipFill>
         <p:spPr>
           <a:xfrm>
-            <a:off x="457200" y="2971800"/>
+            <a:off x="457200" y="2944368"/>
             <a:ext cx="2331720" cy="1426464"/>
           </a:xfrm>
           <a:prstGeom prst="rect">
@@ -8560,7 +8560,7 @@
         <p:spPr>
           <a:xfrm>
             <a:off x="457200" y="4480560"/>
-            <a:ext cx="2377440" cy="274320"/>
+            <a:ext cx="2560320" cy="320040"/>
           </a:xfrm>
           <a:prstGeom prst="rect">
             <a:avLst/>

</xml_diff>